<commit_message>
Ajoute une diapositive masquée sur les coûts et un e-mail récapitulatif pour la direction
Co-Authored-By: Claude Opus 5.5 <noreply@anthropic.com>
Claude-Session: https://claude.ai/code/session_01FnPw3XyzToySauDhZCD5jn
</commit_message>
<xml_diff>
--- a/formations/dti/presentation-division-terrestre-internationale.pptx
+++ b/formations/dti/presentation-division-terrestre-internationale.pptx
@@ -22,9 +22,10 @@
     <p:sldId id="270" r:id="rId16"/>
     <p:sldId id="271" r:id="rId17"/>
     <p:sldId id="272" r:id="rId18"/>
+    <p:sldId id="273" r:id="rId19"/>
   </p:sldIdLst>
   <p:notesMasterIdLst>
-    <p:notesMasterId r:id="rId19"/>
+    <p:notesMasterId r:id="rId20"/>
   </p:notesMasterIdLst>
   <p:sldSz cx="12192000" cy="6858000"/>
   <p:notesSz cx="6858000" cy="12192000"/>
@@ -123,53 +124,58 @@
   <p:extLst>
     <p:ext uri="{521415D9-36F7-43E2-AB2F-B90AF26B5E84}">
       <p14:sectionLst xmlns:p14="http://schemas.microsoft.com/office/powerpoint/2010/main">
-        <p14:section name="Introduction" id="{34ee3858-8c71-dc30-9b48-7377546e9ea8}">
+        <p14:section name="Introduction" id="{17f7d216-2a48-6b6f-fc65-55bd75ec3f6e}">
           <p14:sldIdLst>
             <p14:sldId id="256"/>
             <p14:sldId id="257"/>
             <p14:sldId id="258"/>
           </p14:sldIdLst>
         </p14:section>
-        <p14:section name="Pilotage" id="{5c1a77e1-6e6c-3561-9591-9d9ae637fe5c}">
+        <p14:section name="Pilotage" id="{5d5bbacf-2fa5-e3be-ca33-79c7c16f4837}">
           <p14:sldIdLst>
             <p14:sldId id="259"/>
           </p14:sldIdLst>
         </p14:section>
-        <p14:section name="Flotte" id="{58cf4f4a-b78c-e7c4-9490-b0e8a55d2396}">
+        <p14:section name="Flotte" id="{56115653-f612-1e5d-16c1-b8c55089a858}">
           <p14:sldIdLst>
             <p14:sldId id="260"/>
             <p14:sldId id="261"/>
             <p14:sldId id="262"/>
           </p14:sldIdLst>
         </p14:section>
-        <p14:section name="Activité commerciale" id="{53ca4ffe-45cf-cfdc-97b5-0507450c2fa4}">
+        <p14:section name="Activité commerciale" id="{bf5aa824-1951-f25e-5931-4b029f7e493b}">
           <p14:sldIdLst>
             <p14:sldId id="263"/>
           </p14:sldIdLst>
         </p14:section>
-        <p14:section name="Exploitation" id="{9bca1cd0-c696-6bab-3e9e-7236e377b91f}">
+        <p14:section name="Exploitation" id="{4fb43cca-222b-ddea-6361-be1ba8450460}">
           <p14:sldIdLst>
             <p14:sldId id="264"/>
             <p14:sldId id="265"/>
           </p14:sldIdLst>
         </p14:section>
-        <p14:section name="Finances et pilotage" id="{67e8e4b3-b543-ae6d-315c-276876b50e35}">
+        <p14:section name="Finances et pilotage" id="{bec73b29-20e5-61bf-57d2-95204b54e994}">
           <p14:sldIdLst>
             <p14:sldId id="266"/>
             <p14:sldId id="267"/>
           </p14:sldIdLst>
         </p14:section>
-        <p14:section name="Administration" id="{004d8783-d636-8d64-db23-0768be2d52ba}">
+        <p14:section name="Administration" id="{04d31f6f-195b-f9f1-85d9-a610cc40c5f7}">
           <p14:sldIdLst>
             <p14:sldId id="268"/>
             <p14:sldId id="269"/>
           </p14:sldIdLst>
         </p14:section>
-        <p14:section name="Conclusion" id="{bdca5fe4-7b21-4475-a760-f842e410d0ac}">
+        <p14:section name="Conclusion" id="{6ee108fe-4518-bdec-14ad-ef62d6d91cdd}">
           <p14:sldIdLst>
             <p14:sldId id="270"/>
             <p14:sldId id="271"/>
             <p14:sldId id="272"/>
+          </p14:sldIdLst>
+        </p14:section>
+        <p14:section name="Réserve" id="{a9bac32a-e506-f338-4662-37ff6c232f7a}">
+          <p14:sldIdLst>
+            <p14:sldId id="273"/>
           </p14:sldIdLst>
         </p14:section>
       </p14:sectionLst>
@@ -1304,6 +1310,94 @@
             <a:fld id="{F7021451-1387-4CA6-816F-3879F97B5CBC}" type="slidenum">
               <a:rPr lang="en-US"/>
               <a:t>17</a:t>
+            </a:fld>
+            <a:endParaRPr lang="en-US"/>
+          </a:p>
+        </p:txBody>
+      </p:sp>
+    </p:spTree>
+    <p:extLst>
+      <p:ext uri="{BB962C8B-B14F-4D97-AF65-F5344CB8AC3E}">
+        <p14:creationId xmlns:p14="http://schemas.microsoft.com/office/powerpoint/2010/main" val="1024086991"/>
+      </p:ext>
+    </p:extLst>
+  </p:cSld>
+  <p:clrMapOvr>
+    <a:masterClrMapping/>
+  </p:clrMapOvr>
+</p:notes>
+</file>
+
+<file path=ppt/notesSlides/notesSlide18.xml><?xml version="1.0" encoding="utf-8"?>
+<p:notes xmlns:a="http://schemas.openxmlformats.org/drawingml/2006/main" xmlns:r="http://schemas.openxmlformats.org/officeDocument/2006/relationships" xmlns:p="http://schemas.openxmlformats.org/presentationml/2006/main">
+  <p:cSld>
+    <p:spTree>
+      <p:nvGrpSpPr>
+        <p:cNvPr id="1" name=""/>
+        <p:cNvGrpSpPr/>
+        <p:nvPr/>
+      </p:nvGrpSpPr>
+      <p:grpSpPr>
+        <a:xfrm>
+          <a:off x="0" y="0"/>
+          <a:ext cx="0" cy="0"/>
+          <a:chOff x="0" y="0"/>
+          <a:chExt cx="0" cy="0"/>
+        </a:xfrm>
+      </p:grpSpPr>
+      <p:sp>
+        <p:nvSpPr>
+          <p:cNvPr id="2" name="Slide Image Placeholder 1"/>
+          <p:cNvSpPr>
+            <a:spLocks noGrp="1" noRot="1" noChangeAspect="1"/>
+          </p:cNvSpPr>
+          <p:nvPr>
+            <p:ph type="sldImg"/>
+          </p:nvPr>
+        </p:nvSpPr>
+        <p:spPr/>
+      </p:sp>
+      <p:sp>
+        <p:nvSpPr>
+          <p:cNvPr id="3" name="Notes Placeholder 2"/>
+          <p:cNvSpPr>
+            <a:spLocks noGrp="1"/>
+          </p:cNvSpPr>
+          <p:nvPr>
+            <p:ph type="body" idx="1"/>
+          </p:nvPr>
+        </p:nvSpPr>
+        <p:spPr/>
+        <p:txBody>
+          <a:bodyPr/>
+          <a:lstStyle/>
+          <a:p>
+            <a:r>
+              <a:rPr lang="en-US" dirty="0"/>
+              <a:t>DIAPOSITIVE MASQUÉE : elle ne s'affiche pas pendant le diaporama. À montrer uniquement si la direction pose la question (clic droit &gt; Afficher la diapositive, ou la sélectionner depuis le mode présentateur). Ne présenter que ces montants, sans autres frais.</a:t>
+            </a:r>
+            <a:endParaRPr lang="en-US" dirty="0"/>
+          </a:p>
+        </p:txBody>
+      </p:sp>
+      <p:sp>
+        <p:nvSpPr>
+          <p:cNvPr id="4" name="Slide Number Placeholder 3"/>
+          <p:cNvSpPr>
+            <a:spLocks noGrp="1"/>
+          </p:cNvSpPr>
+          <p:nvPr>
+            <p:ph type="sldNum" sz="quarter" idx="10"/>
+          </p:nvPr>
+        </p:nvSpPr>
+        <p:spPr/>
+        <p:txBody>
+          <a:bodyPr/>
+          <a:lstStyle/>
+          <a:p>
+            <a:fld id="{F7021451-1387-4CA6-816F-3879F97B5CBC}" type="slidenum">
+              <a:rPr lang="en-US"/>
+              <a:t>18</a:t>
             </a:fld>
             <a:endParaRPr lang="en-US"/>
           </a:p>
@@ -8331,6 +8425,573 @@
               <a:t>Merci de votre attention</a:t>
             </a:r>
             <a:endParaRPr lang="en-US" sz="2000" dirty="0"/>
+          </a:p>
+        </p:txBody>
+      </p:sp>
+    </p:spTree>
+  </p:cSld>
+  <p:clrMapOvr>
+    <a:masterClrMapping/>
+  </p:clrMapOvr>
+</p:sld>
+</file>
+
+<file path=ppt/slides/slide18.xml><?xml version="1.0" encoding="utf-8"?>
+<p:sld xmlns:a="http://schemas.openxmlformats.org/drawingml/2006/main" xmlns:r="http://schemas.openxmlformats.org/officeDocument/2006/relationships" xmlns:p="http://schemas.openxmlformats.org/presentationml/2006/main" show="0">
+  <p:cSld name="Slide 18">
+    <p:spTree>
+      <p:nvGrpSpPr>
+        <p:cNvPr id="1" name=""/>
+        <p:cNvGrpSpPr/>
+        <p:nvPr/>
+      </p:nvGrpSpPr>
+      <p:grpSpPr>
+        <a:xfrm>
+          <a:off x="0" y="0"/>
+          <a:ext cx="0" cy="0"/>
+          <a:chOff x="0" y="0"/>
+          <a:chExt cx="0" cy="0"/>
+        </a:xfrm>
+      </p:grpSpPr>
+      <p:sp>
+        <p:nvSpPr>
+          <p:cNvPr id="2" name="Text 1"/>
+          <p:cNvSpPr/>
+          <p:nvPr>
+            <p:ph idx="101" type="title" hasCustomPrompt="1"/>
+          </p:nvPr>
+        </p:nvSpPr>
+        <p:spPr>
+          <a:xfrm>
+            <a:off x="548640" y="320040"/>
+            <a:ext cx="11064240" cy="822960"/>
+          </a:xfrm>
+          <a:prstGeom prst="rect">
+            <a:avLst/>
+          </a:prstGeom>
+          <a:noFill/>
+          <a:ln/>
+        </p:spPr>
+        <p:txBody>
+          <a:bodyPr wrap="square" rtlCol="0" anchor="ctr"/>
+          <a:lstStyle/>
+          <a:p>
+            <a:pPr indent="0" marL="0">
+              <a:buNone/>
+            </a:pPr>
+            <a:r>
+              <a:rPr lang="en-US" sz="3000" b="1" dirty="0">
+                <a:solidFill>
+                  <a:schemeClr val="tx2"/>
+                </a:solidFill>
+              </a:rPr>
+              <a:t>Coûts de fonctionnement</a:t>
+            </a:r>
+            <a:endParaRPr lang="en-US" sz="3000" dirty="0"/>
+          </a:p>
+        </p:txBody>
+      </p:sp>
+      <p:sp>
+        <p:nvSpPr>
+          <p:cNvPr id="3" name="Shape 1"/>
+          <p:cNvSpPr/>
+          <p:nvPr/>
+        </p:nvSpPr>
+        <p:spPr>
+          <a:xfrm>
+            <a:off x="548640" y="1371600"/>
+            <a:ext cx="5120640" cy="2103120"/>
+          </a:xfrm>
+          <a:prstGeom prst="roundRect">
+            <a:avLst>
+              <a:gd name="adj" fmla="val 3478"/>
+            </a:avLst>
+          </a:prstGeom>
+          <a:solidFill>
+            <a:schemeClr val="bg2"/>
+          </a:solidFill>
+          <a:ln w="12700">
+            <a:solidFill>
+              <a:schemeClr val="bg2"/>
+            </a:solidFill>
+            <a:prstDash val="solid"/>
+          </a:ln>
+        </p:spPr>
+      </p:sp>
+      <p:sp>
+        <p:nvSpPr>
+          <p:cNvPr id="4" name="Text 2"/>
+          <p:cNvSpPr txBox="1"/>
+          <p:nvPr/>
+        </p:nvSpPr>
+        <p:spPr>
+          <a:xfrm>
+            <a:off x="731520" y="1481328"/>
+            <a:ext cx="4754880" cy="1883664"/>
+          </a:xfrm>
+          <a:prstGeom prst="rect">
+            <a:avLst/>
+          </a:prstGeom>
+          <a:noFill/>
+          <a:ln/>
+        </p:spPr>
+        <p:txBody>
+          <a:bodyPr wrap="square" rtlCol="0" anchor="t"/>
+          <a:lstStyle/>
+          <a:p>
+            <a:pPr indent="0" marL="0">
+              <a:spcAft>
+                <a:spcPts val="400"/>
+              </a:spcAft>
+              <a:buNone/>
+            </a:pPr>
+            <a:r>
+              <a:rPr lang="en-US" sz="1600" b="1" dirty="0">
+                <a:solidFill>
+                  <a:schemeClr val="tx2"/>
+                </a:solidFill>
+              </a:rPr>
+              <a:t>Hébergement du serveur</a:t>
+            </a:r>
+            <a:endParaRPr lang="en-US" sz="1500" dirty="0"/>
+          </a:p>
+          <a:p>
+            <a:pPr indent="0" marL="0">
+              <a:buNone/>
+            </a:pPr>
+            <a:endParaRPr lang="en-US" sz="1500" dirty="0"/>
+          </a:p>
+        </p:txBody>
+      </p:sp>
+      <p:sp>
+        <p:nvSpPr>
+          <p:cNvPr id="5" name="Text 3"/>
+          <p:cNvSpPr txBox="1"/>
+          <p:nvPr/>
+        </p:nvSpPr>
+        <p:spPr>
+          <a:xfrm>
+            <a:off x="731520" y="2057400"/>
+            <a:ext cx="4754880" cy="1280160"/>
+          </a:xfrm>
+          <a:prstGeom prst="rect">
+            <a:avLst/>
+          </a:prstGeom>
+          <a:noFill/>
+          <a:ln/>
+        </p:spPr>
+        <p:txBody>
+          <a:bodyPr wrap="square" rtlCol="0" anchor="t"/>
+          <a:lstStyle/>
+          <a:p>
+            <a:pPr indent="0" marL="0">
+              <a:buNone/>
+            </a:pPr>
+            <a:r>
+              <a:rPr lang="en-US" sz="3200" b="1" dirty="0">
+                <a:solidFill>
+                  <a:schemeClr val="accent1"/>
+                </a:solidFill>
+              </a:rPr>
+              <a:t>100 000 FCFA</a:t>
+            </a:r>
+            <a:endParaRPr lang="en-US" sz="1500" dirty="0"/>
+          </a:p>
+          <a:p>
+            <a:pPr indent="0" marL="0">
+              <a:buNone/>
+            </a:pPr>
+            <a:r>
+              <a:rPr lang="en-US" sz="1600" dirty="0">
+                <a:solidFill>
+                  <a:schemeClr val="tx1"/>
+                </a:solidFill>
+              </a:rPr>
+              <a:t>par an</a:t>
+            </a:r>
+            <a:endParaRPr lang="en-US" sz="1500" dirty="0"/>
+          </a:p>
+        </p:txBody>
+      </p:sp>
+      <p:sp>
+        <p:nvSpPr>
+          <p:cNvPr id="6" name="Shape 4"/>
+          <p:cNvSpPr/>
+          <p:nvPr/>
+        </p:nvSpPr>
+        <p:spPr>
+          <a:xfrm>
+            <a:off x="548640" y="3749040"/>
+            <a:ext cx="5120640" cy="2103120"/>
+          </a:xfrm>
+          <a:prstGeom prst="roundRect">
+            <a:avLst>
+              <a:gd name="adj" fmla="val 3478"/>
+            </a:avLst>
+          </a:prstGeom>
+          <a:solidFill>
+            <a:schemeClr val="bg2"/>
+          </a:solidFill>
+          <a:ln w="12700">
+            <a:solidFill>
+              <a:schemeClr val="bg2"/>
+            </a:solidFill>
+            <a:prstDash val="solid"/>
+          </a:ln>
+        </p:spPr>
+      </p:sp>
+      <p:sp>
+        <p:nvSpPr>
+          <p:cNvPr id="7" name="Text 5"/>
+          <p:cNvSpPr txBox="1"/>
+          <p:nvPr/>
+        </p:nvSpPr>
+        <p:spPr>
+          <a:xfrm>
+            <a:off x="731520" y="3858768"/>
+            <a:ext cx="4754880" cy="1883664"/>
+          </a:xfrm>
+          <a:prstGeom prst="rect">
+            <a:avLst/>
+          </a:prstGeom>
+          <a:noFill/>
+          <a:ln/>
+        </p:spPr>
+        <p:txBody>
+          <a:bodyPr wrap="square" rtlCol="0" anchor="t"/>
+          <a:lstStyle/>
+          <a:p>
+            <a:pPr indent="0" marL="0">
+              <a:spcAft>
+                <a:spcPts val="400"/>
+              </a:spcAft>
+              <a:buNone/>
+            </a:pPr>
+            <a:r>
+              <a:rPr lang="en-US" sz="1600" b="1" dirty="0">
+                <a:solidFill>
+                  <a:schemeClr val="tx2"/>
+                </a:solidFill>
+              </a:rPr>
+              <a:t>Maintenance</a:t>
+            </a:r>
+            <a:endParaRPr lang="en-US" sz="1500" dirty="0"/>
+          </a:p>
+          <a:p>
+            <a:pPr indent="0" marL="0">
+              <a:buNone/>
+            </a:pPr>
+            <a:endParaRPr lang="en-US" sz="1500" dirty="0"/>
+          </a:p>
+        </p:txBody>
+      </p:sp>
+      <p:sp>
+        <p:nvSpPr>
+          <p:cNvPr id="8" name="Text 6"/>
+          <p:cNvSpPr txBox="1"/>
+          <p:nvPr/>
+        </p:nvSpPr>
+        <p:spPr>
+          <a:xfrm>
+            <a:off x="731520" y="4434840"/>
+            <a:ext cx="4754880" cy="1280160"/>
+          </a:xfrm>
+          <a:prstGeom prst="rect">
+            <a:avLst/>
+          </a:prstGeom>
+          <a:noFill/>
+          <a:ln/>
+        </p:spPr>
+        <p:txBody>
+          <a:bodyPr wrap="square" rtlCol="0" anchor="t"/>
+          <a:lstStyle/>
+          <a:p>
+            <a:pPr indent="0" marL="0">
+              <a:buNone/>
+            </a:pPr>
+            <a:r>
+              <a:rPr lang="en-US" sz="3200" b="1" dirty="0">
+                <a:solidFill>
+                  <a:schemeClr val="accent1"/>
+                </a:solidFill>
+              </a:rPr>
+              <a:t>100 000 FCFA</a:t>
+            </a:r>
+            <a:endParaRPr lang="en-US" sz="1500" dirty="0"/>
+          </a:p>
+          <a:p>
+            <a:pPr indent="0" marL="0">
+              <a:buNone/>
+            </a:pPr>
+            <a:r>
+              <a:rPr lang="en-US" sz="1600" dirty="0">
+                <a:solidFill>
+                  <a:schemeClr val="tx1"/>
+                </a:solidFill>
+              </a:rPr>
+              <a:t>par mois, formation des agents comprise</a:t>
+            </a:r>
+            <a:endParaRPr lang="en-US" sz="1500" dirty="0"/>
+          </a:p>
+        </p:txBody>
+      </p:sp>
+      <p:sp>
+        <p:nvSpPr>
+          <p:cNvPr id="9" name="Text 7"/>
+          <p:cNvSpPr txBox="1"/>
+          <p:nvPr/>
+        </p:nvSpPr>
+        <p:spPr>
+          <a:xfrm>
+            <a:off x="6126480" y="1371600"/>
+            <a:ext cx="5486400" cy="411480"/>
+          </a:xfrm>
+          <a:prstGeom prst="rect">
+            <a:avLst/>
+          </a:prstGeom>
+          <a:noFill/>
+          <a:ln/>
+        </p:spPr>
+        <p:txBody>
+          <a:bodyPr wrap="square" rtlCol="0" anchor="t"/>
+          <a:lstStyle/>
+          <a:p>
+            <a:pPr indent="0" marL="0">
+              <a:buNone/>
+            </a:pPr>
+            <a:r>
+              <a:rPr lang="en-US" sz="1700" b="1" dirty="0">
+                <a:solidFill>
+                  <a:schemeClr val="tx2"/>
+                </a:solidFill>
+              </a:rPr>
+              <a:t>Calendrier de paiement de la maintenance</a:t>
+            </a:r>
+            <a:endParaRPr lang="en-US" sz="1700" dirty="0"/>
+          </a:p>
+        </p:txBody>
+      </p:sp>
+      <p:sp>
+        <p:nvSpPr>
+          <p:cNvPr id="10" name="Shape 8"/>
+          <p:cNvSpPr/>
+          <p:nvPr/>
+        </p:nvSpPr>
+        <p:spPr>
+          <a:xfrm>
+            <a:off x="6126480" y="1965960"/>
+            <a:ext cx="5532120" cy="1737360"/>
+          </a:xfrm>
+          <a:prstGeom prst="roundRect">
+            <a:avLst>
+              <a:gd name="adj" fmla="val 4211"/>
+            </a:avLst>
+          </a:prstGeom>
+          <a:solidFill>
+            <a:schemeClr val="tx2"/>
+          </a:solidFill>
+          <a:ln w="12700">
+            <a:solidFill>
+              <a:schemeClr val="tx2"/>
+            </a:solidFill>
+            <a:prstDash val="solid"/>
+          </a:ln>
+        </p:spPr>
+      </p:sp>
+      <p:sp>
+        <p:nvSpPr>
+          <p:cNvPr id="11" name="Text 9"/>
+          <p:cNvSpPr txBox="1"/>
+          <p:nvPr/>
+        </p:nvSpPr>
+        <p:spPr>
+          <a:xfrm>
+            <a:off x="6309360" y="2057400"/>
+            <a:ext cx="5212080" cy="1554480"/>
+          </a:xfrm>
+          <a:prstGeom prst="rect">
+            <a:avLst/>
+          </a:prstGeom>
+          <a:noFill/>
+          <a:ln/>
+        </p:spPr>
+        <p:txBody>
+          <a:bodyPr wrap="square" rtlCol="0" anchor="ctr"/>
+          <a:lstStyle/>
+          <a:p>
+            <a:pPr indent="0" marL="0">
+              <a:buNone/>
+            </a:pPr>
+            <a:r>
+              <a:rPr lang="en-US" sz="2000" b="1" dirty="0">
+                <a:solidFill>
+                  <a:schemeClr val="accent4"/>
+                </a:solidFill>
+              </a:rPr>
+              <a:t>Premier paiement : 300 000 FCFA</a:t>
+            </a:r>
+            <a:endParaRPr lang="en-US" sz="1500" dirty="0"/>
+          </a:p>
+          <a:p>
+            <a:pPr indent="0" marL="0">
+              <a:buNone/>
+            </a:pPr>
+            <a:r>
+              <a:rPr lang="en-US" sz="1500" dirty="0">
+                <a:solidFill>
+                  <a:schemeClr val="bg1"/>
+                </a:solidFill>
+              </a:rPr>
+              <a:t>1er mois de maintenance + 2 mois payés d'avance (mois 2 et 3)</a:t>
+            </a:r>
+            <a:endParaRPr lang="en-US" sz="1500" dirty="0"/>
+          </a:p>
+        </p:txBody>
+      </p:sp>
+      <p:sp>
+        <p:nvSpPr>
+          <p:cNvPr id="12" name="Shape 10"/>
+          <p:cNvSpPr/>
+          <p:nvPr/>
+        </p:nvSpPr>
+        <p:spPr>
+          <a:xfrm>
+            <a:off x="8686800" y="3794760"/>
+            <a:ext cx="411480" cy="411480"/>
+          </a:xfrm>
+          <a:prstGeom prst="downArrow">
+            <a:avLst/>
+          </a:prstGeom>
+          <a:solidFill>
+            <a:schemeClr val="accent5"/>
+          </a:solidFill>
+          <a:ln w="12700">
+            <a:solidFill>
+              <a:schemeClr val="accent5"/>
+            </a:solidFill>
+            <a:prstDash val="solid"/>
+          </a:ln>
+        </p:spPr>
+      </p:sp>
+      <p:sp>
+        <p:nvSpPr>
+          <p:cNvPr id="13" name="Shape 11"/>
+          <p:cNvSpPr/>
+          <p:nvPr/>
+        </p:nvSpPr>
+        <p:spPr>
+          <a:xfrm>
+            <a:off x="6126480" y="4297680"/>
+            <a:ext cx="5532120" cy="1554480"/>
+          </a:xfrm>
+          <a:prstGeom prst="roundRect">
+            <a:avLst>
+              <a:gd name="adj" fmla="val 4706"/>
+            </a:avLst>
+          </a:prstGeom>
+          <a:solidFill>
+            <a:schemeClr val="bg2"/>
+          </a:solidFill>
+          <a:ln w="12700">
+            <a:solidFill>
+              <a:schemeClr val="bg2"/>
+            </a:solidFill>
+            <a:prstDash val="solid"/>
+          </a:ln>
+        </p:spPr>
+      </p:sp>
+      <p:sp>
+        <p:nvSpPr>
+          <p:cNvPr id="14" name="Text 12"/>
+          <p:cNvSpPr txBox="1"/>
+          <p:nvPr/>
+        </p:nvSpPr>
+        <p:spPr>
+          <a:xfrm>
+            <a:off x="6309360" y="4389120"/>
+            <a:ext cx="5212080" cy="1371600"/>
+          </a:xfrm>
+          <a:prstGeom prst="rect">
+            <a:avLst/>
+          </a:prstGeom>
+          <a:noFill/>
+          <a:ln/>
+        </p:spPr>
+        <p:txBody>
+          <a:bodyPr wrap="square" rtlCol="0" anchor="ctr"/>
+          <a:lstStyle/>
+          <a:p>
+            <a:pPr indent="0" marL="0">
+              <a:buNone/>
+            </a:pPr>
+            <a:r>
+              <a:rPr lang="en-US" sz="2000" b="1" dirty="0">
+                <a:solidFill>
+                  <a:schemeClr val="tx2"/>
+                </a:solidFill>
+              </a:rPr>
+              <a:t>À partir du 4ᵉ mois : 100 000 FCFA</a:t>
+            </a:r>
+            <a:endParaRPr lang="en-US" sz="1500" dirty="0"/>
+          </a:p>
+          <a:p>
+            <a:pPr indent="0" marL="0">
+              <a:buNone/>
+            </a:pPr>
+            <a:r>
+              <a:rPr lang="en-US" sz="1500" dirty="0">
+                <a:solidFill>
+                  <a:schemeClr val="tx1"/>
+                </a:solidFill>
+              </a:rPr>
+              <a:t>réglés chaque mois</a:t>
+            </a:r>
+            <a:endParaRPr lang="en-US" sz="1500" dirty="0"/>
+          </a:p>
+        </p:txBody>
+      </p:sp>
+      <p:sp>
+        <p:nvSpPr>
+          <p:cNvPr id="25" name="Slide Number Placeholder 0"/>
+          <p:cNvSpPr>
+            <a:spLocks noGrp="1"/>
+          </p:cNvSpPr>
+          <p:nvPr>
+            <p:ph type="sldNum" sz="quarter" idx="4294967295"/>
+          </p:nvPr>
+        </p:nvSpPr>
+        <p:spPr>
+          <a:xfrm>
+            <a:off x="11247120" y="6400800"/>
+            <a:ext cx="548640" cy="274320"/>
+          </a:xfrm>
+          <a:prstGeom prst="rect">
+            <a:avLst/>
+          </a:prstGeom>
+          <a:extLst>
+            <a:ext uri="{C572A759-6A51-4108-AA02-DFA0A04FC94B}">
+              <ma14:wrappingTextBoxFlag xmlns:ma14="http://schemas.microsoft.com/office/mac/drawingml/2011/main" val="0"/>
+            </a:ext>
+          </a:extLst>
+        </p:spPr>
+        <p:txBody>
+          <a:bodyPr/>
+          <a:lstStyle>
+            <a:lvl1pPr>
+              <a:defRPr sz="1000">
+                <a:solidFill>
+                  <a:schemeClr val="accent5"/>
+                </a:solidFill>
+              </a:defRPr>
+            </a:lvl1pPr>
+          </a:lstStyle>
+          <a:p>
+            <a:pPr algn="r"/>
+            <a:fld id="{F7021451-1387-4CA6-816F-3879F97B5CBC}" type="slidenum">
+              <a:rPr b="0" lang="en-US"/>
+              <a:t>18</a:t>
+            </a:fld>
+            <a:endParaRPr lang="en-US"/>
           </a:p>
         </p:txBody>
       </p:sp>

</xml_diff>

<commit_message>
Ajoute le présentateur et la date sur la page de titre
Co-Authored-By: Claude Opus 5.5 <noreply@anthropic.com>
Claude-Session: https://claude.ai/code/session_01FnPw3XyzToySauDhZCD5jn
</commit_message>
<xml_diff>
--- a/formations/dti/presentation-division-terrestre-internationale.pptx
+++ b/formations/dti/presentation-division-terrestre-internationale.pptx
@@ -126,7 +126,7 @@
   <p:extLst>
     <p:ext uri="{521415D9-36F7-43E2-AB2F-B90AF26B5E84}">
       <p14:sectionLst xmlns:p14="http://schemas.microsoft.com/office/powerpoint/2010/main">
-        <p14:section name="Introduction" id="{f00b8487-4176-66f4-5aec-0a7587cfc157}">
+        <p14:section name="Introduction" id="{1201aa38-1751-6044-538e-4ae649c4f65e}">
           <p14:sldIdLst>
             <p14:sldId id="256"/>
             <p14:sldId id="257"/>
@@ -134,42 +134,42 @@
             <p14:sldId id="259"/>
           </p14:sldIdLst>
         </p14:section>
-        <p14:section name="Pilotage" id="{5ddd3c9c-f36f-1bcb-7efc-baadb13f113f}">
+        <p14:section name="Pilotage" id="{a00fd506-29f9-5886-3de6-6fc160acddb9}">
           <p14:sldIdLst>
             <p14:sldId id="260"/>
           </p14:sldIdLst>
         </p14:section>
-        <p14:section name="Flotte" id="{a9d2946b-520c-491d-6cc0-2d4b57c98892}">
+        <p14:section name="Flotte" id="{b7ac636a-5fab-d73e-421d-b032f0a8fc2a}">
           <p14:sldIdLst>
             <p14:sldId id="261"/>
             <p14:sldId id="262"/>
             <p14:sldId id="263"/>
           </p14:sldIdLst>
         </p14:section>
-        <p14:section name="Activité commerciale" id="{70703e6b-b13e-cda7-3d03-bc6dc8c88cf1}">
+        <p14:section name="Activité commerciale" id="{4c788637-952e-76dc-7866-dddd387815c6}">
           <p14:sldIdLst>
             <p14:sldId id="264"/>
           </p14:sldIdLst>
         </p14:section>
-        <p14:section name="Exploitation" id="{be5bcd52-3bd7-50c7-fd37-ef275a444bca}">
+        <p14:section name="Exploitation" id="{e4f8fa35-a459-75d4-fc4b-45cc18c3340b}">
           <p14:sldIdLst>
             <p14:sldId id="265"/>
             <p14:sldId id="266"/>
           </p14:sldIdLst>
         </p14:section>
-        <p14:section name="Finances et pilotage" id="{dc233500-1708-cb92-5c87-21f5daf34026}">
+        <p14:section name="Finances et pilotage" id="{355272b9-0a35-041f-b47e-a79fa62cadf9}">
           <p14:sldIdLst>
             <p14:sldId id="267"/>
             <p14:sldId id="268"/>
           </p14:sldIdLst>
         </p14:section>
-        <p14:section name="Administration" id="{33ab960b-aabb-9f3c-1556-4093597cad55}">
+        <p14:section name="Administration" id="{02f1f016-95e0-93ee-d842-269b577831e7}">
           <p14:sldIdLst>
             <p14:sldId id="269"/>
             <p14:sldId id="270"/>
           </p14:sldIdLst>
         </p14:section>
-        <p14:section name="Conclusion" id="{e0288255-ecec-634c-9af5-968aae0c41e2}">
+        <p14:section name="Conclusion" id="{9f1cb40e-e4ad-7c12-0c8a-098e0f8dcf86}">
           <p14:sldIdLst>
             <p14:sldId id="271"/>
             <p14:sldId id="272"/>
@@ -177,7 +177,7 @@
             <p14:sldId id="274"/>
           </p14:sldIdLst>
         </p14:section>
-        <p14:section name="Réserve" id="{a5d33e2c-f84a-67f0-a3db-22cd5b5c4c13}">
+        <p14:section name="Réserve" id="{821c97f8-9abd-406f-6790-0b9ab7ad1e94}">
           <p14:sldIdLst>
             <p14:sldId id="275"/>
           </p14:sldIdLst>
@@ -3247,13 +3247,64 @@
       <p:sp>
         <p:nvSpPr>
           <p:cNvPr id="8" name="anim3-3"/>
+          <p:cNvSpPr/>
+          <p:nvPr/>
+        </p:nvSpPr>
+        <p:spPr>
+          <a:xfrm>
+            <a:off x="731520" y="4937760"/>
+            <a:ext cx="640080" cy="640080"/>
+          </a:xfrm>
+          <a:prstGeom prst="roundRect">
+            <a:avLst>
+              <a:gd name="adj" fmla="val 22000"/>
+            </a:avLst>
+          </a:prstGeom>
+          <a:solidFill>
+            <a:schemeClr val="accent1"/>
+          </a:solidFill>
+          <a:ln w="12700">
+            <a:solidFill>
+              <a:schemeClr val="accent1"/>
+            </a:solidFill>
+            <a:prstDash val="solid"/>
+          </a:ln>
+        </p:spPr>
+      </p:sp>
+      <p:pic>
+        <p:nvPicPr>
+          <p:cNvPr id="9" name="anim3-4" descr="preencoded.png">    </p:cNvPr>
+          <p:cNvPicPr>
+            <a:picLocks noChangeAspect="1"/>
+          </p:cNvPicPr>
+          <p:nvPr/>
+        </p:nvPicPr>
+        <p:blipFill>
+          <a:blip r:embed="rId2"/>
+          <a:stretch>
+            <a:fillRect/>
+          </a:stretch>
+        </p:blipFill>
+        <p:spPr>
+          <a:xfrm>
+            <a:off x="897941" y="5104181"/>
+            <a:ext cx="307238" cy="307238"/>
+          </a:xfrm>
+          <a:prstGeom prst="rect">
+            <a:avLst/>
+          </a:prstGeom>
+        </p:spPr>
+      </p:pic>
+      <p:sp>
+        <p:nvSpPr>
+          <p:cNvPr id="10" name="anim3-5"/>
           <p:cNvSpPr txBox="1"/>
           <p:nvPr/>
         </p:nvSpPr>
         <p:spPr>
           <a:xfrm>
-            <a:off x="731520" y="5120640"/>
-            <a:ext cx="5486400" cy="822960"/>
+            <a:off x="1554480" y="4846320"/>
+            <a:ext cx="4206240" cy="1005840"/>
           </a:xfrm>
           <a:prstGeom prst="rect">
             <a:avLst/>
@@ -3262,35 +3313,175 @@
           <a:ln/>
         </p:spPr>
         <p:txBody>
-          <a:bodyPr wrap="square" rtlCol="0" anchor="t"/>
+          <a:bodyPr wrap="square" lIns="0" tIns="0" rIns="0" bIns="0" rtlCol="0" anchor="ctr"/>
           <a:lstStyle/>
           <a:p>
             <a:pPr indent="0" marL="0">
               <a:buNone/>
             </a:pPr>
             <a:r>
-              <a:rPr lang="en-US" sz="1400" dirty="0">
+              <a:rPr lang="en-US" sz="1000" b="1" spc="200" kern="0" dirty="0">
                 <a:solidFill>
-                  <a:schemeClr val="bg1"/>
+                  <a:schemeClr val="accent2"/>
                 </a:solidFill>
               </a:rPr>
-              <a:t>Présentation : [à compléter]</a:t>
+              <a:t>PRÉSENTÉ PAR</a:t>
             </a:r>
-            <a:endParaRPr lang="en-US" sz="1400" dirty="0"/>
+            <a:endParaRPr lang="en-US" sz="1500" dirty="0"/>
           </a:p>
           <a:p>
             <a:pPr indent="0" marL="0">
               <a:buNone/>
             </a:pPr>
             <a:r>
-              <a:rPr lang="en-US" sz="1400" dirty="0">
+              <a:rPr lang="en-US" sz="1900" b="1" dirty="0">
                 <a:solidFill>
                   <a:schemeClr val="bg1"/>
                 </a:solidFill>
               </a:rPr>
-              <a:t>Date : [à compléter]</a:t>
+              <a:t>Armel Meledje</a:t>
             </a:r>
-            <a:endParaRPr lang="en-US" sz="1400" dirty="0"/>
+            <a:endParaRPr lang="en-US" sz="1500" dirty="0"/>
+          </a:p>
+          <a:p>
+            <a:pPr indent="0" marL="0">
+              <a:buNone/>
+            </a:pPr>
+            <a:r>
+              <a:rPr lang="en-US" sz="1300" dirty="0">
+                <a:solidFill>
+                  <a:schemeClr val="accent2"/>
+                </a:solidFill>
+              </a:rPr>
+              <a:t>Développeur Senior – Ingénieur de conception</a:t>
+            </a:r>
+            <a:endParaRPr lang="en-US" sz="1500" dirty="0"/>
+          </a:p>
+        </p:txBody>
+      </p:sp>
+      <p:sp>
+        <p:nvSpPr>
+          <p:cNvPr id="11" name="anim4-6"/>
+          <p:cNvSpPr/>
+          <p:nvPr/>
+        </p:nvSpPr>
+        <p:spPr>
+          <a:xfrm>
+            <a:off x="5623560" y="4937760"/>
+            <a:ext cx="0" cy="822960"/>
+          </a:xfrm>
+          <a:prstGeom prst="line">
+            <a:avLst/>
+          </a:prstGeom>
+          <a:noFill/>
+          <a:ln w="12700">
+            <a:solidFill>
+              <a:srgbClr val="A9BCEB">
+                <a:alpha val="50000"/>
+              </a:srgbClr>
+            </a:solidFill>
+            <a:prstDash val="solid"/>
+          </a:ln>
+        </p:spPr>
+      </p:sp>
+      <p:sp>
+        <p:nvSpPr>
+          <p:cNvPr id="12" name="anim4-7"/>
+          <p:cNvSpPr/>
+          <p:nvPr/>
+        </p:nvSpPr>
+        <p:spPr>
+          <a:xfrm>
+            <a:off x="5852160" y="4937760"/>
+            <a:ext cx="640080" cy="640080"/>
+          </a:xfrm>
+          <a:prstGeom prst="roundRect">
+            <a:avLst>
+              <a:gd name="adj" fmla="val 22000"/>
+            </a:avLst>
+          </a:prstGeom>
+          <a:solidFill>
+            <a:schemeClr val="accent1"/>
+          </a:solidFill>
+          <a:ln w="12700">
+            <a:solidFill>
+              <a:schemeClr val="accent1"/>
+            </a:solidFill>
+            <a:prstDash val="solid"/>
+          </a:ln>
+        </p:spPr>
+      </p:sp>
+      <p:pic>
+        <p:nvPicPr>
+          <p:cNvPr id="13" name="anim4-8" descr="preencoded.png">    </p:cNvPr>
+          <p:cNvPicPr>
+            <a:picLocks noChangeAspect="1"/>
+          </p:cNvPicPr>
+          <p:nvPr/>
+        </p:nvPicPr>
+        <p:blipFill>
+          <a:blip r:embed="rId3"/>
+          <a:stretch>
+            <a:fillRect/>
+          </a:stretch>
+        </p:blipFill>
+        <p:spPr>
+          <a:xfrm>
+            <a:off x="6018581" y="5104181"/>
+            <a:ext cx="307238" cy="307238"/>
+          </a:xfrm>
+          <a:prstGeom prst="rect">
+            <a:avLst/>
+          </a:prstGeom>
+        </p:spPr>
+      </p:pic>
+      <p:sp>
+        <p:nvSpPr>
+          <p:cNvPr id="14" name="anim4-9"/>
+          <p:cNvSpPr txBox="1"/>
+          <p:nvPr/>
+        </p:nvSpPr>
+        <p:spPr>
+          <a:xfrm>
+            <a:off x="6675120" y="4846320"/>
+            <a:ext cx="2743200" cy="1005840"/>
+          </a:xfrm>
+          <a:prstGeom prst="rect">
+            <a:avLst/>
+          </a:prstGeom>
+          <a:noFill/>
+          <a:ln/>
+        </p:spPr>
+        <p:txBody>
+          <a:bodyPr wrap="square" lIns="0" tIns="0" rIns="0" bIns="0" rtlCol="0" anchor="ctr"/>
+          <a:lstStyle/>
+          <a:p>
+            <a:pPr indent="0" marL="0">
+              <a:buNone/>
+            </a:pPr>
+            <a:r>
+              <a:rPr lang="en-US" sz="1000" b="1" spc="200" kern="0" dirty="0">
+                <a:solidFill>
+                  <a:schemeClr val="accent2"/>
+                </a:solidFill>
+              </a:rPr>
+              <a:t>DATE</a:t>
+            </a:r>
+            <a:endParaRPr lang="en-US" sz="1500" dirty="0"/>
+          </a:p>
+          <a:p>
+            <a:pPr indent="0" marL="0">
+              <a:buNone/>
+            </a:pPr>
+            <a:r>
+              <a:rPr lang="en-US" sz="1700" b="1" dirty="0">
+                <a:solidFill>
+                  <a:schemeClr val="bg1"/>
+                </a:solidFill>
+              </a:rPr>
+              <a:t>Vendredi 30 octobre 2026</a:t>
+            </a:r>
+            <a:endParaRPr lang="en-US" sz="1500" dirty="0"/>
           </a:p>
         </p:txBody>
       </p:sp>
@@ -3311,7 +3502,7 @@
               <p:cTn id="2" dur="indefinite" nodeType="mainSeq">
                 <p:childTnLst>
                   <p:par>
-                    <p:cTn id="12" fill="hold">
+                    <p:cTn id="30" fill="hold">
                       <p:stCondLst>
                         <p:cond delay="indefinite"/>
                         <p:cond evt="onBegin" delay="0">
@@ -3320,7 +3511,7 @@
                       </p:stCondLst>
                       <p:childTnLst>
                         <p:par>
-                          <p:cTn id="13" fill="hold">
+                          <p:cTn id="31" fill="hold">
                             <p:stCondLst>
                               <p:cond delay="0"/>
                             </p:stCondLst>
@@ -3424,6 +3615,216 @@
                                         <p:cTn id="11" dur="500"/>
                                         <p:tgtEl>
                                           <p:spTgt spid="8"/>
+                                        </p:tgtEl>
+                                      </p:cBhvr>
+                                    </p:animEffect>
+                                  </p:childTnLst>
+                                </p:cTn>
+                              </p:par>
+                              <p:par>
+                                <p:cTn id="12" presetID="10" presetClass="entr" presetSubtype="0" fill="hold" nodeType="withEffect">
+                                  <p:stCondLst>
+                                    <p:cond delay="500"/>
+                                  </p:stCondLst>
+                                  <p:childTnLst>
+                                    <p:set>
+                                      <p:cBhvr>
+                                        <p:cTn id="13" dur="1" fill="hold">
+                                          <p:stCondLst>
+                                            <p:cond delay="0"/>
+                                          </p:stCondLst>
+                                        </p:cTn>
+                                        <p:tgtEl>
+                                          <p:spTgt spid="9"/>
+                                        </p:tgtEl>
+                                        <p:attrNameLst>
+                                          <p:attrName>style.visibility</p:attrName>
+                                        </p:attrNameLst>
+                                      </p:cBhvr>
+                                      <p:to>
+                                        <p:strVal val="visible"/>
+                                      </p:to>
+                                    </p:set>
+                                    <p:animEffect transition="in" filter="fade">
+                                      <p:cBhvr>
+                                        <p:cTn id="14" dur="500"/>
+                                        <p:tgtEl>
+                                          <p:spTgt spid="9"/>
+                                        </p:tgtEl>
+                                      </p:cBhvr>
+                                    </p:animEffect>
+                                  </p:childTnLst>
+                                </p:cTn>
+                              </p:par>
+                              <p:par>
+                                <p:cTn id="15" presetID="10" presetClass="entr" presetSubtype="0" fill="hold" nodeType="withEffect">
+                                  <p:stCondLst>
+                                    <p:cond delay="500"/>
+                                  </p:stCondLst>
+                                  <p:childTnLst>
+                                    <p:set>
+                                      <p:cBhvr>
+                                        <p:cTn id="16" dur="1" fill="hold">
+                                          <p:stCondLst>
+                                            <p:cond delay="0"/>
+                                          </p:stCondLst>
+                                        </p:cTn>
+                                        <p:tgtEl>
+                                          <p:spTgt spid="10"/>
+                                        </p:tgtEl>
+                                        <p:attrNameLst>
+                                          <p:attrName>style.visibility</p:attrName>
+                                        </p:attrNameLst>
+                                      </p:cBhvr>
+                                      <p:to>
+                                        <p:strVal val="visible"/>
+                                      </p:to>
+                                    </p:set>
+                                    <p:animEffect transition="in" filter="fade">
+                                      <p:cBhvr>
+                                        <p:cTn id="17" dur="500"/>
+                                        <p:tgtEl>
+                                          <p:spTgt spid="10"/>
+                                        </p:tgtEl>
+                                      </p:cBhvr>
+                                    </p:animEffect>
+                                  </p:childTnLst>
+                                </p:cTn>
+                              </p:par>
+                              <p:par>
+                                <p:cTn id="18" presetID="10" presetClass="entr" presetSubtype="0" fill="hold" nodeType="withEffect">
+                                  <p:stCondLst>
+                                    <p:cond delay="750"/>
+                                  </p:stCondLst>
+                                  <p:childTnLst>
+                                    <p:set>
+                                      <p:cBhvr>
+                                        <p:cTn id="19" dur="1" fill="hold">
+                                          <p:stCondLst>
+                                            <p:cond delay="0"/>
+                                          </p:stCondLst>
+                                        </p:cTn>
+                                        <p:tgtEl>
+                                          <p:spTgt spid="11"/>
+                                        </p:tgtEl>
+                                        <p:attrNameLst>
+                                          <p:attrName>style.visibility</p:attrName>
+                                        </p:attrNameLst>
+                                      </p:cBhvr>
+                                      <p:to>
+                                        <p:strVal val="visible"/>
+                                      </p:to>
+                                    </p:set>
+                                    <p:animEffect transition="in" filter="fade">
+                                      <p:cBhvr>
+                                        <p:cTn id="20" dur="500"/>
+                                        <p:tgtEl>
+                                          <p:spTgt spid="11"/>
+                                        </p:tgtEl>
+                                      </p:cBhvr>
+                                    </p:animEffect>
+                                  </p:childTnLst>
+                                </p:cTn>
+                              </p:par>
+                              <p:par>
+                                <p:cTn id="21" presetID="10" presetClass="entr" presetSubtype="0" fill="hold" nodeType="withEffect">
+                                  <p:stCondLst>
+                                    <p:cond delay="750"/>
+                                  </p:stCondLst>
+                                  <p:childTnLst>
+                                    <p:set>
+                                      <p:cBhvr>
+                                        <p:cTn id="22" dur="1" fill="hold">
+                                          <p:stCondLst>
+                                            <p:cond delay="0"/>
+                                          </p:stCondLst>
+                                        </p:cTn>
+                                        <p:tgtEl>
+                                          <p:spTgt spid="12"/>
+                                        </p:tgtEl>
+                                        <p:attrNameLst>
+                                          <p:attrName>style.visibility</p:attrName>
+                                        </p:attrNameLst>
+                                      </p:cBhvr>
+                                      <p:to>
+                                        <p:strVal val="visible"/>
+                                      </p:to>
+                                    </p:set>
+                                    <p:animEffect transition="in" filter="fade">
+                                      <p:cBhvr>
+                                        <p:cTn id="23" dur="500"/>
+                                        <p:tgtEl>
+                                          <p:spTgt spid="12"/>
+                                        </p:tgtEl>
+                                      </p:cBhvr>
+                                    </p:animEffect>
+                                  </p:childTnLst>
+                                </p:cTn>
+                              </p:par>
+                              <p:par>
+                                <p:cTn id="24" presetID="10" presetClass="entr" presetSubtype="0" fill="hold" nodeType="withEffect">
+                                  <p:stCondLst>
+                                    <p:cond delay="750"/>
+                                  </p:stCondLst>
+                                  <p:childTnLst>
+                                    <p:set>
+                                      <p:cBhvr>
+                                        <p:cTn id="25" dur="1" fill="hold">
+                                          <p:stCondLst>
+                                            <p:cond delay="0"/>
+                                          </p:stCondLst>
+                                        </p:cTn>
+                                        <p:tgtEl>
+                                          <p:spTgt spid="13"/>
+                                        </p:tgtEl>
+                                        <p:attrNameLst>
+                                          <p:attrName>style.visibility</p:attrName>
+                                        </p:attrNameLst>
+                                      </p:cBhvr>
+                                      <p:to>
+                                        <p:strVal val="visible"/>
+                                      </p:to>
+                                    </p:set>
+                                    <p:animEffect transition="in" filter="fade">
+                                      <p:cBhvr>
+                                        <p:cTn id="26" dur="500"/>
+                                        <p:tgtEl>
+                                          <p:spTgt spid="13"/>
+                                        </p:tgtEl>
+                                      </p:cBhvr>
+                                    </p:animEffect>
+                                  </p:childTnLst>
+                                </p:cTn>
+                              </p:par>
+                              <p:par>
+                                <p:cTn id="27" presetID="10" presetClass="entr" presetSubtype="0" fill="hold" nodeType="withEffect">
+                                  <p:stCondLst>
+                                    <p:cond delay="750"/>
+                                  </p:stCondLst>
+                                  <p:childTnLst>
+                                    <p:set>
+                                      <p:cBhvr>
+                                        <p:cTn id="28" dur="1" fill="hold">
+                                          <p:stCondLst>
+                                            <p:cond delay="0"/>
+                                          </p:stCondLst>
+                                        </p:cTn>
+                                        <p:tgtEl>
+                                          <p:spTgt spid="14"/>
+                                        </p:tgtEl>
+                                        <p:attrNameLst>
+                                          <p:attrName>style.visibility</p:attrName>
+                                        </p:attrNameLst>
+                                      </p:cBhvr>
+                                      <p:to>
+                                        <p:strVal val="visible"/>
+                                      </p:to>
+                                    </p:set>
+                                    <p:animEffect transition="in" filter="fade">
+                                      <p:cBhvr>
+                                        <p:cTn id="29" dur="500"/>
+                                        <p:tgtEl>
+                                          <p:spTgt spid="14"/>
                                         </p:tgtEl>
                                       </p:cBhvr>
                                     </p:animEffect>
@@ -3459,7 +3860,8 @@
     </p:tnLst>
     <p:bldLst>
       <p:bldP spid="7" grpId="0" animBg="1"/>
-      <p:bldP spid="8" grpId="0" animBg="1"/>
+      <p:bldP spid="10" grpId="0" animBg="1"/>
+      <p:bldP spid="14" grpId="0" animBg="1"/>
     </p:bldLst>
   </p:timing>
 </p:sld>
@@ -3717,7 +4119,7 @@
       </p:sp>
       <p:sp>
         <p:nvSpPr>
-          <p:cNvPr id="9" name="anim1-200"/>
+          <p:cNvPr id="9" name="anim1-206"/>
           <p:cNvSpPr/>
           <p:nvPr/>
         </p:nvSpPr>
@@ -3751,7 +4153,7 @@
       </p:sp>
       <p:sp>
         <p:nvSpPr>
-          <p:cNvPr id="10" name="anim1-201"/>
+          <p:cNvPr id="10" name="anim1-207"/>
           <p:cNvSpPr/>
           <p:nvPr/>
         </p:nvSpPr>
@@ -3778,7 +4180,7 @@
       </p:sp>
       <p:pic>
         <p:nvPicPr>
-          <p:cNvPr id="11" name="anim1-202" descr="preencoded.png">    </p:cNvPr>
+          <p:cNvPr id="11" name="anim1-208" descr="preencoded.png">    </p:cNvPr>
           <p:cNvPicPr>
             <a:picLocks noChangeAspect="1"/>
           </p:cNvPicPr>
@@ -3802,7 +4204,7 @@
       </p:pic>
       <p:sp>
         <p:nvSpPr>
-          <p:cNvPr id="12" name="anim1-203"/>
+          <p:cNvPr id="12" name="anim1-209"/>
           <p:cNvSpPr txBox="1"/>
           <p:nvPr/>
         </p:nvSpPr>
@@ -3855,7 +4257,7 @@
       </p:sp>
       <p:sp>
         <p:nvSpPr>
-          <p:cNvPr id="13" name="anim2-204"/>
+          <p:cNvPr id="13" name="anim2-210"/>
           <p:cNvSpPr/>
           <p:nvPr/>
         </p:nvSpPr>
@@ -3889,7 +4291,7 @@
       </p:sp>
       <p:sp>
         <p:nvSpPr>
-          <p:cNvPr id="14" name="anim2-205"/>
+          <p:cNvPr id="14" name="anim2-211"/>
           <p:cNvSpPr/>
           <p:nvPr/>
         </p:nvSpPr>
@@ -3916,7 +4318,7 @@
       </p:sp>
       <p:pic>
         <p:nvPicPr>
-          <p:cNvPr id="15" name="anim2-206" descr="preencoded.png">    </p:cNvPr>
+          <p:cNvPr id="15" name="anim2-212" descr="preencoded.png">    </p:cNvPr>
           <p:cNvPicPr>
             <a:picLocks noChangeAspect="1"/>
           </p:cNvPicPr>
@@ -3940,7 +4342,7 @@
       </p:pic>
       <p:sp>
         <p:nvSpPr>
-          <p:cNvPr id="16" name="anim2-207"/>
+          <p:cNvPr id="16" name="anim2-213"/>
           <p:cNvSpPr txBox="1"/>
           <p:nvPr/>
         </p:nvSpPr>
@@ -3993,7 +4395,7 @@
       </p:sp>
       <p:sp>
         <p:nvSpPr>
-          <p:cNvPr id="17" name="anim3-208"/>
+          <p:cNvPr id="17" name="anim3-214"/>
           <p:cNvSpPr/>
           <p:nvPr/>
         </p:nvSpPr>
@@ -4027,7 +4429,7 @@
       </p:sp>
       <p:sp>
         <p:nvSpPr>
-          <p:cNvPr id="18" name="anim3-209"/>
+          <p:cNvPr id="18" name="anim3-215"/>
           <p:cNvSpPr/>
           <p:nvPr/>
         </p:nvSpPr>
@@ -4054,7 +4456,7 @@
       </p:sp>
       <p:pic>
         <p:nvPicPr>
-          <p:cNvPr id="19" name="anim3-210" descr="preencoded.png">    </p:cNvPr>
+          <p:cNvPr id="19" name="anim3-216" descr="preencoded.png">    </p:cNvPr>
           <p:cNvPicPr>
             <a:picLocks noChangeAspect="1"/>
           </p:cNvPicPr>
@@ -4078,7 +4480,7 @@
       </p:pic>
       <p:sp>
         <p:nvSpPr>
-          <p:cNvPr id="20" name="anim3-211"/>
+          <p:cNvPr id="20" name="anim3-217"/>
           <p:cNvSpPr txBox="1"/>
           <p:nvPr/>
         </p:nvSpPr>
@@ -4131,7 +4533,7 @@
       </p:sp>
       <p:sp>
         <p:nvSpPr>
-          <p:cNvPr id="21" name="anim4-212"/>
+          <p:cNvPr id="21" name="anim4-218"/>
           <p:cNvSpPr/>
           <p:nvPr/>
         </p:nvSpPr>
@@ -4165,7 +4567,7 @@
       </p:sp>
       <p:sp>
         <p:nvSpPr>
-          <p:cNvPr id="22" name="anim4-213"/>
+          <p:cNvPr id="22" name="anim4-219"/>
           <p:cNvSpPr/>
           <p:nvPr/>
         </p:nvSpPr>
@@ -4192,7 +4594,7 @@
       </p:sp>
       <p:pic>
         <p:nvPicPr>
-          <p:cNvPr id="23" name="anim4-214" descr="preencoded.png">    </p:cNvPr>
+          <p:cNvPr id="23" name="anim4-220" descr="preencoded.png">    </p:cNvPr>
           <p:cNvPicPr>
             <a:picLocks noChangeAspect="1"/>
           </p:cNvPicPr>
@@ -4216,7 +4618,7 @@
       </p:pic>
       <p:sp>
         <p:nvSpPr>
-          <p:cNvPr id="24" name="anim4-215"/>
+          <p:cNvPr id="24" name="anim4-221"/>
           <p:cNvSpPr txBox="1"/>
           <p:nvPr/>
         </p:nvSpPr>
@@ -4269,7 +4671,7 @@
       </p:sp>
       <p:sp>
         <p:nvSpPr>
-          <p:cNvPr id="25" name="anim5-216"/>
+          <p:cNvPr id="25" name="anim5-222"/>
           <p:cNvSpPr/>
           <p:nvPr/>
         </p:nvSpPr>
@@ -4303,7 +4705,7 @@
       </p:sp>
       <p:sp>
         <p:nvSpPr>
-          <p:cNvPr id="26" name="anim5-217"/>
+          <p:cNvPr id="26" name="anim5-223"/>
           <p:cNvSpPr txBox="1"/>
           <p:nvPr/>
         </p:nvSpPr>
@@ -4339,7 +4741,7 @@
       </p:sp>
       <p:pic>
         <p:nvPicPr>
-          <p:cNvPr id="27" name="anim6-218" descr="preencoded.png">    </p:cNvPr>
+          <p:cNvPr id="27" name="anim6-224" descr="preencoded.png">    </p:cNvPr>
           <p:cNvPicPr>
             <a:picLocks noChangeAspect="1"/>
           </p:cNvPicPr>
@@ -4363,7 +4765,7 @@
       </p:pic>
       <p:sp>
         <p:nvSpPr>
-          <p:cNvPr id="28" name="anim6-219"/>
+          <p:cNvPr id="28" name="anim6-225"/>
           <p:cNvSpPr txBox="1"/>
           <p:nvPr/>
         </p:nvSpPr>
@@ -4399,7 +4801,7 @@
       </p:sp>
       <p:pic>
         <p:nvPicPr>
-          <p:cNvPr id="29" name="anim7-220" descr="preencoded.png">    </p:cNvPr>
+          <p:cNvPr id="29" name="anim7-226" descr="preencoded.png">    </p:cNvPr>
           <p:cNvPicPr>
             <a:picLocks noChangeAspect="1"/>
           </p:cNvPicPr>
@@ -4423,7 +4825,7 @@
       </p:pic>
       <p:sp>
         <p:nvSpPr>
-          <p:cNvPr id="30" name="anim7-221"/>
+          <p:cNvPr id="30" name="anim7-227"/>
           <p:cNvSpPr txBox="1"/>
           <p:nvPr/>
         </p:nvSpPr>
@@ -4459,7 +4861,7 @@
       </p:sp>
       <p:pic>
         <p:nvPicPr>
-          <p:cNvPr id="31" name="anim8-222" descr="preencoded.png">    </p:cNvPr>
+          <p:cNvPr id="31" name="anim8-228" descr="preencoded.png">    </p:cNvPr>
           <p:cNvPicPr>
             <a:picLocks noChangeAspect="1"/>
           </p:cNvPicPr>
@@ -4483,7 +4885,7 @@
       </p:pic>
       <p:sp>
         <p:nvSpPr>
-          <p:cNvPr id="32" name="anim8-223"/>
+          <p:cNvPr id="32" name="anim8-229"/>
           <p:cNvSpPr txBox="1"/>
           <p:nvPr/>
         </p:nvSpPr>
@@ -5726,7 +6128,7 @@
       </p:sp>
       <p:sp>
         <p:nvSpPr>
-          <p:cNvPr id="9" name="anim1-224"/>
+          <p:cNvPr id="9" name="anim1-230"/>
           <p:cNvSpPr/>
           <p:nvPr/>
         </p:nvSpPr>
@@ -5760,7 +6162,7 @@
       </p:sp>
       <p:sp>
         <p:nvSpPr>
-          <p:cNvPr id="10" name="anim1-225"/>
+          <p:cNvPr id="10" name="anim1-231"/>
           <p:cNvSpPr/>
           <p:nvPr/>
         </p:nvSpPr>
@@ -5787,7 +6189,7 @@
       </p:sp>
       <p:pic>
         <p:nvPicPr>
-          <p:cNvPr id="11" name="anim1-226" descr="preencoded.png">    </p:cNvPr>
+          <p:cNvPr id="11" name="anim1-232" descr="preencoded.png">    </p:cNvPr>
           <p:cNvPicPr>
             <a:picLocks noChangeAspect="1"/>
           </p:cNvPicPr>
@@ -5811,7 +6213,7 @@
       </p:pic>
       <p:sp>
         <p:nvSpPr>
-          <p:cNvPr id="12" name="anim1-227"/>
+          <p:cNvPr id="12" name="anim1-233"/>
           <p:cNvSpPr txBox="1"/>
           <p:nvPr/>
         </p:nvSpPr>
@@ -5864,7 +6266,7 @@
       </p:sp>
       <p:sp>
         <p:nvSpPr>
-          <p:cNvPr id="13" name="anim2-228"/>
+          <p:cNvPr id="13" name="anim2-234"/>
           <p:cNvSpPr/>
           <p:nvPr/>
         </p:nvSpPr>
@@ -5898,7 +6300,7 @@
       </p:sp>
       <p:sp>
         <p:nvSpPr>
-          <p:cNvPr id="14" name="anim2-229"/>
+          <p:cNvPr id="14" name="anim2-235"/>
           <p:cNvSpPr/>
           <p:nvPr/>
         </p:nvSpPr>
@@ -5925,7 +6327,7 @@
       </p:sp>
       <p:pic>
         <p:nvPicPr>
-          <p:cNvPr id="15" name="anim2-230" descr="preencoded.png">    </p:cNvPr>
+          <p:cNvPr id="15" name="anim2-236" descr="preencoded.png">    </p:cNvPr>
           <p:cNvPicPr>
             <a:picLocks noChangeAspect="1"/>
           </p:cNvPicPr>
@@ -5949,7 +6351,7 @@
       </p:pic>
       <p:sp>
         <p:nvSpPr>
-          <p:cNvPr id="16" name="anim2-231"/>
+          <p:cNvPr id="16" name="anim2-237"/>
           <p:cNvSpPr txBox="1"/>
           <p:nvPr/>
         </p:nvSpPr>
@@ -6002,7 +6404,7 @@
       </p:sp>
       <p:sp>
         <p:nvSpPr>
-          <p:cNvPr id="17" name="anim3-232"/>
+          <p:cNvPr id="17" name="anim3-238"/>
           <p:cNvSpPr/>
           <p:nvPr/>
         </p:nvSpPr>
@@ -6036,7 +6438,7 @@
       </p:sp>
       <p:sp>
         <p:nvSpPr>
-          <p:cNvPr id="18" name="anim3-233"/>
+          <p:cNvPr id="18" name="anim3-239"/>
           <p:cNvSpPr/>
           <p:nvPr/>
         </p:nvSpPr>
@@ -6063,7 +6465,7 @@
       </p:sp>
       <p:pic>
         <p:nvPicPr>
-          <p:cNvPr id="19" name="anim3-234" descr="preencoded.png">    </p:cNvPr>
+          <p:cNvPr id="19" name="anim3-240" descr="preencoded.png">    </p:cNvPr>
           <p:cNvPicPr>
             <a:picLocks noChangeAspect="1"/>
           </p:cNvPicPr>
@@ -6087,7 +6489,7 @@
       </p:pic>
       <p:sp>
         <p:nvSpPr>
-          <p:cNvPr id="20" name="anim3-235"/>
+          <p:cNvPr id="20" name="anim3-241"/>
           <p:cNvSpPr txBox="1"/>
           <p:nvPr/>
         </p:nvSpPr>
@@ -6140,7 +6542,7 @@
       </p:sp>
       <p:sp>
         <p:nvSpPr>
-          <p:cNvPr id="21" name="anim4-236"/>
+          <p:cNvPr id="21" name="anim4-242"/>
           <p:cNvSpPr/>
           <p:nvPr/>
         </p:nvSpPr>
@@ -6174,7 +6576,7 @@
       </p:sp>
       <p:sp>
         <p:nvSpPr>
-          <p:cNvPr id="22" name="anim4-237"/>
+          <p:cNvPr id="22" name="anim4-243"/>
           <p:cNvSpPr/>
           <p:nvPr/>
         </p:nvSpPr>
@@ -6201,7 +6603,7 @@
       </p:sp>
       <p:pic>
         <p:nvPicPr>
-          <p:cNvPr id="23" name="anim4-238" descr="preencoded.png">    </p:cNvPr>
+          <p:cNvPr id="23" name="anim4-244" descr="preencoded.png">    </p:cNvPr>
           <p:cNvPicPr>
             <a:picLocks noChangeAspect="1"/>
           </p:cNvPicPr>
@@ -6225,7 +6627,7 @@
       </p:pic>
       <p:sp>
         <p:nvSpPr>
-          <p:cNvPr id="24" name="anim4-239"/>
+          <p:cNvPr id="24" name="anim4-245"/>
           <p:cNvSpPr txBox="1"/>
           <p:nvPr/>
         </p:nvSpPr>
@@ -6278,7 +6680,7 @@
       </p:sp>
       <p:sp>
         <p:nvSpPr>
-          <p:cNvPr id="25" name="anim5-240"/>
+          <p:cNvPr id="25" name="anim5-246"/>
           <p:cNvSpPr/>
           <p:nvPr/>
         </p:nvSpPr>
@@ -6312,7 +6714,7 @@
       </p:sp>
       <p:sp>
         <p:nvSpPr>
-          <p:cNvPr id="26" name="anim5-241"/>
+          <p:cNvPr id="26" name="anim5-247"/>
           <p:cNvSpPr txBox="1"/>
           <p:nvPr/>
         </p:nvSpPr>
@@ -6348,7 +6750,7 @@
       </p:sp>
       <p:pic>
         <p:nvPicPr>
-          <p:cNvPr id="27" name="anim6-242" descr="preencoded.png">    </p:cNvPr>
+          <p:cNvPr id="27" name="anim6-248" descr="preencoded.png">    </p:cNvPr>
           <p:cNvPicPr>
             <a:picLocks noChangeAspect="1"/>
           </p:cNvPicPr>
@@ -6372,7 +6774,7 @@
       </p:pic>
       <p:sp>
         <p:nvSpPr>
-          <p:cNvPr id="28" name="anim6-243"/>
+          <p:cNvPr id="28" name="anim6-249"/>
           <p:cNvSpPr txBox="1"/>
           <p:nvPr/>
         </p:nvSpPr>
@@ -6408,7 +6810,7 @@
       </p:sp>
       <p:pic>
         <p:nvPicPr>
-          <p:cNvPr id="29" name="anim7-244" descr="preencoded.png">    </p:cNvPr>
+          <p:cNvPr id="29" name="anim7-250" descr="preencoded.png">    </p:cNvPr>
           <p:cNvPicPr>
             <a:picLocks noChangeAspect="1"/>
           </p:cNvPicPr>
@@ -6432,7 +6834,7 @@
       </p:pic>
       <p:sp>
         <p:nvSpPr>
-          <p:cNvPr id="30" name="anim7-245"/>
+          <p:cNvPr id="30" name="anim7-251"/>
           <p:cNvSpPr txBox="1"/>
           <p:nvPr/>
         </p:nvSpPr>
@@ -6468,7 +6870,7 @@
       </p:sp>
       <p:pic>
         <p:nvPicPr>
-          <p:cNvPr id="31" name="anim8-246" descr="preencoded.png">    </p:cNvPr>
+          <p:cNvPr id="31" name="anim8-252" descr="preencoded.png">    </p:cNvPr>
           <p:cNvPicPr>
             <a:picLocks noChangeAspect="1"/>
           </p:cNvPicPr>
@@ -6492,7 +6894,7 @@
       </p:pic>
       <p:sp>
         <p:nvSpPr>
-          <p:cNvPr id="32" name="anim8-247"/>
+          <p:cNvPr id="32" name="anim8-253"/>
           <p:cNvSpPr txBox="1"/>
           <p:nvPr/>
         </p:nvSpPr>
@@ -7735,7 +8137,7 @@
       </p:sp>
       <p:sp>
         <p:nvSpPr>
-          <p:cNvPr id="9" name="anim1-248"/>
+          <p:cNvPr id="9" name="anim1-254"/>
           <p:cNvSpPr/>
           <p:nvPr/>
         </p:nvSpPr>
@@ -7769,7 +8171,7 @@
       </p:sp>
       <p:sp>
         <p:nvSpPr>
-          <p:cNvPr id="10" name="anim1-249"/>
+          <p:cNvPr id="10" name="anim1-255"/>
           <p:cNvSpPr/>
           <p:nvPr/>
         </p:nvSpPr>
@@ -7796,7 +8198,7 @@
       </p:sp>
       <p:pic>
         <p:nvPicPr>
-          <p:cNvPr id="11" name="anim1-250" descr="preencoded.png">    </p:cNvPr>
+          <p:cNvPr id="11" name="anim1-256" descr="preencoded.png">    </p:cNvPr>
           <p:cNvPicPr>
             <a:picLocks noChangeAspect="1"/>
           </p:cNvPicPr>
@@ -7820,7 +8222,7 @@
       </p:pic>
       <p:sp>
         <p:nvSpPr>
-          <p:cNvPr id="12" name="anim1-251"/>
+          <p:cNvPr id="12" name="anim1-257"/>
           <p:cNvSpPr txBox="1"/>
           <p:nvPr/>
         </p:nvSpPr>
@@ -7873,7 +8275,7 @@
       </p:sp>
       <p:sp>
         <p:nvSpPr>
-          <p:cNvPr id="13" name="anim2-252"/>
+          <p:cNvPr id="13" name="anim2-258"/>
           <p:cNvSpPr/>
           <p:nvPr/>
         </p:nvSpPr>
@@ -7907,7 +8309,7 @@
       </p:sp>
       <p:sp>
         <p:nvSpPr>
-          <p:cNvPr id="14" name="anim2-253"/>
+          <p:cNvPr id="14" name="anim2-259"/>
           <p:cNvSpPr/>
           <p:nvPr/>
         </p:nvSpPr>
@@ -7934,7 +8336,7 @@
       </p:sp>
       <p:pic>
         <p:nvPicPr>
-          <p:cNvPr id="15" name="anim2-254" descr="preencoded.png">    </p:cNvPr>
+          <p:cNvPr id="15" name="anim2-260" descr="preencoded.png">    </p:cNvPr>
           <p:cNvPicPr>
             <a:picLocks noChangeAspect="1"/>
           </p:cNvPicPr>
@@ -7958,7 +8360,7 @@
       </p:pic>
       <p:sp>
         <p:nvSpPr>
-          <p:cNvPr id="16" name="anim2-255"/>
+          <p:cNvPr id="16" name="anim2-261"/>
           <p:cNvSpPr txBox="1"/>
           <p:nvPr/>
         </p:nvSpPr>
@@ -8011,7 +8413,7 @@
       </p:sp>
       <p:sp>
         <p:nvSpPr>
-          <p:cNvPr id="17" name="anim3-256"/>
+          <p:cNvPr id="17" name="anim3-262"/>
           <p:cNvSpPr/>
           <p:nvPr/>
         </p:nvSpPr>
@@ -8045,7 +8447,7 @@
       </p:sp>
       <p:sp>
         <p:nvSpPr>
-          <p:cNvPr id="18" name="anim3-257"/>
+          <p:cNvPr id="18" name="anim3-263"/>
           <p:cNvSpPr/>
           <p:nvPr/>
         </p:nvSpPr>
@@ -8072,7 +8474,7 @@
       </p:sp>
       <p:pic>
         <p:nvPicPr>
-          <p:cNvPr id="19" name="anim3-258" descr="preencoded.png">    </p:cNvPr>
+          <p:cNvPr id="19" name="anim3-264" descr="preencoded.png">    </p:cNvPr>
           <p:cNvPicPr>
             <a:picLocks noChangeAspect="1"/>
           </p:cNvPicPr>
@@ -8096,7 +8498,7 @@
       </p:pic>
       <p:sp>
         <p:nvSpPr>
-          <p:cNvPr id="20" name="anim3-259"/>
+          <p:cNvPr id="20" name="anim3-265"/>
           <p:cNvSpPr txBox="1"/>
           <p:nvPr/>
         </p:nvSpPr>
@@ -8149,7 +8551,7 @@
       </p:sp>
       <p:sp>
         <p:nvSpPr>
-          <p:cNvPr id="21" name="anim4-260"/>
+          <p:cNvPr id="21" name="anim4-266"/>
           <p:cNvSpPr/>
           <p:nvPr/>
         </p:nvSpPr>
@@ -8183,7 +8585,7 @@
       </p:sp>
       <p:sp>
         <p:nvSpPr>
-          <p:cNvPr id="22" name="anim4-261"/>
+          <p:cNvPr id="22" name="anim4-267"/>
           <p:cNvSpPr/>
           <p:nvPr/>
         </p:nvSpPr>
@@ -8210,7 +8612,7 @@
       </p:sp>
       <p:pic>
         <p:nvPicPr>
-          <p:cNvPr id="23" name="anim4-262" descr="preencoded.png">    </p:cNvPr>
+          <p:cNvPr id="23" name="anim4-268" descr="preencoded.png">    </p:cNvPr>
           <p:cNvPicPr>
             <a:picLocks noChangeAspect="1"/>
           </p:cNvPicPr>
@@ -8234,7 +8636,7 @@
       </p:pic>
       <p:sp>
         <p:nvSpPr>
-          <p:cNvPr id="24" name="anim4-263"/>
+          <p:cNvPr id="24" name="anim4-269"/>
           <p:cNvSpPr txBox="1"/>
           <p:nvPr/>
         </p:nvSpPr>
@@ -8287,7 +8689,7 @@
       </p:sp>
       <p:sp>
         <p:nvSpPr>
-          <p:cNvPr id="25" name="anim5-264"/>
+          <p:cNvPr id="25" name="anim5-270"/>
           <p:cNvSpPr/>
           <p:nvPr/>
         </p:nvSpPr>
@@ -8321,7 +8723,7 @@
       </p:sp>
       <p:sp>
         <p:nvSpPr>
-          <p:cNvPr id="26" name="anim5-265"/>
+          <p:cNvPr id="26" name="anim5-271"/>
           <p:cNvSpPr txBox="1"/>
           <p:nvPr/>
         </p:nvSpPr>
@@ -8357,7 +8759,7 @@
       </p:sp>
       <p:pic>
         <p:nvPicPr>
-          <p:cNvPr id="27" name="anim6-266" descr="preencoded.png">    </p:cNvPr>
+          <p:cNvPr id="27" name="anim6-272" descr="preencoded.png">    </p:cNvPr>
           <p:cNvPicPr>
             <a:picLocks noChangeAspect="1"/>
           </p:cNvPicPr>
@@ -8381,7 +8783,7 @@
       </p:pic>
       <p:sp>
         <p:nvSpPr>
-          <p:cNvPr id="28" name="anim6-267"/>
+          <p:cNvPr id="28" name="anim6-273"/>
           <p:cNvSpPr txBox="1"/>
           <p:nvPr/>
         </p:nvSpPr>
@@ -8417,7 +8819,7 @@
       </p:sp>
       <p:pic>
         <p:nvPicPr>
-          <p:cNvPr id="29" name="anim7-268" descr="preencoded.png">    </p:cNvPr>
+          <p:cNvPr id="29" name="anim7-274" descr="preencoded.png">    </p:cNvPr>
           <p:cNvPicPr>
             <a:picLocks noChangeAspect="1"/>
           </p:cNvPicPr>
@@ -8441,7 +8843,7 @@
       </p:pic>
       <p:sp>
         <p:nvSpPr>
-          <p:cNvPr id="30" name="anim7-269"/>
+          <p:cNvPr id="30" name="anim7-275"/>
           <p:cNvSpPr txBox="1"/>
           <p:nvPr/>
         </p:nvSpPr>
@@ -8477,7 +8879,7 @@
       </p:sp>
       <p:pic>
         <p:nvPicPr>
-          <p:cNvPr id="31" name="anim8-270" descr="preencoded.png">    </p:cNvPr>
+          <p:cNvPr id="31" name="anim8-276" descr="preencoded.png">    </p:cNvPr>
           <p:cNvPicPr>
             <a:picLocks noChangeAspect="1"/>
           </p:cNvPicPr>
@@ -8501,7 +8903,7 @@
       </p:pic>
       <p:sp>
         <p:nvSpPr>
-          <p:cNvPr id="32" name="anim8-271"/>
+          <p:cNvPr id="32" name="anim8-277"/>
           <p:cNvSpPr txBox="1"/>
           <p:nvPr/>
         </p:nvSpPr>
@@ -9697,7 +10099,7 @@
       </p:sp>
       <p:sp>
         <p:nvSpPr>
-          <p:cNvPr id="8" name="anim1-272"/>
+          <p:cNvPr id="8" name="anim1-278"/>
           <p:cNvSpPr/>
           <p:nvPr/>
         </p:nvSpPr>
@@ -9731,7 +10133,7 @@
       </p:sp>
       <p:sp>
         <p:nvSpPr>
-          <p:cNvPr id="9" name="anim1-273"/>
+          <p:cNvPr id="9" name="anim1-279"/>
           <p:cNvSpPr/>
           <p:nvPr/>
         </p:nvSpPr>
@@ -9758,7 +10160,7 @@
       </p:sp>
       <p:pic>
         <p:nvPicPr>
-          <p:cNvPr id="10" name="anim1-274" descr="preencoded.png">    </p:cNvPr>
+          <p:cNvPr id="10" name="anim1-280" descr="preencoded.png">    </p:cNvPr>
           <p:cNvPicPr>
             <a:picLocks noChangeAspect="1"/>
           </p:cNvPicPr>
@@ -9782,7 +10184,7 @@
       </p:pic>
       <p:sp>
         <p:nvSpPr>
-          <p:cNvPr id="11" name="anim1-275"/>
+          <p:cNvPr id="11" name="anim1-281"/>
           <p:cNvSpPr txBox="1"/>
           <p:nvPr/>
         </p:nvSpPr>
@@ -9818,7 +10220,7 @@
       </p:sp>
       <p:sp>
         <p:nvSpPr>
-          <p:cNvPr id="12" name="anim2-276"/>
+          <p:cNvPr id="12" name="anim2-282"/>
           <p:cNvSpPr/>
           <p:nvPr/>
         </p:nvSpPr>
@@ -9852,7 +10254,7 @@
       </p:sp>
       <p:sp>
         <p:nvSpPr>
-          <p:cNvPr id="13" name="anim2-277"/>
+          <p:cNvPr id="13" name="anim2-283"/>
           <p:cNvSpPr/>
           <p:nvPr/>
         </p:nvSpPr>
@@ -9879,7 +10281,7 @@
       </p:sp>
       <p:pic>
         <p:nvPicPr>
-          <p:cNvPr id="14" name="anim2-278" descr="preencoded.png">    </p:cNvPr>
+          <p:cNvPr id="14" name="anim2-284" descr="preencoded.png">    </p:cNvPr>
           <p:cNvPicPr>
             <a:picLocks noChangeAspect="1"/>
           </p:cNvPicPr>
@@ -9903,7 +10305,7 @@
       </p:pic>
       <p:sp>
         <p:nvSpPr>
-          <p:cNvPr id="15" name="anim2-279"/>
+          <p:cNvPr id="15" name="anim2-285"/>
           <p:cNvSpPr txBox="1"/>
           <p:nvPr/>
         </p:nvSpPr>
@@ -9939,7 +10341,7 @@
       </p:sp>
       <p:sp>
         <p:nvSpPr>
-          <p:cNvPr id="16" name="anim3-280"/>
+          <p:cNvPr id="16" name="anim3-286"/>
           <p:cNvSpPr/>
           <p:nvPr/>
         </p:nvSpPr>
@@ -9973,7 +10375,7 @@
       </p:sp>
       <p:sp>
         <p:nvSpPr>
-          <p:cNvPr id="17" name="anim3-281"/>
+          <p:cNvPr id="17" name="anim3-287"/>
           <p:cNvSpPr/>
           <p:nvPr/>
         </p:nvSpPr>
@@ -10000,7 +10402,7 @@
       </p:sp>
       <p:pic>
         <p:nvPicPr>
-          <p:cNvPr id="18" name="anim3-282" descr="preencoded.png">    </p:cNvPr>
+          <p:cNvPr id="18" name="anim3-288" descr="preencoded.png">    </p:cNvPr>
           <p:cNvPicPr>
             <a:picLocks noChangeAspect="1"/>
           </p:cNvPicPr>
@@ -10024,7 +10426,7 @@
       </p:pic>
       <p:sp>
         <p:nvSpPr>
-          <p:cNvPr id="19" name="anim3-283"/>
+          <p:cNvPr id="19" name="anim3-289"/>
           <p:cNvSpPr txBox="1"/>
           <p:nvPr/>
         </p:nvSpPr>
@@ -10060,7 +10462,7 @@
       </p:sp>
       <p:sp>
         <p:nvSpPr>
-          <p:cNvPr id="20" name="anim4-284"/>
+          <p:cNvPr id="20" name="anim4-290"/>
           <p:cNvSpPr/>
           <p:nvPr/>
         </p:nvSpPr>
@@ -10094,7 +10496,7 @@
       </p:sp>
       <p:sp>
         <p:nvSpPr>
-          <p:cNvPr id="21" name="anim4-285"/>
+          <p:cNvPr id="21" name="anim4-291"/>
           <p:cNvSpPr/>
           <p:nvPr/>
         </p:nvSpPr>
@@ -10121,7 +10523,7 @@
       </p:sp>
       <p:pic>
         <p:nvPicPr>
-          <p:cNvPr id="22" name="anim4-286" descr="preencoded.png">    </p:cNvPr>
+          <p:cNvPr id="22" name="anim4-292" descr="preencoded.png">    </p:cNvPr>
           <p:cNvPicPr>
             <a:picLocks noChangeAspect="1"/>
           </p:cNvPicPr>
@@ -10145,7 +10547,7 @@
       </p:pic>
       <p:sp>
         <p:nvSpPr>
-          <p:cNvPr id="23" name="anim4-287"/>
+          <p:cNvPr id="23" name="anim4-293"/>
           <p:cNvSpPr txBox="1"/>
           <p:nvPr/>
         </p:nvSpPr>
@@ -10181,7 +10583,7 @@
       </p:sp>
       <p:sp>
         <p:nvSpPr>
-          <p:cNvPr id="24" name="anim5-288"/>
+          <p:cNvPr id="24" name="anim5-294"/>
           <p:cNvSpPr/>
           <p:nvPr/>
         </p:nvSpPr>
@@ -10215,7 +10617,7 @@
       </p:sp>
       <p:sp>
         <p:nvSpPr>
-          <p:cNvPr id="25" name="anim5-289"/>
+          <p:cNvPr id="25" name="anim5-295"/>
           <p:cNvSpPr/>
           <p:nvPr/>
         </p:nvSpPr>
@@ -10242,7 +10644,7 @@
       </p:sp>
       <p:pic>
         <p:nvPicPr>
-          <p:cNvPr id="26" name="anim5-290" descr="preencoded.png">    </p:cNvPr>
+          <p:cNvPr id="26" name="anim5-296" descr="preencoded.png">    </p:cNvPr>
           <p:cNvPicPr>
             <a:picLocks noChangeAspect="1"/>
           </p:cNvPicPr>
@@ -10266,7 +10668,7 @@
       </p:pic>
       <p:sp>
         <p:nvSpPr>
-          <p:cNvPr id="27" name="anim5-291"/>
+          <p:cNvPr id="27" name="anim5-297"/>
           <p:cNvSpPr txBox="1"/>
           <p:nvPr/>
         </p:nvSpPr>
@@ -10302,7 +10704,7 @@
       </p:sp>
       <p:sp>
         <p:nvSpPr>
-          <p:cNvPr id="28" name="anim6-292"/>
+          <p:cNvPr id="28" name="anim6-298"/>
           <p:cNvSpPr/>
           <p:nvPr/>
         </p:nvSpPr>
@@ -10336,7 +10738,7 @@
       </p:sp>
       <p:sp>
         <p:nvSpPr>
-          <p:cNvPr id="29" name="anim6-293"/>
+          <p:cNvPr id="29" name="anim6-299"/>
           <p:cNvSpPr/>
           <p:nvPr/>
         </p:nvSpPr>
@@ -10363,7 +10765,7 @@
       </p:sp>
       <p:pic>
         <p:nvPicPr>
-          <p:cNvPr id="30" name="anim6-294" descr="preencoded.png">    </p:cNvPr>
+          <p:cNvPr id="30" name="anim6-300" descr="preencoded.png">    </p:cNvPr>
           <p:cNvPicPr>
             <a:picLocks noChangeAspect="1"/>
           </p:cNvPicPr>
@@ -10387,7 +10789,7 @@
       </p:pic>
       <p:sp>
         <p:nvSpPr>
-          <p:cNvPr id="31" name="anim6-295"/>
+          <p:cNvPr id="31" name="anim6-301"/>
           <p:cNvSpPr txBox="1"/>
           <p:nvPr/>
         </p:nvSpPr>
@@ -10423,7 +10825,7 @@
       </p:sp>
       <p:sp>
         <p:nvSpPr>
-          <p:cNvPr id="32" name="anim7-296"/>
+          <p:cNvPr id="32" name="anim7-302"/>
           <p:cNvSpPr/>
           <p:nvPr/>
         </p:nvSpPr>
@@ -10457,7 +10859,7 @@
       </p:sp>
       <p:sp>
         <p:nvSpPr>
-          <p:cNvPr id="33" name="anim7-297"/>
+          <p:cNvPr id="33" name="anim7-303"/>
           <p:cNvSpPr/>
           <p:nvPr/>
         </p:nvSpPr>
@@ -10484,7 +10886,7 @@
       </p:sp>
       <p:pic>
         <p:nvPicPr>
-          <p:cNvPr id="34" name="anim7-298" descr="preencoded.png">    </p:cNvPr>
+          <p:cNvPr id="34" name="anim7-304" descr="preencoded.png">    </p:cNvPr>
           <p:cNvPicPr>
             <a:picLocks noChangeAspect="1"/>
           </p:cNvPicPr>
@@ -10508,7 +10910,7 @@
       </p:pic>
       <p:sp>
         <p:nvSpPr>
-          <p:cNvPr id="35" name="anim7-299"/>
+          <p:cNvPr id="35" name="anim7-305"/>
           <p:cNvSpPr txBox="1"/>
           <p:nvPr/>
         </p:nvSpPr>
@@ -10544,7 +10946,7 @@
       </p:sp>
       <p:sp>
         <p:nvSpPr>
-          <p:cNvPr id="36" name="anim8-300"/>
+          <p:cNvPr id="36" name="anim8-306"/>
           <p:cNvSpPr/>
           <p:nvPr/>
         </p:nvSpPr>
@@ -10578,7 +10980,7 @@
       </p:sp>
       <p:sp>
         <p:nvSpPr>
-          <p:cNvPr id="37" name="anim8-301"/>
+          <p:cNvPr id="37" name="anim8-307"/>
           <p:cNvSpPr/>
           <p:nvPr/>
         </p:nvSpPr>
@@ -10605,7 +11007,7 @@
       </p:sp>
       <p:pic>
         <p:nvPicPr>
-          <p:cNvPr id="38" name="anim8-302" descr="preencoded.png">    </p:cNvPr>
+          <p:cNvPr id="38" name="anim8-308" descr="preencoded.png">    </p:cNvPr>
           <p:cNvPicPr>
             <a:picLocks noChangeAspect="1"/>
           </p:cNvPicPr>
@@ -10629,7 +11031,7 @@
       </p:pic>
       <p:sp>
         <p:nvSpPr>
-          <p:cNvPr id="39" name="anim8-303"/>
+          <p:cNvPr id="39" name="anim8-309"/>
           <p:cNvSpPr txBox="1"/>
           <p:nvPr/>
         </p:nvSpPr>
@@ -10665,7 +11067,7 @@
       </p:sp>
       <p:sp>
         <p:nvSpPr>
-          <p:cNvPr id="40" name="anim9-304"/>
+          <p:cNvPr id="40" name="anim9-310"/>
           <p:cNvSpPr/>
           <p:nvPr/>
         </p:nvSpPr>
@@ -10699,7 +11101,7 @@
       </p:sp>
       <p:sp>
         <p:nvSpPr>
-          <p:cNvPr id="41" name="anim9-305"/>
+          <p:cNvPr id="41" name="anim9-311"/>
           <p:cNvSpPr/>
           <p:nvPr/>
         </p:nvSpPr>
@@ -10726,7 +11128,7 @@
       </p:sp>
       <p:pic>
         <p:nvPicPr>
-          <p:cNvPr id="42" name="anim9-306" descr="preencoded.png">    </p:cNvPr>
+          <p:cNvPr id="42" name="anim9-312" descr="preencoded.png">    </p:cNvPr>
           <p:cNvPicPr>
             <a:picLocks noChangeAspect="1"/>
           </p:cNvPicPr>
@@ -10750,7 +11152,7 @@
       </p:pic>
       <p:sp>
         <p:nvSpPr>
-          <p:cNvPr id="43" name="anim9-307"/>
+          <p:cNvPr id="43" name="anim9-313"/>
           <p:cNvSpPr txBox="1"/>
           <p:nvPr/>
         </p:nvSpPr>
@@ -10786,7 +11188,7 @@
       </p:sp>
       <p:sp>
         <p:nvSpPr>
-          <p:cNvPr id="44" name="anim10-308"/>
+          <p:cNvPr id="44" name="anim10-314"/>
           <p:cNvSpPr/>
           <p:nvPr/>
         </p:nvSpPr>
@@ -10820,7 +11222,7 @@
       </p:sp>
       <p:sp>
         <p:nvSpPr>
-          <p:cNvPr id="45" name="anim10-309"/>
+          <p:cNvPr id="45" name="anim10-315"/>
           <p:cNvSpPr/>
           <p:nvPr/>
         </p:nvSpPr>
@@ -10847,7 +11249,7 @@
       </p:sp>
       <p:pic>
         <p:nvPicPr>
-          <p:cNvPr id="46" name="anim10-310" descr="preencoded.png">    </p:cNvPr>
+          <p:cNvPr id="46" name="anim10-316" descr="preencoded.png">    </p:cNvPr>
           <p:cNvPicPr>
             <a:picLocks noChangeAspect="1"/>
           </p:cNvPicPr>
@@ -10871,7 +11273,7 @@
       </p:pic>
       <p:sp>
         <p:nvSpPr>
-          <p:cNvPr id="47" name="anim10-311"/>
+          <p:cNvPr id="47" name="anim10-317"/>
           <p:cNvSpPr txBox="1"/>
           <p:nvPr/>
         </p:nvSpPr>
@@ -10907,7 +11309,7 @@
       </p:sp>
       <p:sp>
         <p:nvSpPr>
-          <p:cNvPr id="48" name="anim11-312"/>
+          <p:cNvPr id="48" name="anim11-318"/>
           <p:cNvSpPr/>
           <p:nvPr/>
         </p:nvSpPr>
@@ -10941,7 +11343,7 @@
       </p:sp>
       <p:sp>
         <p:nvSpPr>
-          <p:cNvPr id="49" name="anim11-313"/>
+          <p:cNvPr id="49" name="anim11-319"/>
           <p:cNvSpPr/>
           <p:nvPr/>
         </p:nvSpPr>
@@ -10968,7 +11370,7 @@
       </p:sp>
       <p:pic>
         <p:nvPicPr>
-          <p:cNvPr id="50" name="anim11-314" descr="preencoded.png">    </p:cNvPr>
+          <p:cNvPr id="50" name="anim11-320" descr="preencoded.png">    </p:cNvPr>
           <p:cNvPicPr>
             <a:picLocks noChangeAspect="1"/>
           </p:cNvPicPr>
@@ -10992,7 +11394,7 @@
       </p:pic>
       <p:sp>
         <p:nvSpPr>
-          <p:cNvPr id="51" name="anim11-315"/>
+          <p:cNvPr id="51" name="anim11-321"/>
           <p:cNvSpPr txBox="1"/>
           <p:nvPr/>
         </p:nvSpPr>
@@ -12974,7 +13376,7 @@
       </p:sp>
       <p:sp>
         <p:nvSpPr>
-          <p:cNvPr id="9" name="anim1-316"/>
+          <p:cNvPr id="9" name="anim1-322"/>
           <p:cNvSpPr/>
           <p:nvPr/>
         </p:nvSpPr>
@@ -13008,7 +13410,7 @@
       </p:sp>
       <p:sp>
         <p:nvSpPr>
-          <p:cNvPr id="10" name="anim1-317"/>
+          <p:cNvPr id="10" name="anim1-323"/>
           <p:cNvSpPr/>
           <p:nvPr/>
         </p:nvSpPr>
@@ -13035,7 +13437,7 @@
       </p:sp>
       <p:pic>
         <p:nvPicPr>
-          <p:cNvPr id="11" name="anim1-318" descr="preencoded.png">    </p:cNvPr>
+          <p:cNvPr id="11" name="anim1-324" descr="preencoded.png">    </p:cNvPr>
           <p:cNvPicPr>
             <a:picLocks noChangeAspect="1"/>
           </p:cNvPicPr>
@@ -13059,7 +13461,7 @@
       </p:pic>
       <p:sp>
         <p:nvSpPr>
-          <p:cNvPr id="12" name="anim1-319"/>
+          <p:cNvPr id="12" name="anim1-325"/>
           <p:cNvSpPr txBox="1"/>
           <p:nvPr/>
         </p:nvSpPr>
@@ -13112,7 +13514,7 @@
       </p:sp>
       <p:sp>
         <p:nvSpPr>
-          <p:cNvPr id="13" name="anim2-320"/>
+          <p:cNvPr id="13" name="anim2-326"/>
           <p:cNvSpPr/>
           <p:nvPr/>
         </p:nvSpPr>
@@ -13146,7 +13548,7 @@
       </p:sp>
       <p:sp>
         <p:nvSpPr>
-          <p:cNvPr id="14" name="anim2-321"/>
+          <p:cNvPr id="14" name="anim2-327"/>
           <p:cNvSpPr/>
           <p:nvPr/>
         </p:nvSpPr>
@@ -13173,7 +13575,7 @@
       </p:sp>
       <p:pic>
         <p:nvPicPr>
-          <p:cNvPr id="15" name="anim2-322" descr="preencoded.png">    </p:cNvPr>
+          <p:cNvPr id="15" name="anim2-328" descr="preencoded.png">    </p:cNvPr>
           <p:cNvPicPr>
             <a:picLocks noChangeAspect="1"/>
           </p:cNvPicPr>
@@ -13197,7 +13599,7 @@
       </p:pic>
       <p:sp>
         <p:nvSpPr>
-          <p:cNvPr id="16" name="anim2-323"/>
+          <p:cNvPr id="16" name="anim2-329"/>
           <p:cNvSpPr txBox="1"/>
           <p:nvPr/>
         </p:nvSpPr>
@@ -13250,7 +13652,7 @@
       </p:sp>
       <p:sp>
         <p:nvSpPr>
-          <p:cNvPr id="17" name="anim3-324"/>
+          <p:cNvPr id="17" name="anim3-330"/>
           <p:cNvSpPr/>
           <p:nvPr/>
         </p:nvSpPr>
@@ -13284,7 +13686,7 @@
       </p:sp>
       <p:sp>
         <p:nvSpPr>
-          <p:cNvPr id="18" name="anim3-325"/>
+          <p:cNvPr id="18" name="anim3-331"/>
           <p:cNvSpPr/>
           <p:nvPr/>
         </p:nvSpPr>
@@ -13311,7 +13713,7 @@
       </p:sp>
       <p:pic>
         <p:nvPicPr>
-          <p:cNvPr id="19" name="anim3-326" descr="preencoded.png">    </p:cNvPr>
+          <p:cNvPr id="19" name="anim3-332" descr="preencoded.png">    </p:cNvPr>
           <p:cNvPicPr>
             <a:picLocks noChangeAspect="1"/>
           </p:cNvPicPr>
@@ -13335,7 +13737,7 @@
       </p:pic>
       <p:sp>
         <p:nvSpPr>
-          <p:cNvPr id="20" name="anim3-327"/>
+          <p:cNvPr id="20" name="anim3-333"/>
           <p:cNvSpPr txBox="1"/>
           <p:nvPr/>
         </p:nvSpPr>
@@ -13388,7 +13790,7 @@
       </p:sp>
       <p:sp>
         <p:nvSpPr>
-          <p:cNvPr id="21" name="anim4-328"/>
+          <p:cNvPr id="21" name="anim4-334"/>
           <p:cNvSpPr/>
           <p:nvPr/>
         </p:nvSpPr>
@@ -13422,7 +13824,7 @@
       </p:sp>
       <p:sp>
         <p:nvSpPr>
-          <p:cNvPr id="22" name="anim4-329"/>
+          <p:cNvPr id="22" name="anim4-335"/>
           <p:cNvSpPr/>
           <p:nvPr/>
         </p:nvSpPr>
@@ -13449,7 +13851,7 @@
       </p:sp>
       <p:pic>
         <p:nvPicPr>
-          <p:cNvPr id="23" name="anim4-330" descr="preencoded.png">    </p:cNvPr>
+          <p:cNvPr id="23" name="anim4-336" descr="preencoded.png">    </p:cNvPr>
           <p:cNvPicPr>
             <a:picLocks noChangeAspect="1"/>
           </p:cNvPicPr>
@@ -13473,7 +13875,7 @@
       </p:pic>
       <p:sp>
         <p:nvSpPr>
-          <p:cNvPr id="24" name="anim4-331"/>
+          <p:cNvPr id="24" name="anim4-337"/>
           <p:cNvSpPr txBox="1"/>
           <p:nvPr/>
         </p:nvSpPr>
@@ -13526,7 +13928,7 @@
       </p:sp>
       <p:sp>
         <p:nvSpPr>
-          <p:cNvPr id="25" name="anim5-332"/>
+          <p:cNvPr id="25" name="anim5-338"/>
           <p:cNvSpPr/>
           <p:nvPr/>
         </p:nvSpPr>
@@ -13560,7 +13962,7 @@
       </p:sp>
       <p:sp>
         <p:nvSpPr>
-          <p:cNvPr id="26" name="anim5-333"/>
+          <p:cNvPr id="26" name="anim5-339"/>
           <p:cNvSpPr txBox="1"/>
           <p:nvPr/>
         </p:nvSpPr>
@@ -13596,7 +13998,7 @@
       </p:sp>
       <p:pic>
         <p:nvPicPr>
-          <p:cNvPr id="27" name="anim6-334" descr="preencoded.png">    </p:cNvPr>
+          <p:cNvPr id="27" name="anim6-340" descr="preencoded.png">    </p:cNvPr>
           <p:cNvPicPr>
             <a:picLocks noChangeAspect="1"/>
           </p:cNvPicPr>
@@ -13620,7 +14022,7 @@
       </p:pic>
       <p:sp>
         <p:nvSpPr>
-          <p:cNvPr id="28" name="anim6-335"/>
+          <p:cNvPr id="28" name="anim6-341"/>
           <p:cNvSpPr txBox="1"/>
           <p:nvPr/>
         </p:nvSpPr>
@@ -13656,7 +14058,7 @@
       </p:sp>
       <p:pic>
         <p:nvPicPr>
-          <p:cNvPr id="29" name="anim7-336" descr="preencoded.png">    </p:cNvPr>
+          <p:cNvPr id="29" name="anim7-342" descr="preencoded.png">    </p:cNvPr>
           <p:cNvPicPr>
             <a:picLocks noChangeAspect="1"/>
           </p:cNvPicPr>
@@ -13680,7 +14082,7 @@
       </p:pic>
       <p:sp>
         <p:nvSpPr>
-          <p:cNvPr id="30" name="anim7-337"/>
+          <p:cNvPr id="30" name="anim7-343"/>
           <p:cNvSpPr txBox="1"/>
           <p:nvPr/>
         </p:nvSpPr>
@@ -13716,7 +14118,7 @@
       </p:sp>
       <p:pic>
         <p:nvPicPr>
-          <p:cNvPr id="31" name="anim8-338" descr="preencoded.png">    </p:cNvPr>
+          <p:cNvPr id="31" name="anim8-344" descr="preencoded.png">    </p:cNvPr>
           <p:cNvPicPr>
             <a:picLocks noChangeAspect="1"/>
           </p:cNvPicPr>
@@ -13740,7 +14142,7 @@
       </p:pic>
       <p:sp>
         <p:nvSpPr>
-          <p:cNvPr id="32" name="anim8-339"/>
+          <p:cNvPr id="32" name="anim8-345"/>
           <p:cNvSpPr txBox="1"/>
           <p:nvPr/>
         </p:nvSpPr>
@@ -14983,7 +15385,7 @@
       </p:sp>
       <p:sp>
         <p:nvSpPr>
-          <p:cNvPr id="9" name="anim1-340"/>
+          <p:cNvPr id="9" name="anim1-346"/>
           <p:cNvSpPr/>
           <p:nvPr/>
         </p:nvSpPr>
@@ -15017,7 +15419,7 @@
       </p:sp>
       <p:sp>
         <p:nvSpPr>
-          <p:cNvPr id="10" name="anim1-341"/>
+          <p:cNvPr id="10" name="anim1-347"/>
           <p:cNvSpPr/>
           <p:nvPr/>
         </p:nvSpPr>
@@ -15044,7 +15446,7 @@
       </p:sp>
       <p:pic>
         <p:nvPicPr>
-          <p:cNvPr id="11" name="anim1-342" descr="preencoded.png">    </p:cNvPr>
+          <p:cNvPr id="11" name="anim1-348" descr="preencoded.png">    </p:cNvPr>
           <p:cNvPicPr>
             <a:picLocks noChangeAspect="1"/>
           </p:cNvPicPr>
@@ -15068,7 +15470,7 @@
       </p:pic>
       <p:sp>
         <p:nvSpPr>
-          <p:cNvPr id="12" name="anim1-343"/>
+          <p:cNvPr id="12" name="anim1-349"/>
           <p:cNvSpPr txBox="1"/>
           <p:nvPr/>
         </p:nvSpPr>
@@ -15121,7 +15523,7 @@
       </p:sp>
       <p:sp>
         <p:nvSpPr>
-          <p:cNvPr id="13" name="anim2-344"/>
+          <p:cNvPr id="13" name="anim2-350"/>
           <p:cNvSpPr/>
           <p:nvPr/>
         </p:nvSpPr>
@@ -15155,7 +15557,7 @@
       </p:sp>
       <p:sp>
         <p:nvSpPr>
-          <p:cNvPr id="14" name="anim2-345"/>
+          <p:cNvPr id="14" name="anim2-351"/>
           <p:cNvSpPr/>
           <p:nvPr/>
         </p:nvSpPr>
@@ -15182,7 +15584,7 @@
       </p:sp>
       <p:pic>
         <p:nvPicPr>
-          <p:cNvPr id="15" name="anim2-346" descr="preencoded.png">    </p:cNvPr>
+          <p:cNvPr id="15" name="anim2-352" descr="preencoded.png">    </p:cNvPr>
           <p:cNvPicPr>
             <a:picLocks noChangeAspect="1"/>
           </p:cNvPicPr>
@@ -15206,7 +15608,7 @@
       </p:pic>
       <p:sp>
         <p:nvSpPr>
-          <p:cNvPr id="16" name="anim2-347"/>
+          <p:cNvPr id="16" name="anim2-353"/>
           <p:cNvSpPr txBox="1"/>
           <p:nvPr/>
         </p:nvSpPr>
@@ -15259,7 +15661,7 @@
       </p:sp>
       <p:sp>
         <p:nvSpPr>
-          <p:cNvPr id="17" name="anim3-348"/>
+          <p:cNvPr id="17" name="anim3-354"/>
           <p:cNvSpPr/>
           <p:nvPr/>
         </p:nvSpPr>
@@ -15293,7 +15695,7 @@
       </p:sp>
       <p:sp>
         <p:nvSpPr>
-          <p:cNvPr id="18" name="anim3-349"/>
+          <p:cNvPr id="18" name="anim3-355"/>
           <p:cNvSpPr/>
           <p:nvPr/>
         </p:nvSpPr>
@@ -15320,7 +15722,7 @@
       </p:sp>
       <p:pic>
         <p:nvPicPr>
-          <p:cNvPr id="19" name="anim3-350" descr="preencoded.png">    </p:cNvPr>
+          <p:cNvPr id="19" name="anim3-356" descr="preencoded.png">    </p:cNvPr>
           <p:cNvPicPr>
             <a:picLocks noChangeAspect="1"/>
           </p:cNvPicPr>
@@ -15344,7 +15746,7 @@
       </p:pic>
       <p:sp>
         <p:nvSpPr>
-          <p:cNvPr id="20" name="anim3-351"/>
+          <p:cNvPr id="20" name="anim3-357"/>
           <p:cNvSpPr txBox="1"/>
           <p:nvPr/>
         </p:nvSpPr>
@@ -15397,7 +15799,7 @@
       </p:sp>
       <p:sp>
         <p:nvSpPr>
-          <p:cNvPr id="21" name="anim4-352"/>
+          <p:cNvPr id="21" name="anim4-358"/>
           <p:cNvSpPr/>
           <p:nvPr/>
         </p:nvSpPr>
@@ -15431,7 +15833,7 @@
       </p:sp>
       <p:sp>
         <p:nvSpPr>
-          <p:cNvPr id="22" name="anim4-353"/>
+          <p:cNvPr id="22" name="anim4-359"/>
           <p:cNvSpPr/>
           <p:nvPr/>
         </p:nvSpPr>
@@ -15458,7 +15860,7 @@
       </p:sp>
       <p:pic>
         <p:nvPicPr>
-          <p:cNvPr id="23" name="anim4-354" descr="preencoded.png">    </p:cNvPr>
+          <p:cNvPr id="23" name="anim4-360" descr="preencoded.png">    </p:cNvPr>
           <p:cNvPicPr>
             <a:picLocks noChangeAspect="1"/>
           </p:cNvPicPr>
@@ -15482,7 +15884,7 @@
       </p:pic>
       <p:sp>
         <p:nvSpPr>
-          <p:cNvPr id="24" name="anim4-355"/>
+          <p:cNvPr id="24" name="anim4-361"/>
           <p:cNvSpPr txBox="1"/>
           <p:nvPr/>
         </p:nvSpPr>
@@ -15535,7 +15937,7 @@
       </p:sp>
       <p:sp>
         <p:nvSpPr>
-          <p:cNvPr id="25" name="anim5-356"/>
+          <p:cNvPr id="25" name="anim5-362"/>
           <p:cNvSpPr/>
           <p:nvPr/>
         </p:nvSpPr>
@@ -15569,7 +15971,7 @@
       </p:sp>
       <p:sp>
         <p:nvSpPr>
-          <p:cNvPr id="26" name="anim5-357"/>
+          <p:cNvPr id="26" name="anim5-363"/>
           <p:cNvSpPr txBox="1"/>
           <p:nvPr/>
         </p:nvSpPr>
@@ -15605,7 +16007,7 @@
       </p:sp>
       <p:pic>
         <p:nvPicPr>
-          <p:cNvPr id="27" name="anim6-358" descr="preencoded.png">    </p:cNvPr>
+          <p:cNvPr id="27" name="anim6-364" descr="preencoded.png">    </p:cNvPr>
           <p:cNvPicPr>
             <a:picLocks noChangeAspect="1"/>
           </p:cNvPicPr>
@@ -15629,7 +16031,7 @@
       </p:pic>
       <p:sp>
         <p:nvSpPr>
-          <p:cNvPr id="28" name="anim6-359"/>
+          <p:cNvPr id="28" name="anim6-365"/>
           <p:cNvSpPr txBox="1"/>
           <p:nvPr/>
         </p:nvSpPr>
@@ -15665,7 +16067,7 @@
       </p:sp>
       <p:pic>
         <p:nvPicPr>
-          <p:cNvPr id="29" name="anim7-360" descr="preencoded.png">    </p:cNvPr>
+          <p:cNvPr id="29" name="anim7-366" descr="preencoded.png">    </p:cNvPr>
           <p:cNvPicPr>
             <a:picLocks noChangeAspect="1"/>
           </p:cNvPicPr>
@@ -15689,7 +16091,7 @@
       </p:pic>
       <p:sp>
         <p:nvSpPr>
-          <p:cNvPr id="30" name="anim7-361"/>
+          <p:cNvPr id="30" name="anim7-367"/>
           <p:cNvSpPr txBox="1"/>
           <p:nvPr/>
         </p:nvSpPr>
@@ -15725,7 +16127,7 @@
       </p:sp>
       <p:pic>
         <p:nvPicPr>
-          <p:cNvPr id="31" name="anim8-362" descr="preencoded.png">    </p:cNvPr>
+          <p:cNvPr id="31" name="anim8-368" descr="preencoded.png">    </p:cNvPr>
           <p:cNvPicPr>
             <a:picLocks noChangeAspect="1"/>
           </p:cNvPicPr>
@@ -15749,7 +16151,7 @@
       </p:pic>
       <p:sp>
         <p:nvSpPr>
-          <p:cNvPr id="32" name="anim8-363"/>
+          <p:cNvPr id="32" name="anim8-369"/>
           <p:cNvSpPr txBox="1"/>
           <p:nvPr/>
         </p:nvSpPr>
@@ -16797,7 +17199,7 @@
       </p:sp>
       <p:sp>
         <p:nvSpPr>
-          <p:cNvPr id="3" name="anim1-364"/>
+          <p:cNvPr id="3" name="anim1-370"/>
           <p:cNvSpPr/>
           <p:nvPr/>
         </p:nvSpPr>
@@ -16824,7 +17226,7 @@
       </p:sp>
       <p:sp>
         <p:nvSpPr>
-          <p:cNvPr id="4" name="anim1-365"/>
+          <p:cNvPr id="4" name="anim1-371"/>
           <p:cNvSpPr txBox="1"/>
           <p:nvPr/>
         </p:nvSpPr>
@@ -16863,7 +17265,7 @@
       </p:sp>
       <p:sp>
         <p:nvSpPr>
-          <p:cNvPr id="5" name="anim1-366"/>
+          <p:cNvPr id="5" name="anim1-372"/>
           <p:cNvSpPr txBox="1"/>
           <p:nvPr/>
         </p:nvSpPr>
@@ -16916,7 +17318,7 @@
       </p:sp>
       <p:sp>
         <p:nvSpPr>
-          <p:cNvPr id="6" name="anim2-367"/>
+          <p:cNvPr id="6" name="anim2-373"/>
           <p:cNvSpPr/>
           <p:nvPr/>
         </p:nvSpPr>
@@ -16943,7 +17345,7 @@
       </p:sp>
       <p:sp>
         <p:nvSpPr>
-          <p:cNvPr id="7" name="anim2-368"/>
+          <p:cNvPr id="7" name="anim2-374"/>
           <p:cNvSpPr txBox="1"/>
           <p:nvPr/>
         </p:nvSpPr>
@@ -16982,7 +17384,7 @@
       </p:sp>
       <p:sp>
         <p:nvSpPr>
-          <p:cNvPr id="8" name="anim2-369"/>
+          <p:cNvPr id="8" name="anim2-375"/>
           <p:cNvSpPr txBox="1"/>
           <p:nvPr/>
         </p:nvSpPr>
@@ -17035,7 +17437,7 @@
       </p:sp>
       <p:sp>
         <p:nvSpPr>
-          <p:cNvPr id="9" name="anim3-370"/>
+          <p:cNvPr id="9" name="anim3-376"/>
           <p:cNvSpPr/>
           <p:nvPr/>
         </p:nvSpPr>
@@ -17062,7 +17464,7 @@
       </p:sp>
       <p:sp>
         <p:nvSpPr>
-          <p:cNvPr id="10" name="anim3-371"/>
+          <p:cNvPr id="10" name="anim3-377"/>
           <p:cNvSpPr txBox="1"/>
           <p:nvPr/>
         </p:nvSpPr>
@@ -17101,7 +17503,7 @@
       </p:sp>
       <p:sp>
         <p:nvSpPr>
-          <p:cNvPr id="11" name="anim3-372"/>
+          <p:cNvPr id="11" name="anim3-378"/>
           <p:cNvSpPr txBox="1"/>
           <p:nvPr/>
         </p:nvSpPr>
@@ -17154,7 +17556,7 @@
       </p:sp>
       <p:sp>
         <p:nvSpPr>
-          <p:cNvPr id="12" name="anim4-373"/>
+          <p:cNvPr id="12" name="anim4-379"/>
           <p:cNvSpPr/>
           <p:nvPr/>
         </p:nvSpPr>
@@ -17181,7 +17583,7 @@
       </p:sp>
       <p:sp>
         <p:nvSpPr>
-          <p:cNvPr id="13" name="anim4-374"/>
+          <p:cNvPr id="13" name="anim4-380"/>
           <p:cNvSpPr txBox="1"/>
           <p:nvPr/>
         </p:nvSpPr>
@@ -17220,7 +17622,7 @@
       </p:sp>
       <p:sp>
         <p:nvSpPr>
-          <p:cNvPr id="14" name="anim4-375"/>
+          <p:cNvPr id="14" name="anim4-381"/>
           <p:cNvSpPr txBox="1"/>
           <p:nvPr/>
         </p:nvSpPr>
@@ -17273,7 +17675,7 @@
       </p:sp>
       <p:sp>
         <p:nvSpPr>
-          <p:cNvPr id="15" name="anim5-376"/>
+          <p:cNvPr id="15" name="anim5-382"/>
           <p:cNvSpPr txBox="1"/>
           <p:nvPr/>
         </p:nvSpPr>
@@ -18049,7 +18451,7 @@
       </p:sp>
       <p:sp>
         <p:nvSpPr>
-          <p:cNvPr id="7" name="anim1-377"/>
+          <p:cNvPr id="7" name="anim1-383"/>
           <p:cNvSpPr/>
           <p:nvPr/>
         </p:nvSpPr>
@@ -18083,7 +18485,7 @@
       </p:sp>
       <p:sp>
         <p:nvSpPr>
-          <p:cNvPr id="8" name="anim1-378"/>
+          <p:cNvPr id="8" name="anim1-384"/>
           <p:cNvSpPr/>
           <p:nvPr/>
         </p:nvSpPr>
@@ -18110,7 +18512,7 @@
       </p:sp>
       <p:pic>
         <p:nvPicPr>
-          <p:cNvPr id="9" name="anim1-379" descr="preencoded.png">    </p:cNvPr>
+          <p:cNvPr id="9" name="anim1-385" descr="preencoded.png">    </p:cNvPr>
           <p:cNvPicPr>
             <a:picLocks noChangeAspect="1"/>
           </p:cNvPicPr>
@@ -18134,7 +18536,7 @@
       </p:pic>
       <p:sp>
         <p:nvSpPr>
-          <p:cNvPr id="10" name="anim1-380"/>
+          <p:cNvPr id="10" name="anim1-386"/>
           <p:cNvSpPr txBox="1"/>
           <p:nvPr/>
         </p:nvSpPr>
@@ -18170,7 +18572,7 @@
       </p:sp>
       <p:pic>
         <p:nvPicPr>
-          <p:cNvPr id="11" name="anim2-381" descr="preencoded.png">    </p:cNvPr>
+          <p:cNvPr id="11" name="anim2-387" descr="preencoded.png">    </p:cNvPr>
           <p:cNvPicPr>
             <a:picLocks noChangeAspect="1"/>
           </p:cNvPicPr>
@@ -18194,7 +18596,7 @@
       </p:pic>
       <p:sp>
         <p:nvSpPr>
-          <p:cNvPr id="12" name="anim2-382"/>
+          <p:cNvPr id="12" name="anim2-388"/>
           <p:cNvSpPr txBox="1"/>
           <p:nvPr/>
         </p:nvSpPr>
@@ -18230,7 +18632,7 @@
       </p:sp>
       <p:pic>
         <p:nvPicPr>
-          <p:cNvPr id="13" name="anim3-383" descr="preencoded.png">    </p:cNvPr>
+          <p:cNvPr id="13" name="anim3-389" descr="preencoded.png">    </p:cNvPr>
           <p:cNvPicPr>
             <a:picLocks noChangeAspect="1"/>
           </p:cNvPicPr>
@@ -18254,7 +18656,7 @@
       </p:pic>
       <p:sp>
         <p:nvSpPr>
-          <p:cNvPr id="14" name="anim3-384"/>
+          <p:cNvPr id="14" name="anim3-390"/>
           <p:cNvSpPr txBox="1"/>
           <p:nvPr/>
         </p:nvSpPr>
@@ -18290,7 +18692,7 @@
       </p:sp>
       <p:pic>
         <p:nvPicPr>
-          <p:cNvPr id="15" name="anim4-385" descr="preencoded.png">    </p:cNvPr>
+          <p:cNvPr id="15" name="anim4-391" descr="preencoded.png">    </p:cNvPr>
           <p:cNvPicPr>
             <a:picLocks noChangeAspect="1"/>
           </p:cNvPicPr>
@@ -18314,7 +18716,7 @@
       </p:pic>
       <p:sp>
         <p:nvSpPr>
-          <p:cNvPr id="16" name="anim4-386"/>
+          <p:cNvPr id="16" name="anim4-392"/>
           <p:cNvSpPr txBox="1"/>
           <p:nvPr/>
         </p:nvSpPr>
@@ -18350,7 +18752,7 @@
       </p:sp>
       <p:pic>
         <p:nvPicPr>
-          <p:cNvPr id="17" name="anim5-387" descr="preencoded.png">    </p:cNvPr>
+          <p:cNvPr id="17" name="anim5-393" descr="preencoded.png">    </p:cNvPr>
           <p:cNvPicPr>
             <a:picLocks noChangeAspect="1"/>
           </p:cNvPicPr>
@@ -18374,7 +18776,7 @@
       </p:pic>
       <p:sp>
         <p:nvSpPr>
-          <p:cNvPr id="18" name="anim5-388"/>
+          <p:cNvPr id="18" name="anim5-394"/>
           <p:cNvSpPr txBox="1"/>
           <p:nvPr/>
         </p:nvSpPr>
@@ -18410,7 +18812,7 @@
       </p:sp>
       <p:sp>
         <p:nvSpPr>
-          <p:cNvPr id="19" name="anim6-389"/>
+          <p:cNvPr id="19" name="anim6-395"/>
           <p:cNvSpPr/>
           <p:nvPr/>
         </p:nvSpPr>
@@ -18444,7 +18846,7 @@
       </p:sp>
       <p:sp>
         <p:nvSpPr>
-          <p:cNvPr id="20" name="anim6-390"/>
+          <p:cNvPr id="20" name="anim6-396"/>
           <p:cNvSpPr/>
           <p:nvPr/>
         </p:nvSpPr>
@@ -18471,7 +18873,7 @@
       </p:sp>
       <p:pic>
         <p:nvPicPr>
-          <p:cNvPr id="21" name="anim6-391" descr="preencoded.png">    </p:cNvPr>
+          <p:cNvPr id="21" name="anim6-397" descr="preencoded.png">    </p:cNvPr>
           <p:cNvPicPr>
             <a:picLocks noChangeAspect="1"/>
           </p:cNvPicPr>
@@ -18495,7 +18897,7 @@
       </p:pic>
       <p:sp>
         <p:nvSpPr>
-          <p:cNvPr id="22" name="anim6-392"/>
+          <p:cNvPr id="22" name="anim6-398"/>
           <p:cNvSpPr txBox="1"/>
           <p:nvPr/>
         </p:nvSpPr>
@@ -18531,7 +18933,7 @@
       </p:sp>
       <p:pic>
         <p:nvPicPr>
-          <p:cNvPr id="23" name="anim7-393" descr="preencoded.png">    </p:cNvPr>
+          <p:cNvPr id="23" name="anim7-399" descr="preencoded.png">    </p:cNvPr>
           <p:cNvPicPr>
             <a:picLocks noChangeAspect="1"/>
           </p:cNvPicPr>
@@ -18555,7 +18957,7 @@
       </p:pic>
       <p:sp>
         <p:nvSpPr>
-          <p:cNvPr id="24" name="anim7-394"/>
+          <p:cNvPr id="24" name="anim7-400"/>
           <p:cNvSpPr txBox="1"/>
           <p:nvPr/>
         </p:nvSpPr>
@@ -18591,7 +18993,7 @@
       </p:sp>
       <p:pic>
         <p:nvPicPr>
-          <p:cNvPr id="25" name="anim8-395" descr="preencoded.png">    </p:cNvPr>
+          <p:cNvPr id="25" name="anim8-401" descr="preencoded.png">    </p:cNvPr>
           <p:cNvPicPr>
             <a:picLocks noChangeAspect="1"/>
           </p:cNvPicPr>
@@ -18615,7 +19017,7 @@
       </p:pic>
       <p:sp>
         <p:nvSpPr>
-          <p:cNvPr id="26" name="anim8-396"/>
+          <p:cNvPr id="26" name="anim8-402"/>
           <p:cNvSpPr txBox="1"/>
           <p:nvPr/>
         </p:nvSpPr>
@@ -18651,7 +19053,7 @@
       </p:sp>
       <p:pic>
         <p:nvPicPr>
-          <p:cNvPr id="27" name="anim9-397" descr="preencoded.png">    </p:cNvPr>
+          <p:cNvPr id="27" name="anim9-403" descr="preencoded.png">    </p:cNvPr>
           <p:cNvPicPr>
             <a:picLocks noChangeAspect="1"/>
           </p:cNvPicPr>
@@ -18675,7 +19077,7 @@
       </p:pic>
       <p:sp>
         <p:nvSpPr>
-          <p:cNvPr id="28" name="anim9-398"/>
+          <p:cNvPr id="28" name="anim9-404"/>
           <p:cNvSpPr txBox="1"/>
           <p:nvPr/>
         </p:nvSpPr>
@@ -18711,7 +19113,7 @@
       </p:sp>
       <p:pic>
         <p:nvPicPr>
-          <p:cNvPr id="29" name="anim10-399" descr="preencoded.png">    </p:cNvPr>
+          <p:cNvPr id="29" name="anim10-405" descr="preencoded.png">    </p:cNvPr>
           <p:cNvPicPr>
             <a:picLocks noChangeAspect="1"/>
           </p:cNvPicPr>
@@ -18735,7 +19137,7 @@
       </p:pic>
       <p:sp>
         <p:nvSpPr>
-          <p:cNvPr id="30" name="anim10-400"/>
+          <p:cNvPr id="30" name="anim10-406"/>
           <p:cNvSpPr txBox="1"/>
           <p:nvPr/>
         </p:nvSpPr>
@@ -19933,7 +20335,7 @@
       </p:sp>
       <p:sp>
         <p:nvSpPr>
-          <p:cNvPr id="8" name="anim1-401"/>
+          <p:cNvPr id="8" name="anim1-407"/>
           <p:cNvSpPr/>
           <p:nvPr/>
         </p:nvSpPr>
@@ -19956,7 +20358,7 @@
       </p:sp>
       <p:sp>
         <p:nvSpPr>
-          <p:cNvPr id="9" name="anim1-402"/>
+          <p:cNvPr id="9" name="anim1-408"/>
           <p:cNvSpPr/>
           <p:nvPr/>
         </p:nvSpPr>
@@ -19979,7 +20381,7 @@
       </p:sp>
       <p:pic>
         <p:nvPicPr>
-          <p:cNvPr id="10" name="anim1-403" descr="preencoded.png">    </p:cNvPr>
+          <p:cNvPr id="10" name="anim1-409" descr="preencoded.png">    </p:cNvPr>
           <p:cNvPicPr>
             <a:picLocks noChangeAspect="1"/>
           </p:cNvPicPr>
@@ -20003,7 +20405,7 @@
       </p:pic>
       <p:sp>
         <p:nvSpPr>
-          <p:cNvPr id="11" name="anim2-404"/>
+          <p:cNvPr id="11" name="anim2-410"/>
           <p:cNvSpPr/>
           <p:nvPr/>
         </p:nvSpPr>
@@ -20035,7 +20437,7 @@
       </p:sp>
       <p:pic>
         <p:nvPicPr>
-          <p:cNvPr id="12" name="anim2-405" descr="preencoded.png">    </p:cNvPr>
+          <p:cNvPr id="12" name="anim2-411" descr="preencoded.png">    </p:cNvPr>
           <p:cNvPicPr>
             <a:picLocks noChangeAspect="1"/>
           </p:cNvPicPr>
@@ -20059,7 +20461,7 @@
       </p:pic>
       <p:sp>
         <p:nvSpPr>
-          <p:cNvPr id="13" name="anim2-406"/>
+          <p:cNvPr id="13" name="anim2-412"/>
           <p:cNvSpPr/>
           <p:nvPr/>
         </p:nvSpPr>
@@ -20084,7 +20486,7 @@
       </p:sp>
       <p:sp>
         <p:nvSpPr>
-          <p:cNvPr id="14" name="anim2-407"/>
+          <p:cNvPr id="14" name="anim2-413"/>
           <p:cNvSpPr txBox="1"/>
           <p:nvPr/>
         </p:nvSpPr>
@@ -20120,7 +20522,7 @@
       </p:sp>
       <p:sp>
         <p:nvSpPr>
-          <p:cNvPr id="15" name="anim2-408"/>
+          <p:cNvPr id="15" name="anim2-414"/>
           <p:cNvSpPr txBox="1"/>
           <p:nvPr/>
         </p:nvSpPr>
@@ -20170,7 +20572,7 @@
       </p:sp>
       <p:sp>
         <p:nvSpPr>
-          <p:cNvPr id="16" name="anim3-409"/>
+          <p:cNvPr id="16" name="anim3-415"/>
           <p:cNvSpPr/>
           <p:nvPr/>
         </p:nvSpPr>
@@ -20202,7 +20604,7 @@
       </p:sp>
       <p:pic>
         <p:nvPicPr>
-          <p:cNvPr id="17" name="anim3-410" descr="preencoded.png">    </p:cNvPr>
+          <p:cNvPr id="17" name="anim3-416" descr="preencoded.png">    </p:cNvPr>
           <p:cNvPicPr>
             <a:picLocks noChangeAspect="1"/>
           </p:cNvPicPr>
@@ -20226,7 +20628,7 @@
       </p:pic>
       <p:sp>
         <p:nvSpPr>
-          <p:cNvPr id="18" name="anim3-411"/>
+          <p:cNvPr id="18" name="anim3-417"/>
           <p:cNvSpPr/>
           <p:nvPr/>
         </p:nvSpPr>
@@ -20251,7 +20653,7 @@
       </p:sp>
       <p:sp>
         <p:nvSpPr>
-          <p:cNvPr id="19" name="anim3-412"/>
+          <p:cNvPr id="19" name="anim3-418"/>
           <p:cNvSpPr txBox="1"/>
           <p:nvPr/>
         </p:nvSpPr>
@@ -20287,7 +20689,7 @@
       </p:sp>
       <p:sp>
         <p:nvSpPr>
-          <p:cNvPr id="20" name="anim3-413"/>
+          <p:cNvPr id="20" name="anim3-419"/>
           <p:cNvSpPr txBox="1"/>
           <p:nvPr/>
         </p:nvSpPr>
@@ -20337,7 +20739,7 @@
       </p:sp>
       <p:sp>
         <p:nvSpPr>
-          <p:cNvPr id="21" name="anim4-414"/>
+          <p:cNvPr id="21" name="anim4-420"/>
           <p:cNvSpPr/>
           <p:nvPr/>
         </p:nvSpPr>
@@ -20369,7 +20771,7 @@
       </p:sp>
       <p:pic>
         <p:nvPicPr>
-          <p:cNvPr id="22" name="anim4-415" descr="preencoded.png">    </p:cNvPr>
+          <p:cNvPr id="22" name="anim4-421" descr="preencoded.png">    </p:cNvPr>
           <p:cNvPicPr>
             <a:picLocks noChangeAspect="1"/>
           </p:cNvPicPr>
@@ -20393,7 +20795,7 @@
       </p:pic>
       <p:sp>
         <p:nvSpPr>
-          <p:cNvPr id="23" name="anim4-416"/>
+          <p:cNvPr id="23" name="anim4-422"/>
           <p:cNvSpPr/>
           <p:nvPr/>
         </p:nvSpPr>
@@ -20418,7 +20820,7 @@
       </p:sp>
       <p:sp>
         <p:nvSpPr>
-          <p:cNvPr id="24" name="anim4-417"/>
+          <p:cNvPr id="24" name="anim4-423"/>
           <p:cNvSpPr txBox="1"/>
           <p:nvPr/>
         </p:nvSpPr>
@@ -20454,7 +20856,7 @@
       </p:sp>
       <p:sp>
         <p:nvSpPr>
-          <p:cNvPr id="25" name="anim4-418"/>
+          <p:cNvPr id="25" name="anim4-424"/>
           <p:cNvSpPr txBox="1"/>
           <p:nvPr/>
         </p:nvSpPr>
@@ -20504,7 +20906,7 @@
       </p:sp>
       <p:sp>
         <p:nvSpPr>
-          <p:cNvPr id="26" name="anim5-419"/>
+          <p:cNvPr id="26" name="anim5-425"/>
           <p:cNvSpPr/>
           <p:nvPr/>
         </p:nvSpPr>
@@ -20536,7 +20938,7 @@
       </p:sp>
       <p:pic>
         <p:nvPicPr>
-          <p:cNvPr id="27" name="anim5-420" descr="preencoded.png">    </p:cNvPr>
+          <p:cNvPr id="27" name="anim5-426" descr="preencoded.png">    </p:cNvPr>
           <p:cNvPicPr>
             <a:picLocks noChangeAspect="1"/>
           </p:cNvPicPr>
@@ -20560,7 +20962,7 @@
       </p:pic>
       <p:sp>
         <p:nvSpPr>
-          <p:cNvPr id="28" name="anim5-421"/>
+          <p:cNvPr id="28" name="anim5-427"/>
           <p:cNvSpPr/>
           <p:nvPr/>
         </p:nvSpPr>
@@ -20585,7 +20987,7 @@
       </p:sp>
       <p:sp>
         <p:nvSpPr>
-          <p:cNvPr id="29" name="anim5-422"/>
+          <p:cNvPr id="29" name="anim5-428"/>
           <p:cNvSpPr txBox="1"/>
           <p:nvPr/>
         </p:nvSpPr>
@@ -20621,7 +21023,7 @@
       </p:sp>
       <p:sp>
         <p:nvSpPr>
-          <p:cNvPr id="30" name="anim5-423"/>
+          <p:cNvPr id="30" name="anim5-429"/>
           <p:cNvSpPr txBox="1"/>
           <p:nvPr/>
         </p:nvSpPr>
@@ -20671,7 +21073,7 @@
       </p:sp>
       <p:sp>
         <p:nvSpPr>
-          <p:cNvPr id="31" name="anim6-424"/>
+          <p:cNvPr id="31" name="anim6-430"/>
           <p:cNvSpPr/>
           <p:nvPr/>
         </p:nvSpPr>
@@ -20703,7 +21105,7 @@
       </p:sp>
       <p:pic>
         <p:nvPicPr>
-          <p:cNvPr id="32" name="anim6-425" descr="preencoded.png">    </p:cNvPr>
+          <p:cNvPr id="32" name="anim6-431" descr="preencoded.png">    </p:cNvPr>
           <p:cNvPicPr>
             <a:picLocks noChangeAspect="1"/>
           </p:cNvPicPr>
@@ -20727,7 +21129,7 @@
       </p:pic>
       <p:sp>
         <p:nvSpPr>
-          <p:cNvPr id="33" name="anim6-426"/>
+          <p:cNvPr id="33" name="anim6-432"/>
           <p:cNvSpPr/>
           <p:nvPr/>
         </p:nvSpPr>
@@ -20752,7 +21154,7 @@
       </p:sp>
       <p:sp>
         <p:nvSpPr>
-          <p:cNvPr id="34" name="anim6-427"/>
+          <p:cNvPr id="34" name="anim6-433"/>
           <p:cNvSpPr txBox="1"/>
           <p:nvPr/>
         </p:nvSpPr>
@@ -20788,7 +21190,7 @@
       </p:sp>
       <p:sp>
         <p:nvSpPr>
-          <p:cNvPr id="35" name="anim6-428"/>
+          <p:cNvPr id="35" name="anim6-434"/>
           <p:cNvSpPr txBox="1"/>
           <p:nvPr/>
         </p:nvSpPr>
@@ -20838,7 +21240,7 @@
       </p:sp>
       <p:sp>
         <p:nvSpPr>
-          <p:cNvPr id="36" name="anim7-429"/>
+          <p:cNvPr id="36" name="anim7-435"/>
           <p:cNvSpPr/>
           <p:nvPr/>
         </p:nvSpPr>
@@ -20872,7 +21274,7 @@
       </p:sp>
       <p:sp>
         <p:nvSpPr>
-          <p:cNvPr id="37" name="anim7-430"/>
+          <p:cNvPr id="37" name="anim7-436"/>
           <p:cNvSpPr/>
           <p:nvPr/>
         </p:nvSpPr>
@@ -20899,7 +21301,7 @@
       </p:sp>
       <p:pic>
         <p:nvPicPr>
-          <p:cNvPr id="38" name="anim7-431" descr="preencoded.png">    </p:cNvPr>
+          <p:cNvPr id="38" name="anim7-437" descr="preencoded.png">    </p:cNvPr>
           <p:cNvPicPr>
             <a:picLocks noChangeAspect="1"/>
           </p:cNvPicPr>
@@ -20923,7 +21325,7 @@
       </p:pic>
       <p:sp>
         <p:nvSpPr>
-          <p:cNvPr id="39" name="anim7-432"/>
+          <p:cNvPr id="39" name="anim7-438"/>
           <p:cNvSpPr txBox="1"/>
           <p:nvPr/>
         </p:nvSpPr>
@@ -22256,7 +22658,7 @@
       </p:sp>
       <p:pic>
         <p:nvPicPr>
-          <p:cNvPr id="3" name="anim1-433" descr="preencoded.png">    </p:cNvPr>
+          <p:cNvPr id="3" name="anim1-439" descr="preencoded.png">    </p:cNvPr>
           <p:cNvPicPr>
             <a:picLocks noChangeAspect="1"/>
           </p:cNvPicPr>
@@ -22318,7 +22720,7 @@
       </p:sp>
       <p:sp>
         <p:nvSpPr>
-          <p:cNvPr id="5" name="anim2-434"/>
+          <p:cNvPr id="5" name="anim2-440"/>
           <p:cNvSpPr txBox="1"/>
           <p:nvPr/>
         </p:nvSpPr>
@@ -22656,7 +23058,7 @@
       </p:sp>
       <p:sp>
         <p:nvSpPr>
-          <p:cNvPr id="7" name="anim1-4"/>
+          <p:cNvPr id="7" name="anim1-10"/>
           <p:cNvSpPr txBox="1"/>
           <p:nvPr/>
         </p:nvSpPr>
@@ -22692,7 +23094,7 @@
       </p:sp>
       <p:sp>
         <p:nvSpPr>
-          <p:cNvPr id="8" name="anim2-5"/>
+          <p:cNvPr id="8" name="anim2-11"/>
           <p:cNvSpPr/>
           <p:nvPr/>
         </p:nvSpPr>
@@ -22726,7 +23128,7 @@
       </p:sp>
       <p:sp>
         <p:nvSpPr>
-          <p:cNvPr id="9" name="anim2-6"/>
+          <p:cNvPr id="9" name="anim2-12"/>
           <p:cNvSpPr/>
           <p:nvPr/>
         </p:nvSpPr>
@@ -22753,7 +23155,7 @@
       </p:sp>
       <p:pic>
         <p:nvPicPr>
-          <p:cNvPr id="10" name="anim2-7" descr="preencoded.png">    </p:cNvPr>
+          <p:cNvPr id="10" name="anim2-13" descr="preencoded.png">    </p:cNvPr>
           <p:cNvPicPr>
             <a:picLocks noChangeAspect="1"/>
           </p:cNvPicPr>
@@ -22777,7 +23179,7 @@
       </p:pic>
       <p:sp>
         <p:nvSpPr>
-          <p:cNvPr id="11" name="anim2-8"/>
+          <p:cNvPr id="11" name="anim2-14"/>
           <p:cNvSpPr txBox="1"/>
           <p:nvPr/>
         </p:nvSpPr>
@@ -22830,7 +23232,7 @@
       </p:sp>
       <p:sp>
         <p:nvSpPr>
-          <p:cNvPr id="12" name="anim3-9"/>
+          <p:cNvPr id="12" name="anim3-15"/>
           <p:cNvSpPr/>
           <p:nvPr/>
         </p:nvSpPr>
@@ -22864,7 +23266,7 @@
       </p:sp>
       <p:sp>
         <p:nvSpPr>
-          <p:cNvPr id="13" name="anim3-10"/>
+          <p:cNvPr id="13" name="anim3-16"/>
           <p:cNvSpPr/>
           <p:nvPr/>
         </p:nvSpPr>
@@ -22891,7 +23293,7 @@
       </p:sp>
       <p:pic>
         <p:nvPicPr>
-          <p:cNvPr id="14" name="anim3-11" descr="preencoded.png">    </p:cNvPr>
+          <p:cNvPr id="14" name="anim3-17" descr="preencoded.png">    </p:cNvPr>
           <p:cNvPicPr>
             <a:picLocks noChangeAspect="1"/>
           </p:cNvPicPr>
@@ -22915,7 +23317,7 @@
       </p:pic>
       <p:sp>
         <p:nvSpPr>
-          <p:cNvPr id="15" name="anim3-12"/>
+          <p:cNvPr id="15" name="anim3-18"/>
           <p:cNvSpPr txBox="1"/>
           <p:nvPr/>
         </p:nvSpPr>
@@ -22968,7 +23370,7 @@
       </p:sp>
       <p:sp>
         <p:nvSpPr>
-          <p:cNvPr id="16" name="anim4-13"/>
+          <p:cNvPr id="16" name="anim4-19"/>
           <p:cNvSpPr/>
           <p:nvPr/>
         </p:nvSpPr>
@@ -23002,7 +23404,7 @@
       </p:sp>
       <p:sp>
         <p:nvSpPr>
-          <p:cNvPr id="17" name="anim4-14"/>
+          <p:cNvPr id="17" name="anim4-20"/>
           <p:cNvSpPr/>
           <p:nvPr/>
         </p:nvSpPr>
@@ -23029,7 +23431,7 @@
       </p:sp>
       <p:pic>
         <p:nvPicPr>
-          <p:cNvPr id="18" name="anim4-15" descr="preencoded.png">    </p:cNvPr>
+          <p:cNvPr id="18" name="anim4-21" descr="preencoded.png">    </p:cNvPr>
           <p:cNvPicPr>
             <a:picLocks noChangeAspect="1"/>
           </p:cNvPicPr>
@@ -23053,7 +23455,7 @@
       </p:pic>
       <p:sp>
         <p:nvSpPr>
-          <p:cNvPr id="19" name="anim4-16"/>
+          <p:cNvPr id="19" name="anim4-22"/>
           <p:cNvSpPr txBox="1"/>
           <p:nvPr/>
         </p:nvSpPr>
@@ -23106,7 +23508,7 @@
       </p:sp>
       <p:sp>
         <p:nvSpPr>
-          <p:cNvPr id="20" name="anim5-17"/>
+          <p:cNvPr id="20" name="anim5-23"/>
           <p:cNvSpPr/>
           <p:nvPr/>
         </p:nvSpPr>
@@ -23131,7 +23533,7 @@
       </p:sp>
       <p:sp>
         <p:nvSpPr>
-          <p:cNvPr id="21" name="anim6-18"/>
+          <p:cNvPr id="21" name="anim6-24"/>
           <p:cNvSpPr txBox="1"/>
           <p:nvPr/>
         </p:nvSpPr>
@@ -23167,7 +23569,7 @@
       </p:sp>
       <p:sp>
         <p:nvSpPr>
-          <p:cNvPr id="22" name="anim7-19"/>
+          <p:cNvPr id="22" name="anim7-25"/>
           <p:cNvSpPr/>
           <p:nvPr/>
         </p:nvSpPr>
@@ -23201,7 +23603,7 @@
       </p:sp>
       <p:sp>
         <p:nvSpPr>
-          <p:cNvPr id="23" name="anim7-20"/>
+          <p:cNvPr id="23" name="anim7-26"/>
           <p:cNvSpPr/>
           <p:nvPr/>
         </p:nvSpPr>
@@ -23228,7 +23630,7 @@
       </p:sp>
       <p:pic>
         <p:nvPicPr>
-          <p:cNvPr id="24" name="anim7-21" descr="preencoded.png">    </p:cNvPr>
+          <p:cNvPr id="24" name="anim7-27" descr="preencoded.png">    </p:cNvPr>
           <p:cNvPicPr>
             <a:picLocks noChangeAspect="1"/>
           </p:cNvPicPr>
@@ -23252,7 +23654,7 @@
       </p:pic>
       <p:sp>
         <p:nvSpPr>
-          <p:cNvPr id="25" name="anim7-22"/>
+          <p:cNvPr id="25" name="anim7-28"/>
           <p:cNvSpPr txBox="1"/>
           <p:nvPr/>
         </p:nvSpPr>
@@ -23305,7 +23707,7 @@
       </p:sp>
       <p:sp>
         <p:nvSpPr>
-          <p:cNvPr id="26" name="anim8-23"/>
+          <p:cNvPr id="26" name="anim8-29"/>
           <p:cNvSpPr/>
           <p:nvPr/>
         </p:nvSpPr>
@@ -23339,7 +23741,7 @@
       </p:sp>
       <p:sp>
         <p:nvSpPr>
-          <p:cNvPr id="27" name="anim8-24"/>
+          <p:cNvPr id="27" name="anim8-30"/>
           <p:cNvSpPr/>
           <p:nvPr/>
         </p:nvSpPr>
@@ -23366,7 +23768,7 @@
       </p:sp>
       <p:pic>
         <p:nvPicPr>
-          <p:cNvPr id="28" name="anim8-25" descr="preencoded.png">    </p:cNvPr>
+          <p:cNvPr id="28" name="anim8-31" descr="preencoded.png">    </p:cNvPr>
           <p:cNvPicPr>
             <a:picLocks noChangeAspect="1"/>
           </p:cNvPicPr>
@@ -23390,7 +23792,7 @@
       </p:pic>
       <p:sp>
         <p:nvSpPr>
-          <p:cNvPr id="29" name="anim8-26"/>
+          <p:cNvPr id="29" name="anim8-32"/>
           <p:cNvSpPr txBox="1"/>
           <p:nvPr/>
         </p:nvSpPr>
@@ -23443,7 +23845,7 @@
       </p:sp>
       <p:sp>
         <p:nvSpPr>
-          <p:cNvPr id="30" name="anim9-27"/>
+          <p:cNvPr id="30" name="anim9-33"/>
           <p:cNvSpPr/>
           <p:nvPr/>
         </p:nvSpPr>
@@ -23477,7 +23879,7 @@
       </p:sp>
       <p:sp>
         <p:nvSpPr>
-          <p:cNvPr id="31" name="anim9-28"/>
+          <p:cNvPr id="31" name="anim9-34"/>
           <p:cNvSpPr/>
           <p:nvPr/>
         </p:nvSpPr>
@@ -23504,7 +23906,7 @@
       </p:sp>
       <p:pic>
         <p:nvPicPr>
-          <p:cNvPr id="32" name="anim9-29" descr="preencoded.png">    </p:cNvPr>
+          <p:cNvPr id="32" name="anim9-35" descr="preencoded.png">    </p:cNvPr>
           <p:cNvPicPr>
             <a:picLocks noChangeAspect="1"/>
           </p:cNvPicPr>
@@ -23528,7 +23930,7 @@
       </p:pic>
       <p:sp>
         <p:nvSpPr>
-          <p:cNvPr id="33" name="anim9-30"/>
+          <p:cNvPr id="33" name="anim9-36"/>
           <p:cNvSpPr txBox="1"/>
           <p:nvPr/>
         </p:nvSpPr>
@@ -24810,7 +25212,7 @@
       </p:sp>
       <p:sp>
         <p:nvSpPr>
-          <p:cNvPr id="7" name="anim1-435"/>
+          <p:cNvPr id="7" name="anim1-441"/>
           <p:cNvSpPr/>
           <p:nvPr/>
         </p:nvSpPr>
@@ -24844,7 +25246,7 @@
       </p:sp>
       <p:sp>
         <p:nvSpPr>
-          <p:cNvPr id="8" name="anim1-436"/>
+          <p:cNvPr id="8" name="anim1-442"/>
           <p:cNvSpPr/>
           <p:nvPr/>
         </p:nvSpPr>
@@ -24871,7 +25273,7 @@
       </p:sp>
       <p:pic>
         <p:nvPicPr>
-          <p:cNvPr id="9" name="anim1-437" descr="preencoded.png">    </p:cNvPr>
+          <p:cNvPr id="9" name="anim1-443" descr="preencoded.png">    </p:cNvPr>
           <p:cNvPicPr>
             <a:picLocks noChangeAspect="1"/>
           </p:cNvPicPr>
@@ -24895,7 +25297,7 @@
       </p:pic>
       <p:sp>
         <p:nvSpPr>
-          <p:cNvPr id="10" name="anim1-438"/>
+          <p:cNvPr id="10" name="anim1-444"/>
           <p:cNvSpPr txBox="1"/>
           <p:nvPr/>
         </p:nvSpPr>
@@ -24931,7 +25333,7 @@
       </p:sp>
       <p:sp>
         <p:nvSpPr>
-          <p:cNvPr id="11" name="anim1-439"/>
+          <p:cNvPr id="11" name="anim1-445"/>
           <p:cNvSpPr txBox="1"/>
           <p:nvPr/>
         </p:nvSpPr>
@@ -24981,7 +25383,7 @@
       </p:sp>
       <p:sp>
         <p:nvSpPr>
-          <p:cNvPr id="12" name="anim2-440"/>
+          <p:cNvPr id="12" name="anim2-446"/>
           <p:cNvSpPr/>
           <p:nvPr/>
         </p:nvSpPr>
@@ -25015,7 +25417,7 @@
       </p:sp>
       <p:sp>
         <p:nvSpPr>
-          <p:cNvPr id="13" name="anim2-441"/>
+          <p:cNvPr id="13" name="anim2-447"/>
           <p:cNvSpPr/>
           <p:nvPr/>
         </p:nvSpPr>
@@ -25042,7 +25444,7 @@
       </p:sp>
       <p:pic>
         <p:nvPicPr>
-          <p:cNvPr id="14" name="anim2-442" descr="preencoded.png">    </p:cNvPr>
+          <p:cNvPr id="14" name="anim2-448" descr="preencoded.png">    </p:cNvPr>
           <p:cNvPicPr>
             <a:picLocks noChangeAspect="1"/>
           </p:cNvPicPr>
@@ -25066,7 +25468,7 @@
       </p:pic>
       <p:sp>
         <p:nvSpPr>
-          <p:cNvPr id="15" name="anim2-443"/>
+          <p:cNvPr id="15" name="anim2-449"/>
           <p:cNvSpPr txBox="1"/>
           <p:nvPr/>
         </p:nvSpPr>
@@ -25102,7 +25504,7 @@
       </p:sp>
       <p:sp>
         <p:nvSpPr>
-          <p:cNvPr id="16" name="anim2-444"/>
+          <p:cNvPr id="16" name="anim2-450"/>
           <p:cNvSpPr txBox="1"/>
           <p:nvPr/>
         </p:nvSpPr>
@@ -25152,7 +25554,7 @@
       </p:sp>
       <p:sp>
         <p:nvSpPr>
-          <p:cNvPr id="17" name="anim3-445"/>
+          <p:cNvPr id="17" name="anim3-451"/>
           <p:cNvSpPr txBox="1"/>
           <p:nvPr/>
         </p:nvSpPr>
@@ -25188,7 +25590,7 @@
       </p:sp>
       <p:sp>
         <p:nvSpPr>
-          <p:cNvPr id="18" name="anim3-446"/>
+          <p:cNvPr id="18" name="anim3-452"/>
           <p:cNvSpPr/>
           <p:nvPr/>
         </p:nvSpPr>
@@ -25222,7 +25624,7 @@
       </p:sp>
       <p:sp>
         <p:nvSpPr>
-          <p:cNvPr id="19" name="anim3-447"/>
+          <p:cNvPr id="19" name="anim3-453"/>
           <p:cNvSpPr txBox="1"/>
           <p:nvPr/>
         </p:nvSpPr>
@@ -25272,7 +25674,7 @@
       </p:sp>
       <p:sp>
         <p:nvSpPr>
-          <p:cNvPr id="20" name="anim4-448"/>
+          <p:cNvPr id="20" name="anim4-454"/>
           <p:cNvSpPr/>
           <p:nvPr/>
         </p:nvSpPr>
@@ -25297,7 +25699,7 @@
       </p:sp>
       <p:sp>
         <p:nvSpPr>
-          <p:cNvPr id="21" name="anim4-449"/>
+          <p:cNvPr id="21" name="anim4-455"/>
           <p:cNvSpPr/>
           <p:nvPr/>
         </p:nvSpPr>
@@ -25331,7 +25733,7 @@
       </p:sp>
       <p:sp>
         <p:nvSpPr>
-          <p:cNvPr id="22" name="anim4-450"/>
+          <p:cNvPr id="22" name="anim4-456"/>
           <p:cNvSpPr txBox="1"/>
           <p:nvPr/>
         </p:nvSpPr>
@@ -26224,7 +26626,7 @@
       </p:sp>
       <p:sp>
         <p:nvSpPr>
-          <p:cNvPr id="7" name="anim1-31"/>
+          <p:cNvPr id="7" name="anim1-37"/>
           <p:cNvSpPr/>
           <p:nvPr/>
         </p:nvSpPr>
@@ -26249,7 +26651,7 @@
       </p:sp>
       <p:sp>
         <p:nvSpPr>
-          <p:cNvPr id="8" name="anim1-32"/>
+          <p:cNvPr id="8" name="anim1-38"/>
           <p:cNvSpPr/>
           <p:nvPr/>
         </p:nvSpPr>
@@ -26274,7 +26676,7 @@
       </p:sp>
       <p:sp>
         <p:nvSpPr>
-          <p:cNvPr id="9" name="anim1-33"/>
+          <p:cNvPr id="9" name="anim1-39"/>
           <p:cNvSpPr txBox="1"/>
           <p:nvPr/>
         </p:nvSpPr>
@@ -26324,7 +26726,7 @@
       </p:sp>
       <p:sp>
         <p:nvSpPr>
-          <p:cNvPr id="10" name="anim2-34"/>
+          <p:cNvPr id="10" name="anim2-40"/>
           <p:cNvSpPr/>
           <p:nvPr/>
         </p:nvSpPr>
@@ -26358,7 +26760,7 @@
       </p:sp>
       <p:sp>
         <p:nvSpPr>
-          <p:cNvPr id="11" name="anim2-35"/>
+          <p:cNvPr id="11" name="anim2-41"/>
           <p:cNvSpPr/>
           <p:nvPr/>
         </p:nvSpPr>
@@ -26385,7 +26787,7 @@
       </p:sp>
       <p:pic>
         <p:nvPicPr>
-          <p:cNvPr id="12" name="anim2-36" descr="preencoded.png">    </p:cNvPr>
+          <p:cNvPr id="12" name="anim2-42" descr="preencoded.png">    </p:cNvPr>
           <p:cNvPicPr>
             <a:picLocks noChangeAspect="1"/>
           </p:cNvPicPr>
@@ -26409,7 +26811,7 @@
       </p:pic>
       <p:sp>
         <p:nvSpPr>
-          <p:cNvPr id="13" name="anim2-37"/>
+          <p:cNvPr id="13" name="anim2-43"/>
           <p:cNvSpPr txBox="1"/>
           <p:nvPr/>
         </p:nvSpPr>
@@ -26462,7 +26864,7 @@
       </p:sp>
       <p:sp>
         <p:nvSpPr>
-          <p:cNvPr id="14" name="anim3-38"/>
+          <p:cNvPr id="14" name="anim3-44"/>
           <p:cNvSpPr/>
           <p:nvPr/>
         </p:nvSpPr>
@@ -26496,7 +26898,7 @@
       </p:sp>
       <p:sp>
         <p:nvSpPr>
-          <p:cNvPr id="15" name="anim3-39"/>
+          <p:cNvPr id="15" name="anim3-45"/>
           <p:cNvSpPr/>
           <p:nvPr/>
         </p:nvSpPr>
@@ -26523,7 +26925,7 @@
       </p:sp>
       <p:pic>
         <p:nvPicPr>
-          <p:cNvPr id="16" name="anim3-40" descr="preencoded.png">    </p:cNvPr>
+          <p:cNvPr id="16" name="anim3-46" descr="preencoded.png">    </p:cNvPr>
           <p:cNvPicPr>
             <a:picLocks noChangeAspect="1"/>
           </p:cNvPicPr>
@@ -26547,7 +26949,7 @@
       </p:pic>
       <p:sp>
         <p:nvSpPr>
-          <p:cNvPr id="17" name="anim3-41"/>
+          <p:cNvPr id="17" name="anim3-47"/>
           <p:cNvSpPr txBox="1"/>
           <p:nvPr/>
         </p:nvSpPr>
@@ -26600,7 +27002,7 @@
       </p:sp>
       <p:sp>
         <p:nvSpPr>
-          <p:cNvPr id="18" name="anim4-42"/>
+          <p:cNvPr id="18" name="anim4-48"/>
           <p:cNvSpPr/>
           <p:nvPr/>
         </p:nvSpPr>
@@ -26634,7 +27036,7 @@
       </p:sp>
       <p:sp>
         <p:nvSpPr>
-          <p:cNvPr id="19" name="anim4-43"/>
+          <p:cNvPr id="19" name="anim4-49"/>
           <p:cNvSpPr/>
           <p:nvPr/>
         </p:nvSpPr>
@@ -26661,7 +27063,7 @@
       </p:sp>
       <p:pic>
         <p:nvPicPr>
-          <p:cNvPr id="20" name="anim4-44" descr="preencoded.png">    </p:cNvPr>
+          <p:cNvPr id="20" name="anim4-50" descr="preencoded.png">    </p:cNvPr>
           <p:cNvPicPr>
             <a:picLocks noChangeAspect="1"/>
           </p:cNvPicPr>
@@ -26685,7 +27087,7 @@
       </p:pic>
       <p:sp>
         <p:nvSpPr>
-          <p:cNvPr id="21" name="anim4-45"/>
+          <p:cNvPr id="21" name="anim4-51"/>
           <p:cNvSpPr txBox="1"/>
           <p:nvPr/>
         </p:nvSpPr>
@@ -26738,7 +27140,7 @@
       </p:sp>
       <p:sp>
         <p:nvSpPr>
-          <p:cNvPr id="22" name="anim5-46"/>
+          <p:cNvPr id="22" name="anim5-52"/>
           <p:cNvSpPr/>
           <p:nvPr/>
         </p:nvSpPr>
@@ -26772,7 +27174,7 @@
       </p:sp>
       <p:sp>
         <p:nvSpPr>
-          <p:cNvPr id="23" name="anim5-47"/>
+          <p:cNvPr id="23" name="anim5-53"/>
           <p:cNvSpPr/>
           <p:nvPr/>
         </p:nvSpPr>
@@ -26799,7 +27201,7 @@
       </p:sp>
       <p:pic>
         <p:nvPicPr>
-          <p:cNvPr id="24" name="anim5-48" descr="preencoded.png">    </p:cNvPr>
+          <p:cNvPr id="24" name="anim5-54" descr="preencoded.png">    </p:cNvPr>
           <p:cNvPicPr>
             <a:picLocks noChangeAspect="1"/>
           </p:cNvPicPr>
@@ -26823,7 +27225,7 @@
       </p:pic>
       <p:sp>
         <p:nvSpPr>
-          <p:cNvPr id="25" name="anim5-49"/>
+          <p:cNvPr id="25" name="anim5-55"/>
           <p:cNvSpPr txBox="1"/>
           <p:nvPr/>
         </p:nvSpPr>
@@ -26876,7 +27278,7 @@
       </p:sp>
       <p:sp>
         <p:nvSpPr>
-          <p:cNvPr id="26" name="anim6-50"/>
+          <p:cNvPr id="26" name="anim6-56"/>
           <p:cNvSpPr/>
           <p:nvPr/>
         </p:nvSpPr>
@@ -26910,7 +27312,7 @@
       </p:sp>
       <p:sp>
         <p:nvSpPr>
-          <p:cNvPr id="27" name="anim6-51"/>
+          <p:cNvPr id="27" name="anim6-57"/>
           <p:cNvSpPr/>
           <p:nvPr/>
         </p:nvSpPr>
@@ -26937,7 +27339,7 @@
       </p:sp>
       <p:pic>
         <p:nvPicPr>
-          <p:cNvPr id="28" name="anim6-52" descr="preencoded.png">    </p:cNvPr>
+          <p:cNvPr id="28" name="anim6-58" descr="preencoded.png">    </p:cNvPr>
           <p:cNvPicPr>
             <a:picLocks noChangeAspect="1"/>
           </p:cNvPicPr>
@@ -26961,7 +27363,7 @@
       </p:pic>
       <p:sp>
         <p:nvSpPr>
-          <p:cNvPr id="29" name="anim6-53"/>
+          <p:cNvPr id="29" name="anim6-59"/>
           <p:cNvSpPr txBox="1"/>
           <p:nvPr/>
         </p:nvSpPr>
@@ -27014,7 +27416,7 @@
       </p:sp>
       <p:sp>
         <p:nvSpPr>
-          <p:cNvPr id="30" name="anim7-54"/>
+          <p:cNvPr id="30" name="anim7-60"/>
           <p:cNvSpPr/>
           <p:nvPr/>
         </p:nvSpPr>
@@ -27048,7 +27450,7 @@
       </p:sp>
       <p:sp>
         <p:nvSpPr>
-          <p:cNvPr id="31" name="anim7-55"/>
+          <p:cNvPr id="31" name="anim7-61"/>
           <p:cNvSpPr/>
           <p:nvPr/>
         </p:nvSpPr>
@@ -27075,7 +27477,7 @@
       </p:sp>
       <p:pic>
         <p:nvPicPr>
-          <p:cNvPr id="32" name="anim7-56" descr="preencoded.png">    </p:cNvPr>
+          <p:cNvPr id="32" name="anim7-62" descr="preencoded.png">    </p:cNvPr>
           <p:cNvPicPr>
             <a:picLocks noChangeAspect="1"/>
           </p:cNvPicPr>
@@ -27099,7 +27501,7 @@
       </p:pic>
       <p:sp>
         <p:nvSpPr>
-          <p:cNvPr id="33" name="anim7-57"/>
+          <p:cNvPr id="33" name="anim7-63"/>
           <p:cNvSpPr txBox="1"/>
           <p:nvPr/>
         </p:nvSpPr>
@@ -28268,7 +28670,7 @@
       </p:sp>
       <p:sp>
         <p:nvSpPr>
-          <p:cNvPr id="3" name="anim1-58"/>
+          <p:cNvPr id="3" name="anim1-64"/>
           <p:cNvSpPr txBox="1"/>
           <p:nvPr/>
         </p:nvSpPr>
@@ -28304,7 +28706,7 @@
       </p:sp>
       <p:sp>
         <p:nvSpPr>
-          <p:cNvPr id="4" name="anim1-59"/>
+          <p:cNvPr id="4" name="anim1-65"/>
           <p:cNvSpPr/>
           <p:nvPr/>
         </p:nvSpPr>
@@ -28327,7 +28729,7 @@
       </p:sp>
       <p:sp>
         <p:nvSpPr>
-          <p:cNvPr id="5" name="anim1-60"/>
+          <p:cNvPr id="5" name="anim1-66"/>
           <p:cNvSpPr/>
           <p:nvPr/>
         </p:nvSpPr>
@@ -28350,7 +28752,7 @@
       </p:sp>
       <p:sp>
         <p:nvSpPr>
-          <p:cNvPr id="6" name="anim2-61"/>
+          <p:cNvPr id="6" name="anim2-67"/>
           <p:cNvSpPr/>
           <p:nvPr/>
         </p:nvSpPr>
@@ -28375,7 +28777,7 @@
       </p:sp>
       <p:pic>
         <p:nvPicPr>
-          <p:cNvPr id="7" name="anim2-62" descr="preencoded.png">    </p:cNvPr>
+          <p:cNvPr id="7" name="anim2-68" descr="preencoded.png">    </p:cNvPr>
           <p:cNvPicPr>
             <a:picLocks noChangeAspect="1"/>
           </p:cNvPicPr>
@@ -28399,7 +28801,7 @@
       </p:pic>
       <p:sp>
         <p:nvSpPr>
-          <p:cNvPr id="8" name="anim2-63"/>
+          <p:cNvPr id="8" name="anim2-69"/>
           <p:cNvSpPr txBox="1"/>
           <p:nvPr/>
         </p:nvSpPr>
@@ -28452,7 +28854,7 @@
       </p:sp>
       <p:sp>
         <p:nvSpPr>
-          <p:cNvPr id="9" name="anim3-64"/>
+          <p:cNvPr id="9" name="anim3-70"/>
           <p:cNvSpPr/>
           <p:nvPr/>
         </p:nvSpPr>
@@ -28477,7 +28879,7 @@
       </p:sp>
       <p:pic>
         <p:nvPicPr>
-          <p:cNvPr id="10" name="anim3-65" descr="preencoded.png">    </p:cNvPr>
+          <p:cNvPr id="10" name="anim3-71" descr="preencoded.png">    </p:cNvPr>
           <p:cNvPicPr>
             <a:picLocks noChangeAspect="1"/>
           </p:cNvPicPr>
@@ -28501,7 +28903,7 @@
       </p:pic>
       <p:sp>
         <p:nvSpPr>
-          <p:cNvPr id="11" name="anim3-66"/>
+          <p:cNvPr id="11" name="anim3-72"/>
           <p:cNvSpPr txBox="1"/>
           <p:nvPr/>
         </p:nvSpPr>
@@ -28554,7 +28956,7 @@
       </p:sp>
       <p:sp>
         <p:nvSpPr>
-          <p:cNvPr id="12" name="anim4-67"/>
+          <p:cNvPr id="12" name="anim4-73"/>
           <p:cNvSpPr/>
           <p:nvPr/>
         </p:nvSpPr>
@@ -28579,7 +28981,7 @@
       </p:sp>
       <p:pic>
         <p:nvPicPr>
-          <p:cNvPr id="13" name="anim4-68" descr="preencoded.png">    </p:cNvPr>
+          <p:cNvPr id="13" name="anim4-74" descr="preencoded.png">    </p:cNvPr>
           <p:cNvPicPr>
             <a:picLocks noChangeAspect="1"/>
           </p:cNvPicPr>
@@ -28603,7 +29005,7 @@
       </p:pic>
       <p:sp>
         <p:nvSpPr>
-          <p:cNvPr id="14" name="anim4-69"/>
+          <p:cNvPr id="14" name="anim4-75"/>
           <p:cNvSpPr txBox="1"/>
           <p:nvPr/>
         </p:nvSpPr>
@@ -28656,7 +29058,7 @@
       </p:sp>
       <p:sp>
         <p:nvSpPr>
-          <p:cNvPr id="15" name="anim5-70"/>
+          <p:cNvPr id="15" name="anim5-76"/>
           <p:cNvSpPr/>
           <p:nvPr/>
         </p:nvSpPr>
@@ -28681,7 +29083,7 @@
       </p:sp>
       <p:pic>
         <p:nvPicPr>
-          <p:cNvPr id="16" name="anim5-71" descr="preencoded.png">    </p:cNvPr>
+          <p:cNvPr id="16" name="anim5-77" descr="preencoded.png">    </p:cNvPr>
           <p:cNvPicPr>
             <a:picLocks noChangeAspect="1"/>
           </p:cNvPicPr>
@@ -28705,7 +29107,7 @@
       </p:pic>
       <p:sp>
         <p:nvSpPr>
-          <p:cNvPr id="17" name="anim5-72"/>
+          <p:cNvPr id="17" name="anim5-78"/>
           <p:cNvSpPr txBox="1"/>
           <p:nvPr/>
         </p:nvSpPr>
@@ -28758,7 +29160,7 @@
       </p:sp>
       <p:sp>
         <p:nvSpPr>
-          <p:cNvPr id="18" name="anim6-73"/>
+          <p:cNvPr id="18" name="anim6-79"/>
           <p:cNvSpPr/>
           <p:nvPr/>
         </p:nvSpPr>
@@ -28783,7 +29185,7 @@
       </p:sp>
       <p:pic>
         <p:nvPicPr>
-          <p:cNvPr id="19" name="anim6-74" descr="preencoded.png">    </p:cNvPr>
+          <p:cNvPr id="19" name="anim6-80" descr="preencoded.png">    </p:cNvPr>
           <p:cNvPicPr>
             <a:picLocks noChangeAspect="1"/>
           </p:cNvPicPr>
@@ -28807,7 +29209,7 @@
       </p:pic>
       <p:sp>
         <p:nvSpPr>
-          <p:cNvPr id="20" name="anim6-75"/>
+          <p:cNvPr id="20" name="anim6-81"/>
           <p:cNvSpPr txBox="1"/>
           <p:nvPr/>
         </p:nvSpPr>
@@ -28860,7 +29262,7 @@
       </p:sp>
       <p:sp>
         <p:nvSpPr>
-          <p:cNvPr id="21" name="anim7-76"/>
+          <p:cNvPr id="21" name="anim7-82"/>
           <p:cNvSpPr/>
           <p:nvPr/>
         </p:nvSpPr>
@@ -28885,7 +29287,7 @@
       </p:sp>
       <p:pic>
         <p:nvPicPr>
-          <p:cNvPr id="22" name="anim7-77" descr="preencoded.png">    </p:cNvPr>
+          <p:cNvPr id="22" name="anim7-83" descr="preencoded.png">    </p:cNvPr>
           <p:cNvPicPr>
             <a:picLocks noChangeAspect="1"/>
           </p:cNvPicPr>
@@ -28909,7 +29311,7 @@
       </p:pic>
       <p:sp>
         <p:nvSpPr>
-          <p:cNvPr id="23" name="anim7-78"/>
+          <p:cNvPr id="23" name="anim7-84"/>
           <p:cNvSpPr txBox="1"/>
           <p:nvPr/>
         </p:nvSpPr>
@@ -30063,7 +30465,7 @@
       </p:sp>
       <p:sp>
         <p:nvSpPr>
-          <p:cNvPr id="9" name="anim1-79"/>
+          <p:cNvPr id="9" name="anim1-85"/>
           <p:cNvSpPr/>
           <p:nvPr/>
         </p:nvSpPr>
@@ -30097,7 +30499,7 @@
       </p:sp>
       <p:sp>
         <p:nvSpPr>
-          <p:cNvPr id="10" name="anim1-80"/>
+          <p:cNvPr id="10" name="anim1-86"/>
           <p:cNvSpPr/>
           <p:nvPr/>
         </p:nvSpPr>
@@ -30124,7 +30526,7 @@
       </p:sp>
       <p:pic>
         <p:nvPicPr>
-          <p:cNvPr id="11" name="anim1-81" descr="preencoded.png">    </p:cNvPr>
+          <p:cNvPr id="11" name="anim1-87" descr="preencoded.png">    </p:cNvPr>
           <p:cNvPicPr>
             <a:picLocks noChangeAspect="1"/>
           </p:cNvPicPr>
@@ -30148,7 +30550,7 @@
       </p:pic>
       <p:sp>
         <p:nvSpPr>
-          <p:cNvPr id="12" name="anim1-82"/>
+          <p:cNvPr id="12" name="anim1-88"/>
           <p:cNvSpPr txBox="1"/>
           <p:nvPr/>
         </p:nvSpPr>
@@ -30201,7 +30603,7 @@
       </p:sp>
       <p:sp>
         <p:nvSpPr>
-          <p:cNvPr id="13" name="anim2-83"/>
+          <p:cNvPr id="13" name="anim2-89"/>
           <p:cNvSpPr/>
           <p:nvPr/>
         </p:nvSpPr>
@@ -30235,7 +30637,7 @@
       </p:sp>
       <p:sp>
         <p:nvSpPr>
-          <p:cNvPr id="14" name="anim2-84"/>
+          <p:cNvPr id="14" name="anim2-90"/>
           <p:cNvSpPr/>
           <p:nvPr/>
         </p:nvSpPr>
@@ -30262,7 +30664,7 @@
       </p:sp>
       <p:pic>
         <p:nvPicPr>
-          <p:cNvPr id="15" name="anim2-85" descr="preencoded.png">    </p:cNvPr>
+          <p:cNvPr id="15" name="anim2-91" descr="preencoded.png">    </p:cNvPr>
           <p:cNvPicPr>
             <a:picLocks noChangeAspect="1"/>
           </p:cNvPicPr>
@@ -30286,7 +30688,7 @@
       </p:pic>
       <p:sp>
         <p:nvSpPr>
-          <p:cNvPr id="16" name="anim2-86"/>
+          <p:cNvPr id="16" name="anim2-92"/>
           <p:cNvSpPr txBox="1"/>
           <p:nvPr/>
         </p:nvSpPr>
@@ -30339,7 +30741,7 @@
       </p:sp>
       <p:sp>
         <p:nvSpPr>
-          <p:cNvPr id="17" name="anim3-87"/>
+          <p:cNvPr id="17" name="anim3-93"/>
           <p:cNvSpPr/>
           <p:nvPr/>
         </p:nvSpPr>
@@ -30373,7 +30775,7 @@
       </p:sp>
       <p:sp>
         <p:nvSpPr>
-          <p:cNvPr id="18" name="anim3-88"/>
+          <p:cNvPr id="18" name="anim3-94"/>
           <p:cNvSpPr/>
           <p:nvPr/>
         </p:nvSpPr>
@@ -30400,7 +30802,7 @@
       </p:sp>
       <p:pic>
         <p:nvPicPr>
-          <p:cNvPr id="19" name="anim3-89" descr="preencoded.png">    </p:cNvPr>
+          <p:cNvPr id="19" name="anim3-95" descr="preencoded.png">    </p:cNvPr>
           <p:cNvPicPr>
             <a:picLocks noChangeAspect="1"/>
           </p:cNvPicPr>
@@ -30424,7 +30826,7 @@
       </p:pic>
       <p:sp>
         <p:nvSpPr>
-          <p:cNvPr id="20" name="anim3-90"/>
+          <p:cNvPr id="20" name="anim3-96"/>
           <p:cNvSpPr txBox="1"/>
           <p:nvPr/>
         </p:nvSpPr>
@@ -30477,7 +30879,7 @@
       </p:sp>
       <p:sp>
         <p:nvSpPr>
-          <p:cNvPr id="21" name="anim4-91"/>
+          <p:cNvPr id="21" name="anim4-97"/>
           <p:cNvSpPr/>
           <p:nvPr/>
         </p:nvSpPr>
@@ -30511,7 +30913,7 @@
       </p:sp>
       <p:sp>
         <p:nvSpPr>
-          <p:cNvPr id="22" name="anim4-92"/>
+          <p:cNvPr id="22" name="anim4-98"/>
           <p:cNvSpPr/>
           <p:nvPr/>
         </p:nvSpPr>
@@ -30538,7 +30940,7 @@
       </p:sp>
       <p:pic>
         <p:nvPicPr>
-          <p:cNvPr id="23" name="anim4-93" descr="preencoded.png">    </p:cNvPr>
+          <p:cNvPr id="23" name="anim4-99" descr="preencoded.png">    </p:cNvPr>
           <p:cNvPicPr>
             <a:picLocks noChangeAspect="1"/>
           </p:cNvPicPr>
@@ -30562,7 +30964,7 @@
       </p:pic>
       <p:sp>
         <p:nvSpPr>
-          <p:cNvPr id="24" name="anim4-94"/>
+          <p:cNvPr id="24" name="anim4-100"/>
           <p:cNvSpPr txBox="1"/>
           <p:nvPr/>
         </p:nvSpPr>
@@ -30615,7 +31017,7 @@
       </p:sp>
       <p:sp>
         <p:nvSpPr>
-          <p:cNvPr id="25" name="anim5-95"/>
+          <p:cNvPr id="25" name="anim5-101"/>
           <p:cNvSpPr/>
           <p:nvPr/>
         </p:nvSpPr>
@@ -30649,7 +31051,7 @@
       </p:sp>
       <p:sp>
         <p:nvSpPr>
-          <p:cNvPr id="26" name="anim5-96"/>
+          <p:cNvPr id="26" name="anim5-102"/>
           <p:cNvSpPr txBox="1"/>
           <p:nvPr/>
         </p:nvSpPr>
@@ -30685,7 +31087,7 @@
       </p:sp>
       <p:pic>
         <p:nvPicPr>
-          <p:cNvPr id="27" name="anim6-97" descr="preencoded.png">    </p:cNvPr>
+          <p:cNvPr id="27" name="anim6-103" descr="preencoded.png">    </p:cNvPr>
           <p:cNvPicPr>
             <a:picLocks noChangeAspect="1"/>
           </p:cNvPicPr>
@@ -30709,7 +31111,7 @@
       </p:pic>
       <p:sp>
         <p:nvSpPr>
-          <p:cNvPr id="28" name="anim6-98"/>
+          <p:cNvPr id="28" name="anim6-104"/>
           <p:cNvSpPr txBox="1"/>
           <p:nvPr/>
         </p:nvSpPr>
@@ -30745,7 +31147,7 @@
       </p:sp>
       <p:pic>
         <p:nvPicPr>
-          <p:cNvPr id="29" name="anim7-99" descr="preencoded.png">    </p:cNvPr>
+          <p:cNvPr id="29" name="anim7-105" descr="preencoded.png">    </p:cNvPr>
           <p:cNvPicPr>
             <a:picLocks noChangeAspect="1"/>
           </p:cNvPicPr>
@@ -30769,7 +31171,7 @@
       </p:pic>
       <p:sp>
         <p:nvSpPr>
-          <p:cNvPr id="30" name="anim7-100"/>
+          <p:cNvPr id="30" name="anim7-106"/>
           <p:cNvSpPr txBox="1"/>
           <p:nvPr/>
         </p:nvSpPr>
@@ -30805,7 +31207,7 @@
       </p:sp>
       <p:pic>
         <p:nvPicPr>
-          <p:cNvPr id="31" name="anim8-101" descr="preencoded.png">    </p:cNvPr>
+          <p:cNvPr id="31" name="anim8-107" descr="preencoded.png">    </p:cNvPr>
           <p:cNvPicPr>
             <a:picLocks noChangeAspect="1"/>
           </p:cNvPicPr>
@@ -30829,7 +31231,7 @@
       </p:pic>
       <p:sp>
         <p:nvSpPr>
-          <p:cNvPr id="32" name="anim8-102"/>
+          <p:cNvPr id="32" name="anim8-108"/>
           <p:cNvSpPr txBox="1"/>
           <p:nvPr/>
         </p:nvSpPr>
@@ -32072,7 +32474,7 @@
       </p:sp>
       <p:sp>
         <p:nvSpPr>
-          <p:cNvPr id="9" name="anim1-103"/>
+          <p:cNvPr id="9" name="anim1-109"/>
           <p:cNvSpPr/>
           <p:nvPr/>
         </p:nvSpPr>
@@ -32106,7 +32508,7 @@
       </p:sp>
       <p:sp>
         <p:nvSpPr>
-          <p:cNvPr id="10" name="anim1-104"/>
+          <p:cNvPr id="10" name="anim1-110"/>
           <p:cNvSpPr/>
           <p:nvPr/>
         </p:nvSpPr>
@@ -32133,7 +32535,7 @@
       </p:sp>
       <p:pic>
         <p:nvPicPr>
-          <p:cNvPr id="11" name="anim1-105" descr="preencoded.png">    </p:cNvPr>
+          <p:cNvPr id="11" name="anim1-111" descr="preencoded.png">    </p:cNvPr>
           <p:cNvPicPr>
             <a:picLocks noChangeAspect="1"/>
           </p:cNvPicPr>
@@ -32157,7 +32559,7 @@
       </p:pic>
       <p:sp>
         <p:nvSpPr>
-          <p:cNvPr id="12" name="anim1-106"/>
+          <p:cNvPr id="12" name="anim1-112"/>
           <p:cNvSpPr txBox="1"/>
           <p:nvPr/>
         </p:nvSpPr>
@@ -32210,7 +32612,7 @@
       </p:sp>
       <p:sp>
         <p:nvSpPr>
-          <p:cNvPr id="13" name="anim2-107"/>
+          <p:cNvPr id="13" name="anim2-113"/>
           <p:cNvSpPr/>
           <p:nvPr/>
         </p:nvSpPr>
@@ -32244,7 +32646,7 @@
       </p:sp>
       <p:sp>
         <p:nvSpPr>
-          <p:cNvPr id="14" name="anim2-108"/>
+          <p:cNvPr id="14" name="anim2-114"/>
           <p:cNvSpPr/>
           <p:nvPr/>
         </p:nvSpPr>
@@ -32271,7 +32673,7 @@
       </p:sp>
       <p:pic>
         <p:nvPicPr>
-          <p:cNvPr id="15" name="anim2-109" descr="preencoded.png">    </p:cNvPr>
+          <p:cNvPr id="15" name="anim2-115" descr="preencoded.png">    </p:cNvPr>
           <p:cNvPicPr>
             <a:picLocks noChangeAspect="1"/>
           </p:cNvPicPr>
@@ -32295,7 +32697,7 @@
       </p:pic>
       <p:sp>
         <p:nvSpPr>
-          <p:cNvPr id="16" name="anim2-110"/>
+          <p:cNvPr id="16" name="anim2-116"/>
           <p:cNvSpPr txBox="1"/>
           <p:nvPr/>
         </p:nvSpPr>
@@ -32348,7 +32750,7 @@
       </p:sp>
       <p:sp>
         <p:nvSpPr>
-          <p:cNvPr id="17" name="anim3-111"/>
+          <p:cNvPr id="17" name="anim3-117"/>
           <p:cNvSpPr/>
           <p:nvPr/>
         </p:nvSpPr>
@@ -32382,7 +32784,7 @@
       </p:sp>
       <p:sp>
         <p:nvSpPr>
-          <p:cNvPr id="18" name="anim3-112"/>
+          <p:cNvPr id="18" name="anim3-118"/>
           <p:cNvSpPr/>
           <p:nvPr/>
         </p:nvSpPr>
@@ -32409,7 +32811,7 @@
       </p:sp>
       <p:pic>
         <p:nvPicPr>
-          <p:cNvPr id="19" name="anim3-113" descr="preencoded.png">    </p:cNvPr>
+          <p:cNvPr id="19" name="anim3-119" descr="preencoded.png">    </p:cNvPr>
           <p:cNvPicPr>
             <a:picLocks noChangeAspect="1"/>
           </p:cNvPicPr>
@@ -32433,7 +32835,7 @@
       </p:pic>
       <p:sp>
         <p:nvSpPr>
-          <p:cNvPr id="20" name="anim3-114"/>
+          <p:cNvPr id="20" name="anim3-120"/>
           <p:cNvSpPr txBox="1"/>
           <p:nvPr/>
         </p:nvSpPr>
@@ -32486,7 +32888,7 @@
       </p:sp>
       <p:sp>
         <p:nvSpPr>
-          <p:cNvPr id="21" name="anim4-115"/>
+          <p:cNvPr id="21" name="anim4-121"/>
           <p:cNvSpPr/>
           <p:nvPr/>
         </p:nvSpPr>
@@ -32520,7 +32922,7 @@
       </p:sp>
       <p:sp>
         <p:nvSpPr>
-          <p:cNvPr id="22" name="anim4-116"/>
+          <p:cNvPr id="22" name="anim4-122"/>
           <p:cNvSpPr/>
           <p:nvPr/>
         </p:nvSpPr>
@@ -32547,7 +32949,7 @@
       </p:sp>
       <p:pic>
         <p:nvPicPr>
-          <p:cNvPr id="23" name="anim4-117" descr="preencoded.png">    </p:cNvPr>
+          <p:cNvPr id="23" name="anim4-123" descr="preencoded.png">    </p:cNvPr>
           <p:cNvPicPr>
             <a:picLocks noChangeAspect="1"/>
           </p:cNvPicPr>
@@ -32571,7 +32973,7 @@
       </p:pic>
       <p:sp>
         <p:nvSpPr>
-          <p:cNvPr id="24" name="anim4-118"/>
+          <p:cNvPr id="24" name="anim4-124"/>
           <p:cNvSpPr txBox="1"/>
           <p:nvPr/>
         </p:nvSpPr>
@@ -32624,7 +33026,7 @@
       </p:sp>
       <p:sp>
         <p:nvSpPr>
-          <p:cNvPr id="25" name="anim5-119"/>
+          <p:cNvPr id="25" name="anim5-125"/>
           <p:cNvSpPr/>
           <p:nvPr/>
         </p:nvSpPr>
@@ -32658,7 +33060,7 @@
       </p:sp>
       <p:sp>
         <p:nvSpPr>
-          <p:cNvPr id="26" name="anim5-120"/>
+          <p:cNvPr id="26" name="anim5-126"/>
           <p:cNvSpPr txBox="1"/>
           <p:nvPr/>
         </p:nvSpPr>
@@ -32694,7 +33096,7 @@
       </p:sp>
       <p:pic>
         <p:nvPicPr>
-          <p:cNvPr id="27" name="anim6-121" descr="preencoded.png">    </p:cNvPr>
+          <p:cNvPr id="27" name="anim6-127" descr="preencoded.png">    </p:cNvPr>
           <p:cNvPicPr>
             <a:picLocks noChangeAspect="1"/>
           </p:cNvPicPr>
@@ -32718,7 +33120,7 @@
       </p:pic>
       <p:sp>
         <p:nvSpPr>
-          <p:cNvPr id="28" name="anim6-122"/>
+          <p:cNvPr id="28" name="anim6-128"/>
           <p:cNvSpPr txBox="1"/>
           <p:nvPr/>
         </p:nvSpPr>
@@ -32754,7 +33156,7 @@
       </p:sp>
       <p:pic>
         <p:nvPicPr>
-          <p:cNvPr id="29" name="anim7-123" descr="preencoded.png">    </p:cNvPr>
+          <p:cNvPr id="29" name="anim7-129" descr="preencoded.png">    </p:cNvPr>
           <p:cNvPicPr>
             <a:picLocks noChangeAspect="1"/>
           </p:cNvPicPr>
@@ -32778,7 +33180,7 @@
       </p:pic>
       <p:sp>
         <p:nvSpPr>
-          <p:cNvPr id="30" name="anim7-124"/>
+          <p:cNvPr id="30" name="anim7-130"/>
           <p:cNvSpPr txBox="1"/>
           <p:nvPr/>
         </p:nvSpPr>
@@ -32814,7 +33216,7 @@
       </p:sp>
       <p:pic>
         <p:nvPicPr>
-          <p:cNvPr id="31" name="anim8-125" descr="preencoded.png">    </p:cNvPr>
+          <p:cNvPr id="31" name="anim8-131" descr="preencoded.png">    </p:cNvPr>
           <p:cNvPicPr>
             <a:picLocks noChangeAspect="1"/>
           </p:cNvPicPr>
@@ -32838,7 +33240,7 @@
       </p:pic>
       <p:sp>
         <p:nvSpPr>
-          <p:cNvPr id="32" name="anim8-126"/>
+          <p:cNvPr id="32" name="anim8-132"/>
           <p:cNvSpPr txBox="1"/>
           <p:nvPr/>
         </p:nvSpPr>
@@ -34081,7 +34483,7 @@
       </p:sp>
       <p:sp>
         <p:nvSpPr>
-          <p:cNvPr id="9" name="anim1-127"/>
+          <p:cNvPr id="9" name="anim1-133"/>
           <p:cNvSpPr/>
           <p:nvPr/>
         </p:nvSpPr>
@@ -34115,7 +34517,7 @@
       </p:sp>
       <p:sp>
         <p:nvSpPr>
-          <p:cNvPr id="10" name="anim1-128"/>
+          <p:cNvPr id="10" name="anim1-134"/>
           <p:cNvSpPr/>
           <p:nvPr/>
         </p:nvSpPr>
@@ -34142,7 +34544,7 @@
       </p:sp>
       <p:pic>
         <p:nvPicPr>
-          <p:cNvPr id="11" name="anim1-129" descr="preencoded.png">    </p:cNvPr>
+          <p:cNvPr id="11" name="anim1-135" descr="preencoded.png">    </p:cNvPr>
           <p:cNvPicPr>
             <a:picLocks noChangeAspect="1"/>
           </p:cNvPicPr>
@@ -34166,7 +34568,7 @@
       </p:pic>
       <p:sp>
         <p:nvSpPr>
-          <p:cNvPr id="12" name="anim1-130"/>
+          <p:cNvPr id="12" name="anim1-136"/>
           <p:cNvSpPr txBox="1"/>
           <p:nvPr/>
         </p:nvSpPr>
@@ -34219,7 +34621,7 @@
       </p:sp>
       <p:sp>
         <p:nvSpPr>
-          <p:cNvPr id="13" name="anim2-131"/>
+          <p:cNvPr id="13" name="anim2-137"/>
           <p:cNvSpPr/>
           <p:nvPr/>
         </p:nvSpPr>
@@ -34253,7 +34655,7 @@
       </p:sp>
       <p:sp>
         <p:nvSpPr>
-          <p:cNvPr id="14" name="anim2-132"/>
+          <p:cNvPr id="14" name="anim2-138"/>
           <p:cNvSpPr/>
           <p:nvPr/>
         </p:nvSpPr>
@@ -34280,7 +34682,7 @@
       </p:sp>
       <p:pic>
         <p:nvPicPr>
-          <p:cNvPr id="15" name="anim2-133" descr="preencoded.png">    </p:cNvPr>
+          <p:cNvPr id="15" name="anim2-139" descr="preencoded.png">    </p:cNvPr>
           <p:cNvPicPr>
             <a:picLocks noChangeAspect="1"/>
           </p:cNvPicPr>
@@ -34304,7 +34706,7 @@
       </p:pic>
       <p:sp>
         <p:nvSpPr>
-          <p:cNvPr id="16" name="anim2-134"/>
+          <p:cNvPr id="16" name="anim2-140"/>
           <p:cNvSpPr txBox="1"/>
           <p:nvPr/>
         </p:nvSpPr>
@@ -34357,7 +34759,7 @@
       </p:sp>
       <p:sp>
         <p:nvSpPr>
-          <p:cNvPr id="17" name="anim3-135"/>
+          <p:cNvPr id="17" name="anim3-141"/>
           <p:cNvSpPr/>
           <p:nvPr/>
         </p:nvSpPr>
@@ -34391,7 +34793,7 @@
       </p:sp>
       <p:sp>
         <p:nvSpPr>
-          <p:cNvPr id="18" name="anim3-136"/>
+          <p:cNvPr id="18" name="anim3-142"/>
           <p:cNvSpPr/>
           <p:nvPr/>
         </p:nvSpPr>
@@ -34418,7 +34820,7 @@
       </p:sp>
       <p:pic>
         <p:nvPicPr>
-          <p:cNvPr id="19" name="anim3-137" descr="preencoded.png">    </p:cNvPr>
+          <p:cNvPr id="19" name="anim3-143" descr="preencoded.png">    </p:cNvPr>
           <p:cNvPicPr>
             <a:picLocks noChangeAspect="1"/>
           </p:cNvPicPr>
@@ -34442,7 +34844,7 @@
       </p:pic>
       <p:sp>
         <p:nvSpPr>
-          <p:cNvPr id="20" name="anim3-138"/>
+          <p:cNvPr id="20" name="anim3-144"/>
           <p:cNvSpPr txBox="1"/>
           <p:nvPr/>
         </p:nvSpPr>
@@ -34495,7 +34897,7 @@
       </p:sp>
       <p:sp>
         <p:nvSpPr>
-          <p:cNvPr id="21" name="anim4-139"/>
+          <p:cNvPr id="21" name="anim4-145"/>
           <p:cNvSpPr/>
           <p:nvPr/>
         </p:nvSpPr>
@@ -34529,7 +34931,7 @@
       </p:sp>
       <p:sp>
         <p:nvSpPr>
-          <p:cNvPr id="22" name="anim4-140"/>
+          <p:cNvPr id="22" name="anim4-146"/>
           <p:cNvSpPr/>
           <p:nvPr/>
         </p:nvSpPr>
@@ -34556,7 +34958,7 @@
       </p:sp>
       <p:pic>
         <p:nvPicPr>
-          <p:cNvPr id="23" name="anim4-141" descr="preencoded.png">    </p:cNvPr>
+          <p:cNvPr id="23" name="anim4-147" descr="preencoded.png">    </p:cNvPr>
           <p:cNvPicPr>
             <a:picLocks noChangeAspect="1"/>
           </p:cNvPicPr>
@@ -34580,7 +34982,7 @@
       </p:pic>
       <p:sp>
         <p:nvSpPr>
-          <p:cNvPr id="24" name="anim4-142"/>
+          <p:cNvPr id="24" name="anim4-148"/>
           <p:cNvSpPr txBox="1"/>
           <p:nvPr/>
         </p:nvSpPr>
@@ -34633,7 +35035,7 @@
       </p:sp>
       <p:sp>
         <p:nvSpPr>
-          <p:cNvPr id="25" name="anim5-143"/>
+          <p:cNvPr id="25" name="anim5-149"/>
           <p:cNvSpPr/>
           <p:nvPr/>
         </p:nvSpPr>
@@ -34667,7 +35069,7 @@
       </p:sp>
       <p:sp>
         <p:nvSpPr>
-          <p:cNvPr id="26" name="anim5-144"/>
+          <p:cNvPr id="26" name="anim5-150"/>
           <p:cNvSpPr txBox="1"/>
           <p:nvPr/>
         </p:nvSpPr>
@@ -34703,7 +35105,7 @@
       </p:sp>
       <p:pic>
         <p:nvPicPr>
-          <p:cNvPr id="27" name="anim6-145" descr="preencoded.png">    </p:cNvPr>
+          <p:cNvPr id="27" name="anim6-151" descr="preencoded.png">    </p:cNvPr>
           <p:cNvPicPr>
             <a:picLocks noChangeAspect="1"/>
           </p:cNvPicPr>
@@ -34727,7 +35129,7 @@
       </p:pic>
       <p:sp>
         <p:nvSpPr>
-          <p:cNvPr id="28" name="anim6-146"/>
+          <p:cNvPr id="28" name="anim6-152"/>
           <p:cNvSpPr txBox="1"/>
           <p:nvPr/>
         </p:nvSpPr>
@@ -34763,7 +35165,7 @@
       </p:sp>
       <p:pic>
         <p:nvPicPr>
-          <p:cNvPr id="29" name="anim7-147" descr="preencoded.png">    </p:cNvPr>
+          <p:cNvPr id="29" name="anim7-153" descr="preencoded.png">    </p:cNvPr>
           <p:cNvPicPr>
             <a:picLocks noChangeAspect="1"/>
           </p:cNvPicPr>
@@ -34787,7 +35189,7 @@
       </p:pic>
       <p:sp>
         <p:nvSpPr>
-          <p:cNvPr id="30" name="anim7-148"/>
+          <p:cNvPr id="30" name="anim7-154"/>
           <p:cNvSpPr txBox="1"/>
           <p:nvPr/>
         </p:nvSpPr>
@@ -34823,7 +35225,7 @@
       </p:sp>
       <p:pic>
         <p:nvPicPr>
-          <p:cNvPr id="31" name="anim8-149" descr="preencoded.png">    </p:cNvPr>
+          <p:cNvPr id="31" name="anim8-155" descr="preencoded.png">    </p:cNvPr>
           <p:cNvPicPr>
             <a:picLocks noChangeAspect="1"/>
           </p:cNvPicPr>
@@ -34847,7 +35249,7 @@
       </p:pic>
       <p:sp>
         <p:nvSpPr>
-          <p:cNvPr id="32" name="anim8-150"/>
+          <p:cNvPr id="32" name="anim8-156"/>
           <p:cNvSpPr txBox="1"/>
           <p:nvPr/>
         </p:nvSpPr>
@@ -36090,7 +36492,7 @@
       </p:sp>
       <p:sp>
         <p:nvSpPr>
-          <p:cNvPr id="9" name="anim1-151"/>
+          <p:cNvPr id="9" name="anim1-157"/>
           <p:cNvSpPr/>
           <p:nvPr/>
         </p:nvSpPr>
@@ -36124,7 +36526,7 @@
       </p:sp>
       <p:sp>
         <p:nvSpPr>
-          <p:cNvPr id="10" name="anim1-152"/>
+          <p:cNvPr id="10" name="anim1-158"/>
           <p:cNvSpPr/>
           <p:nvPr/>
         </p:nvSpPr>
@@ -36151,7 +36553,7 @@
       </p:sp>
       <p:pic>
         <p:nvPicPr>
-          <p:cNvPr id="11" name="anim1-153" descr="preencoded.png">    </p:cNvPr>
+          <p:cNvPr id="11" name="anim1-159" descr="preencoded.png">    </p:cNvPr>
           <p:cNvPicPr>
             <a:picLocks noChangeAspect="1"/>
           </p:cNvPicPr>
@@ -36175,7 +36577,7 @@
       </p:pic>
       <p:sp>
         <p:nvSpPr>
-          <p:cNvPr id="12" name="anim1-154"/>
+          <p:cNvPr id="12" name="anim1-160"/>
           <p:cNvSpPr txBox="1"/>
           <p:nvPr/>
         </p:nvSpPr>
@@ -36228,7 +36630,7 @@
       </p:sp>
       <p:sp>
         <p:nvSpPr>
-          <p:cNvPr id="13" name="anim2-155"/>
+          <p:cNvPr id="13" name="anim2-161"/>
           <p:cNvSpPr/>
           <p:nvPr/>
         </p:nvSpPr>
@@ -36262,7 +36664,7 @@
       </p:sp>
       <p:sp>
         <p:nvSpPr>
-          <p:cNvPr id="14" name="anim2-156"/>
+          <p:cNvPr id="14" name="anim2-162"/>
           <p:cNvSpPr/>
           <p:nvPr/>
         </p:nvSpPr>
@@ -36289,7 +36691,7 @@
       </p:sp>
       <p:pic>
         <p:nvPicPr>
-          <p:cNvPr id="15" name="anim2-157" descr="preencoded.png">    </p:cNvPr>
+          <p:cNvPr id="15" name="anim2-163" descr="preencoded.png">    </p:cNvPr>
           <p:cNvPicPr>
             <a:picLocks noChangeAspect="1"/>
           </p:cNvPicPr>
@@ -36313,7 +36715,7 @@
       </p:pic>
       <p:sp>
         <p:nvSpPr>
-          <p:cNvPr id="16" name="anim2-158"/>
+          <p:cNvPr id="16" name="anim2-164"/>
           <p:cNvSpPr txBox="1"/>
           <p:nvPr/>
         </p:nvSpPr>
@@ -36366,7 +36768,7 @@
       </p:sp>
       <p:sp>
         <p:nvSpPr>
-          <p:cNvPr id="17" name="anim3-159"/>
+          <p:cNvPr id="17" name="anim3-165"/>
           <p:cNvSpPr/>
           <p:nvPr/>
         </p:nvSpPr>
@@ -36400,7 +36802,7 @@
       </p:sp>
       <p:sp>
         <p:nvSpPr>
-          <p:cNvPr id="18" name="anim3-160"/>
+          <p:cNvPr id="18" name="anim3-166"/>
           <p:cNvSpPr/>
           <p:nvPr/>
         </p:nvSpPr>
@@ -36427,7 +36829,7 @@
       </p:sp>
       <p:pic>
         <p:nvPicPr>
-          <p:cNvPr id="19" name="anim3-161" descr="preencoded.png">    </p:cNvPr>
+          <p:cNvPr id="19" name="anim3-167" descr="preencoded.png">    </p:cNvPr>
           <p:cNvPicPr>
             <a:picLocks noChangeAspect="1"/>
           </p:cNvPicPr>
@@ -36451,7 +36853,7 @@
       </p:pic>
       <p:sp>
         <p:nvSpPr>
-          <p:cNvPr id="20" name="anim3-162"/>
+          <p:cNvPr id="20" name="anim3-168"/>
           <p:cNvSpPr txBox="1"/>
           <p:nvPr/>
         </p:nvSpPr>
@@ -36504,7 +36906,7 @@
       </p:sp>
       <p:sp>
         <p:nvSpPr>
-          <p:cNvPr id="21" name="anim4-163"/>
+          <p:cNvPr id="21" name="anim4-169"/>
           <p:cNvSpPr/>
           <p:nvPr/>
         </p:nvSpPr>
@@ -36538,7 +36940,7 @@
       </p:sp>
       <p:sp>
         <p:nvSpPr>
-          <p:cNvPr id="22" name="anim4-164"/>
+          <p:cNvPr id="22" name="anim4-170"/>
           <p:cNvSpPr/>
           <p:nvPr/>
         </p:nvSpPr>
@@ -36565,7 +36967,7 @@
       </p:sp>
       <p:pic>
         <p:nvPicPr>
-          <p:cNvPr id="23" name="anim4-165" descr="preencoded.png">    </p:cNvPr>
+          <p:cNvPr id="23" name="anim4-171" descr="preencoded.png">    </p:cNvPr>
           <p:cNvPicPr>
             <a:picLocks noChangeAspect="1"/>
           </p:cNvPicPr>
@@ -36589,7 +36991,7 @@
       </p:pic>
       <p:sp>
         <p:nvSpPr>
-          <p:cNvPr id="24" name="anim4-166"/>
+          <p:cNvPr id="24" name="anim4-172"/>
           <p:cNvSpPr txBox="1"/>
           <p:nvPr/>
         </p:nvSpPr>
@@ -36642,7 +37044,7 @@
       </p:sp>
       <p:sp>
         <p:nvSpPr>
-          <p:cNvPr id="25" name="anim5-167"/>
+          <p:cNvPr id="25" name="anim5-173"/>
           <p:cNvSpPr/>
           <p:nvPr/>
         </p:nvSpPr>
@@ -36676,7 +37078,7 @@
       </p:sp>
       <p:sp>
         <p:nvSpPr>
-          <p:cNvPr id="26" name="anim5-168"/>
+          <p:cNvPr id="26" name="anim5-174"/>
           <p:cNvSpPr txBox="1"/>
           <p:nvPr/>
         </p:nvSpPr>
@@ -36712,7 +37114,7 @@
       </p:sp>
       <p:pic>
         <p:nvPicPr>
-          <p:cNvPr id="27" name="anim6-169" descr="preencoded.png">    </p:cNvPr>
+          <p:cNvPr id="27" name="anim6-175" descr="preencoded.png">    </p:cNvPr>
           <p:cNvPicPr>
             <a:picLocks noChangeAspect="1"/>
           </p:cNvPicPr>
@@ -36736,7 +37138,7 @@
       </p:pic>
       <p:sp>
         <p:nvSpPr>
-          <p:cNvPr id="28" name="anim6-170"/>
+          <p:cNvPr id="28" name="anim6-176"/>
           <p:cNvSpPr txBox="1"/>
           <p:nvPr/>
         </p:nvSpPr>
@@ -36772,7 +37174,7 @@
       </p:sp>
       <p:pic>
         <p:nvPicPr>
-          <p:cNvPr id="29" name="anim7-171" descr="preencoded.png">    </p:cNvPr>
+          <p:cNvPr id="29" name="anim7-177" descr="preencoded.png">    </p:cNvPr>
           <p:cNvPicPr>
             <a:picLocks noChangeAspect="1"/>
           </p:cNvPicPr>
@@ -36796,7 +37198,7 @@
       </p:pic>
       <p:sp>
         <p:nvSpPr>
-          <p:cNvPr id="30" name="anim7-172"/>
+          <p:cNvPr id="30" name="anim7-178"/>
           <p:cNvSpPr txBox="1"/>
           <p:nvPr/>
         </p:nvSpPr>
@@ -36832,7 +37234,7 @@
       </p:sp>
       <p:pic>
         <p:nvPicPr>
-          <p:cNvPr id="31" name="anim8-173" descr="preencoded.png">    </p:cNvPr>
+          <p:cNvPr id="31" name="anim8-179" descr="preencoded.png">    </p:cNvPr>
           <p:cNvPicPr>
             <a:picLocks noChangeAspect="1"/>
           </p:cNvPicPr>
@@ -36856,7 +37258,7 @@
       </p:pic>
       <p:sp>
         <p:nvSpPr>
-          <p:cNvPr id="32" name="anim8-174"/>
+          <p:cNvPr id="32" name="anim8-180"/>
           <p:cNvSpPr txBox="1"/>
           <p:nvPr/>
         </p:nvSpPr>
@@ -38099,7 +38501,7 @@
       </p:sp>
       <p:sp>
         <p:nvSpPr>
-          <p:cNvPr id="9" name="anim1-175"/>
+          <p:cNvPr id="9" name="anim1-181"/>
           <p:cNvSpPr/>
           <p:nvPr/>
         </p:nvSpPr>
@@ -38133,7 +38535,7 @@
       </p:sp>
       <p:sp>
         <p:nvSpPr>
-          <p:cNvPr id="10" name="anim1-176"/>
+          <p:cNvPr id="10" name="anim1-182"/>
           <p:cNvSpPr/>
           <p:nvPr/>
         </p:nvSpPr>
@@ -38160,7 +38562,7 @@
       </p:sp>
       <p:pic>
         <p:nvPicPr>
-          <p:cNvPr id="11" name="anim1-177" descr="preencoded.png">    </p:cNvPr>
+          <p:cNvPr id="11" name="anim1-183" descr="preencoded.png">    </p:cNvPr>
           <p:cNvPicPr>
             <a:picLocks noChangeAspect="1"/>
           </p:cNvPicPr>
@@ -38184,7 +38586,7 @@
       </p:pic>
       <p:sp>
         <p:nvSpPr>
-          <p:cNvPr id="12" name="anim1-178"/>
+          <p:cNvPr id="12" name="anim1-184"/>
           <p:cNvSpPr txBox="1"/>
           <p:nvPr/>
         </p:nvSpPr>
@@ -38237,7 +38639,7 @@
       </p:sp>
       <p:sp>
         <p:nvSpPr>
-          <p:cNvPr id="13" name="anim2-179"/>
+          <p:cNvPr id="13" name="anim2-185"/>
           <p:cNvSpPr/>
           <p:nvPr/>
         </p:nvSpPr>
@@ -38271,7 +38673,7 @@
       </p:sp>
       <p:sp>
         <p:nvSpPr>
-          <p:cNvPr id="14" name="anim2-180"/>
+          <p:cNvPr id="14" name="anim2-186"/>
           <p:cNvSpPr/>
           <p:nvPr/>
         </p:nvSpPr>
@@ -38298,7 +38700,7 @@
       </p:sp>
       <p:pic>
         <p:nvPicPr>
-          <p:cNvPr id="15" name="anim2-181" descr="preencoded.png">    </p:cNvPr>
+          <p:cNvPr id="15" name="anim2-187" descr="preencoded.png">    </p:cNvPr>
           <p:cNvPicPr>
             <a:picLocks noChangeAspect="1"/>
           </p:cNvPicPr>
@@ -38322,7 +38724,7 @@
       </p:pic>
       <p:sp>
         <p:nvSpPr>
-          <p:cNvPr id="16" name="anim2-182"/>
+          <p:cNvPr id="16" name="anim2-188"/>
           <p:cNvSpPr txBox="1"/>
           <p:nvPr/>
         </p:nvSpPr>
@@ -38375,7 +38777,7 @@
       </p:sp>
       <p:sp>
         <p:nvSpPr>
-          <p:cNvPr id="17" name="anim3-183"/>
+          <p:cNvPr id="17" name="anim3-189"/>
           <p:cNvSpPr/>
           <p:nvPr/>
         </p:nvSpPr>
@@ -38409,7 +38811,7 @@
       </p:sp>
       <p:sp>
         <p:nvSpPr>
-          <p:cNvPr id="18" name="anim3-184"/>
+          <p:cNvPr id="18" name="anim3-190"/>
           <p:cNvSpPr/>
           <p:nvPr/>
         </p:nvSpPr>
@@ -38436,7 +38838,7 @@
       </p:sp>
       <p:pic>
         <p:nvPicPr>
-          <p:cNvPr id="19" name="anim3-185" descr="preencoded.png">    </p:cNvPr>
+          <p:cNvPr id="19" name="anim3-191" descr="preencoded.png">    </p:cNvPr>
           <p:cNvPicPr>
             <a:picLocks noChangeAspect="1"/>
           </p:cNvPicPr>
@@ -38460,7 +38862,7 @@
       </p:pic>
       <p:sp>
         <p:nvSpPr>
-          <p:cNvPr id="20" name="anim3-186"/>
+          <p:cNvPr id="20" name="anim3-192"/>
           <p:cNvSpPr txBox="1"/>
           <p:nvPr/>
         </p:nvSpPr>
@@ -38513,7 +38915,7 @@
       </p:sp>
       <p:sp>
         <p:nvSpPr>
-          <p:cNvPr id="21" name="anim4-187"/>
+          <p:cNvPr id="21" name="anim4-193"/>
           <p:cNvSpPr/>
           <p:nvPr/>
         </p:nvSpPr>
@@ -38547,7 +38949,7 @@
       </p:sp>
       <p:sp>
         <p:nvSpPr>
-          <p:cNvPr id="22" name="anim4-188"/>
+          <p:cNvPr id="22" name="anim4-194"/>
           <p:cNvSpPr/>
           <p:nvPr/>
         </p:nvSpPr>
@@ -38574,7 +38976,7 @@
       </p:sp>
       <p:pic>
         <p:nvPicPr>
-          <p:cNvPr id="23" name="anim4-189" descr="preencoded.png">    </p:cNvPr>
+          <p:cNvPr id="23" name="anim4-195" descr="preencoded.png">    </p:cNvPr>
           <p:cNvPicPr>
             <a:picLocks noChangeAspect="1"/>
           </p:cNvPicPr>
@@ -38598,7 +39000,7 @@
       </p:pic>
       <p:sp>
         <p:nvSpPr>
-          <p:cNvPr id="24" name="anim4-190"/>
+          <p:cNvPr id="24" name="anim4-196"/>
           <p:cNvSpPr txBox="1"/>
           <p:nvPr/>
         </p:nvSpPr>
@@ -38651,7 +39053,7 @@
       </p:sp>
       <p:sp>
         <p:nvSpPr>
-          <p:cNvPr id="25" name="anim5-191"/>
+          <p:cNvPr id="25" name="anim5-197"/>
           <p:cNvSpPr/>
           <p:nvPr/>
         </p:nvSpPr>
@@ -38685,7 +39087,7 @@
       </p:sp>
       <p:sp>
         <p:nvSpPr>
-          <p:cNvPr id="26" name="anim5-192"/>
+          <p:cNvPr id="26" name="anim5-198"/>
           <p:cNvSpPr txBox="1"/>
           <p:nvPr/>
         </p:nvSpPr>
@@ -38721,7 +39123,7 @@
       </p:sp>
       <p:pic>
         <p:nvPicPr>
-          <p:cNvPr id="27" name="anim6-193" descr="preencoded.png">    </p:cNvPr>
+          <p:cNvPr id="27" name="anim6-199" descr="preencoded.png">    </p:cNvPr>
           <p:cNvPicPr>
             <a:picLocks noChangeAspect="1"/>
           </p:cNvPicPr>
@@ -38745,7 +39147,7 @@
       </p:pic>
       <p:sp>
         <p:nvSpPr>
-          <p:cNvPr id="28" name="anim6-194"/>
+          <p:cNvPr id="28" name="anim6-200"/>
           <p:cNvSpPr txBox="1"/>
           <p:nvPr/>
         </p:nvSpPr>
@@ -38781,7 +39183,7 @@
       </p:sp>
       <p:pic>
         <p:nvPicPr>
-          <p:cNvPr id="29" name="anim7-195" descr="preencoded.png">    </p:cNvPr>
+          <p:cNvPr id="29" name="anim7-201" descr="preencoded.png">    </p:cNvPr>
           <p:cNvPicPr>
             <a:picLocks noChangeAspect="1"/>
           </p:cNvPicPr>
@@ -38805,7 +39207,7 @@
       </p:pic>
       <p:sp>
         <p:nvSpPr>
-          <p:cNvPr id="30" name="anim7-196"/>
+          <p:cNvPr id="30" name="anim7-202"/>
           <p:cNvSpPr txBox="1"/>
           <p:nvPr/>
         </p:nvSpPr>
@@ -38841,7 +39243,7 @@
       </p:sp>
       <p:pic>
         <p:nvPicPr>
-          <p:cNvPr id="31" name="anim8-197" descr="preencoded.png">    </p:cNvPr>
+          <p:cNvPr id="31" name="anim8-203" descr="preencoded.png">    </p:cNvPr>
           <p:cNvPicPr>
             <a:picLocks noChangeAspect="1"/>
           </p:cNvPicPr>
@@ -38865,7 +39267,7 @@
       </p:pic>
       <p:sp>
         <p:nvSpPr>
-          <p:cNvPr id="32" name="anim8-198"/>
+          <p:cNvPr id="32" name="anim8-204"/>
           <p:cNvSpPr txBox="1"/>
           <p:nvPr/>
         </p:nvSpPr>
@@ -38901,7 +39303,7 @@
       </p:sp>
       <p:sp>
         <p:nvSpPr>
-          <p:cNvPr id="34" name="anim9-199"/>
+          <p:cNvPr id="34" name="anim9-205"/>
           <p:cNvSpPr txBox="1"/>
           <p:nvPr/>
         </p:nvSpPr>

</xml_diff>